<commit_message>
[FHIR-57016](https://jira.hl7.org/browse/FHIR-57016): Enhance the figure for gap reporting
</commit_message>
<xml_diff>
--- a/input/images/source/Gaps in Care Graphics.pptx
+++ b/input/images/source/Gaps in Care Graphics.pptx
@@ -5,16 +5,17 @@
     <p:sldMasterId id="2147483648" r:id="rId1"/>
   </p:sldMasterIdLst>
   <p:notesMasterIdLst>
-    <p:notesMasterId r:id="rId9"/>
+    <p:notesMasterId r:id="rId10"/>
   </p:notesMasterIdLst>
   <p:sldIdLst>
     <p:sldId id="257" r:id="rId2"/>
-    <p:sldId id="258" r:id="rId3"/>
-    <p:sldId id="259" r:id="rId4"/>
-    <p:sldId id="264" r:id="rId5"/>
-    <p:sldId id="256" r:id="rId6"/>
-    <p:sldId id="265" r:id="rId7"/>
-    <p:sldId id="268" r:id="rId8"/>
+    <p:sldId id="269" r:id="rId3"/>
+    <p:sldId id="258" r:id="rId4"/>
+    <p:sldId id="259" r:id="rId5"/>
+    <p:sldId id="264" r:id="rId6"/>
+    <p:sldId id="256" r:id="rId7"/>
+    <p:sldId id="265" r:id="rId8"/>
+    <p:sldId id="268" r:id="rId9"/>
   </p:sldIdLst>
   <p:sldSz cx="12192000" cy="6858000"/>
   <p:notesSz cx="6858000" cy="9144000"/>
@@ -119,6 +120,7 @@
         <p14:section name="Default Section" id="{17FAEFA7-1D50-4BD5-A43F-0A42BB396FC2}">
           <p14:sldIdLst>
             <p14:sldId id="257"/>
+            <p14:sldId id="269"/>
             <p14:sldId id="258"/>
             <p14:sldId id="259"/>
             <p14:sldId id="264"/>
@@ -218,7 +220,7 @@
           <a:p>
             <a:fld id="{17E6B6D7-20D6-4E9A-B6E5-85297A5570A7}" type="datetimeFigureOut">
               <a:rPr lang="en-US" smtClean="0"/>
-              <a:t>7/29/24</a:t>
+              <a:t>6/1/2026</a:t>
             </a:fld>
             <a:endParaRPr lang="en-US"/>
           </a:p>
@@ -530,6 +532,94 @@
           <a:lstStyle/>
           <a:p>
             <a:r>
+              <a:rPr lang="en-US" sz="1200"/>
+              <a:t>(FHIR-57016)</a:t>
+            </a:r>
+            <a:endParaRPr lang="en-US"/>
+          </a:p>
+        </p:txBody>
+      </p:sp>
+      <p:sp>
+        <p:nvSpPr>
+          <p:cNvPr id="4" name="Slide Number Placeholder 3"/>
+          <p:cNvSpPr>
+            <a:spLocks noGrp="1"/>
+          </p:cNvSpPr>
+          <p:nvPr>
+            <p:ph type="sldNum" sz="quarter" idx="5"/>
+          </p:nvPr>
+        </p:nvSpPr>
+        <p:spPr/>
+        <p:txBody>
+          <a:bodyPr/>
+          <a:lstStyle/>
+          <a:p>
+            <a:fld id="{F6C01152-882A-4CAB-AF5B-0D5B05615CCB}" type="slidenum">
+              <a:rPr lang="en-US" smtClean="0"/>
+              <a:t>2</a:t>
+            </a:fld>
+            <a:endParaRPr lang="en-US"/>
+          </a:p>
+        </p:txBody>
+      </p:sp>
+    </p:spTree>
+    <p:extLst>
+      <p:ext uri="{BB962C8B-B14F-4D97-AF65-F5344CB8AC3E}">
+        <p14:creationId xmlns:p14="http://schemas.microsoft.com/office/powerpoint/2010/main" val="1567468874"/>
+      </p:ext>
+    </p:extLst>
+  </p:cSld>
+  <p:clrMapOvr>
+    <a:masterClrMapping/>
+  </p:clrMapOvr>
+</p:notes>
+</file>
+
+<file path=ppt/notesSlides/notesSlide2.xml><?xml version="1.0" encoding="utf-8"?>
+<p:notes xmlns:a="http://schemas.openxmlformats.org/drawingml/2006/main" xmlns:r="http://schemas.openxmlformats.org/officeDocument/2006/relationships" xmlns:p="http://schemas.openxmlformats.org/presentationml/2006/main">
+  <p:cSld>
+    <p:spTree>
+      <p:nvGrpSpPr>
+        <p:cNvPr id="1" name=""/>
+        <p:cNvGrpSpPr/>
+        <p:nvPr/>
+      </p:nvGrpSpPr>
+      <p:grpSpPr>
+        <a:xfrm>
+          <a:off x="0" y="0"/>
+          <a:ext cx="0" cy="0"/>
+          <a:chOff x="0" y="0"/>
+          <a:chExt cx="0" cy="0"/>
+        </a:xfrm>
+      </p:grpSpPr>
+      <p:sp>
+        <p:nvSpPr>
+          <p:cNvPr id="2" name="Slide Image Placeholder 1"/>
+          <p:cNvSpPr>
+            <a:spLocks noGrp="1" noRot="1" noChangeAspect="1"/>
+          </p:cNvSpPr>
+          <p:nvPr>
+            <p:ph type="sldImg"/>
+          </p:nvPr>
+        </p:nvSpPr>
+        <p:spPr/>
+      </p:sp>
+      <p:sp>
+        <p:nvSpPr>
+          <p:cNvPr id="3" name="Notes Placeholder 2"/>
+          <p:cNvSpPr>
+            <a:spLocks noGrp="1"/>
+          </p:cNvSpPr>
+          <p:nvPr>
+            <p:ph type="body" idx="1"/>
+          </p:nvPr>
+        </p:nvSpPr>
+        <p:spPr/>
+        <p:txBody>
+          <a:bodyPr/>
+          <a:lstStyle/>
+          <a:p>
+            <a:r>
               <a:rPr lang="en-US" sz="1200" dirty="0"/>
               <a:t>11/23/2022: Added this slide to address https://jira.hl7.org/browse/FHIR-33175 as part of the STU4-ballot (to show Bundle including all referenced patient resources and </a:t>
             </a:r>
@@ -568,7 +658,7 @@
           <a:p>
             <a:fld id="{F6C01152-882A-4CAB-AF5B-0D5B05615CCB}" type="slidenum">
               <a:rPr lang="en-US" smtClean="0"/>
-              <a:t>7</a:t>
+              <a:t>8</a:t>
             </a:fld>
             <a:endParaRPr lang="en-US"/>
           </a:p>
@@ -734,7 +824,7 @@
           <a:p>
             <a:fld id="{CCEBD49B-BC6D-4065-97F6-E22D565E4F2F}" type="datetimeFigureOut">
               <a:rPr lang="en-US" smtClean="0"/>
-              <a:t>7/29/24</a:t>
+              <a:t>6/1/2026</a:t>
             </a:fld>
             <a:endParaRPr lang="en-US"/>
           </a:p>
@@ -932,7 +1022,7 @@
           <a:p>
             <a:fld id="{CCEBD49B-BC6D-4065-97F6-E22D565E4F2F}" type="datetimeFigureOut">
               <a:rPr lang="en-US" smtClean="0"/>
-              <a:t>7/29/24</a:t>
+              <a:t>6/1/2026</a:t>
             </a:fld>
             <a:endParaRPr lang="en-US"/>
           </a:p>
@@ -1140,7 +1230,7 @@
           <a:p>
             <a:fld id="{CCEBD49B-BC6D-4065-97F6-E22D565E4F2F}" type="datetimeFigureOut">
               <a:rPr lang="en-US" smtClean="0"/>
-              <a:t>7/29/24</a:t>
+              <a:t>6/1/2026</a:t>
             </a:fld>
             <a:endParaRPr lang="en-US"/>
           </a:p>
@@ -1338,7 +1428,7 @@
           <a:p>
             <a:fld id="{CCEBD49B-BC6D-4065-97F6-E22D565E4F2F}" type="datetimeFigureOut">
               <a:rPr lang="en-US" smtClean="0"/>
-              <a:t>7/29/24</a:t>
+              <a:t>6/1/2026</a:t>
             </a:fld>
             <a:endParaRPr lang="en-US"/>
           </a:p>
@@ -1613,7 +1703,7 @@
           <a:p>
             <a:fld id="{CCEBD49B-BC6D-4065-97F6-E22D565E4F2F}" type="datetimeFigureOut">
               <a:rPr lang="en-US" smtClean="0"/>
-              <a:t>7/29/24</a:t>
+              <a:t>6/1/2026</a:t>
             </a:fld>
             <a:endParaRPr lang="en-US"/>
           </a:p>
@@ -1878,7 +1968,7 @@
           <a:p>
             <a:fld id="{CCEBD49B-BC6D-4065-97F6-E22D565E4F2F}" type="datetimeFigureOut">
               <a:rPr lang="en-US" smtClean="0"/>
-              <a:t>7/29/24</a:t>
+              <a:t>6/1/2026</a:t>
             </a:fld>
             <a:endParaRPr lang="en-US"/>
           </a:p>
@@ -2290,7 +2380,7 @@
           <a:p>
             <a:fld id="{CCEBD49B-BC6D-4065-97F6-E22D565E4F2F}" type="datetimeFigureOut">
               <a:rPr lang="en-US" smtClean="0"/>
-              <a:t>7/29/24</a:t>
+              <a:t>6/1/2026</a:t>
             </a:fld>
             <a:endParaRPr lang="en-US"/>
           </a:p>
@@ -2431,7 +2521,7 @@
           <a:p>
             <a:fld id="{CCEBD49B-BC6D-4065-97F6-E22D565E4F2F}" type="datetimeFigureOut">
               <a:rPr lang="en-US" smtClean="0"/>
-              <a:t>7/29/24</a:t>
+              <a:t>6/1/2026</a:t>
             </a:fld>
             <a:endParaRPr lang="en-US"/>
           </a:p>
@@ -2544,7 +2634,7 @@
           <a:p>
             <a:fld id="{CCEBD49B-BC6D-4065-97F6-E22D565E4F2F}" type="datetimeFigureOut">
               <a:rPr lang="en-US" smtClean="0"/>
-              <a:t>7/29/24</a:t>
+              <a:t>6/1/2026</a:t>
             </a:fld>
             <a:endParaRPr lang="en-US"/>
           </a:p>
@@ -2855,7 +2945,7 @@
           <a:p>
             <a:fld id="{CCEBD49B-BC6D-4065-97F6-E22D565E4F2F}" type="datetimeFigureOut">
               <a:rPr lang="en-US" smtClean="0"/>
-              <a:t>7/29/24</a:t>
+              <a:t>6/1/2026</a:t>
             </a:fld>
             <a:endParaRPr lang="en-US"/>
           </a:p>
@@ -3143,7 +3233,7 @@
           <a:p>
             <a:fld id="{CCEBD49B-BC6D-4065-97F6-E22D565E4F2F}" type="datetimeFigureOut">
               <a:rPr lang="en-US" smtClean="0"/>
-              <a:t>7/29/24</a:t>
+              <a:t>6/1/2026</a:t>
             </a:fld>
             <a:endParaRPr lang="en-US"/>
           </a:p>
@@ -3384,7 +3474,7 @@
           <a:p>
             <a:fld id="{CCEBD49B-BC6D-4065-97F6-E22D565E4F2F}" type="datetimeFigureOut">
               <a:rPr lang="en-US" smtClean="0"/>
-              <a:t>7/29/24</a:t>
+              <a:t>6/1/2026</a:t>
             </a:fld>
             <a:endParaRPr lang="en-US"/>
           </a:p>
@@ -4213,6 +4303,425 @@
   <p:cSld>
     <p:spTree>
       <p:nvGrpSpPr>
+        <p:cNvPr id="1" name="">
+          <a:extLst>
+            <a:ext uri="{FF2B5EF4-FFF2-40B4-BE49-F238E27FC236}">
+              <a16:creationId xmlns:a16="http://schemas.microsoft.com/office/drawing/2014/main" id="{63B4832E-F189-E2D1-E227-6A3479912B73}"/>
+            </a:ext>
+          </a:extLst>
+        </p:cNvPr>
+        <p:cNvGrpSpPr/>
+        <p:nvPr/>
+      </p:nvGrpSpPr>
+      <p:grpSpPr>
+        <a:xfrm>
+          <a:off x="0" y="0"/>
+          <a:ext cx="0" cy="0"/>
+          <a:chOff x="0" y="0"/>
+          <a:chExt cx="0" cy="0"/>
+        </a:xfrm>
+      </p:grpSpPr>
+      <p:sp>
+        <p:nvSpPr>
+          <p:cNvPr id="18" name="Rectangle: Rounded Corners 17">
+            <a:extLst>
+              <a:ext uri="{FF2B5EF4-FFF2-40B4-BE49-F238E27FC236}">
+                <a16:creationId xmlns:a16="http://schemas.microsoft.com/office/drawing/2014/main" id="{F7B44D90-4F32-303A-5005-A9A22C4C0EBA}"/>
+              </a:ext>
+            </a:extLst>
+          </p:cNvPr>
+          <p:cNvSpPr/>
+          <p:nvPr/>
+        </p:nvSpPr>
+        <p:spPr>
+          <a:xfrm>
+            <a:off x="1242874" y="2192784"/>
+            <a:ext cx="10433311" cy="4032170"/>
+          </a:xfrm>
+          <a:prstGeom prst="roundRect">
+            <a:avLst/>
+          </a:prstGeom>
+          <a:ln>
+            <a:noFill/>
+          </a:ln>
+        </p:spPr>
+        <p:style>
+          <a:lnRef idx="2">
+            <a:schemeClr val="dk1"/>
+          </a:lnRef>
+          <a:fillRef idx="1">
+            <a:schemeClr val="lt1"/>
+          </a:fillRef>
+          <a:effectRef idx="0">
+            <a:schemeClr val="dk1"/>
+          </a:effectRef>
+          <a:fontRef idx="minor">
+            <a:schemeClr val="dk1"/>
+          </a:fontRef>
+        </p:style>
+        <p:txBody>
+          <a:bodyPr rtlCol="0" anchor="ctr"/>
+          <a:lstStyle/>
+          <a:p>
+            <a:pPr algn="ctr"/>
+            <a:endParaRPr lang="en-US"/>
+          </a:p>
+        </p:txBody>
+      </p:sp>
+      <p:sp>
+        <p:nvSpPr>
+          <p:cNvPr id="2" name="Title 1">
+            <a:extLst>
+              <a:ext uri="{FF2B5EF4-FFF2-40B4-BE49-F238E27FC236}">
+                <a16:creationId xmlns:a16="http://schemas.microsoft.com/office/drawing/2014/main" id="{51F045A8-8645-0F40-9D19-1BB2BEFA7098}"/>
+              </a:ext>
+            </a:extLst>
+          </p:cNvPr>
+          <p:cNvSpPr>
+            <a:spLocks noGrp="1"/>
+          </p:cNvSpPr>
+          <p:nvPr>
+            <p:ph type="title"/>
+          </p:nvPr>
+        </p:nvSpPr>
+        <p:spPr/>
+        <p:txBody>
+          <a:bodyPr/>
+          <a:lstStyle/>
+          <a:p>
+            <a:r>
+              <a:rPr lang="en-US" dirty="0"/>
+              <a:t>Gaps in Care Reporting Scenario</a:t>
+            </a:r>
+            <a:endParaRPr lang="en-US" sz="2000" dirty="0"/>
+          </a:p>
+        </p:txBody>
+      </p:sp>
+      <p:sp>
+        <p:nvSpPr>
+          <p:cNvPr id="14" name="Arrow: U-Turn 13">
+            <a:extLst>
+              <a:ext uri="{FF2B5EF4-FFF2-40B4-BE49-F238E27FC236}">
+                <a16:creationId xmlns:a16="http://schemas.microsoft.com/office/drawing/2014/main" id="{91B427F8-64C0-8BC5-7242-B1CA0BEA47BC}"/>
+              </a:ext>
+            </a:extLst>
+          </p:cNvPr>
+          <p:cNvSpPr/>
+          <p:nvPr/>
+        </p:nvSpPr>
+        <p:spPr>
+          <a:xfrm>
+            <a:off x="3531577" y="3262427"/>
+            <a:ext cx="5486400" cy="365760"/>
+          </a:xfrm>
+          <a:prstGeom prst="uturnArrow">
+            <a:avLst>
+              <a:gd name="adj1" fmla="val 25000"/>
+              <a:gd name="adj2" fmla="val 25000"/>
+              <a:gd name="adj3" fmla="val 28205"/>
+              <a:gd name="adj4" fmla="val 43750"/>
+              <a:gd name="adj5" fmla="val 99039"/>
+            </a:avLst>
+          </a:prstGeom>
+        </p:spPr>
+        <p:style>
+          <a:lnRef idx="3">
+            <a:schemeClr val="lt1"/>
+          </a:lnRef>
+          <a:fillRef idx="1">
+            <a:schemeClr val="dk1"/>
+          </a:fillRef>
+          <a:effectRef idx="1">
+            <a:schemeClr val="dk1"/>
+          </a:effectRef>
+          <a:fontRef idx="minor">
+            <a:schemeClr val="lt1"/>
+          </a:fontRef>
+        </p:style>
+        <p:txBody>
+          <a:bodyPr rtlCol="0" anchor="ctr"/>
+          <a:lstStyle/>
+          <a:p>
+            <a:pPr algn="ctr"/>
+            <a:endParaRPr lang="en-US">
+              <a:solidFill>
+                <a:schemeClr val="tx1"/>
+              </a:solidFill>
+            </a:endParaRPr>
+          </a:p>
+        </p:txBody>
+      </p:sp>
+      <p:sp>
+        <p:nvSpPr>
+          <p:cNvPr id="15" name="Arrow: U-Turn 14">
+            <a:extLst>
+              <a:ext uri="{FF2B5EF4-FFF2-40B4-BE49-F238E27FC236}">
+                <a16:creationId xmlns:a16="http://schemas.microsoft.com/office/drawing/2014/main" id="{748D5C62-1065-3A54-03CA-F7577BBB2BFC}"/>
+              </a:ext>
+            </a:extLst>
+          </p:cNvPr>
+          <p:cNvSpPr/>
+          <p:nvPr/>
+        </p:nvSpPr>
+        <p:spPr>
+          <a:xfrm flipH="1" flipV="1">
+            <a:off x="3531577" y="4662101"/>
+            <a:ext cx="5486400" cy="365760"/>
+          </a:xfrm>
+          <a:prstGeom prst="uturnArrow">
+            <a:avLst>
+              <a:gd name="adj1" fmla="val 25000"/>
+              <a:gd name="adj2" fmla="val 25000"/>
+              <a:gd name="adj3" fmla="val 25000"/>
+              <a:gd name="adj4" fmla="val 43750"/>
+              <a:gd name="adj5" fmla="val 100000"/>
+            </a:avLst>
+          </a:prstGeom>
+        </p:spPr>
+        <p:style>
+          <a:lnRef idx="3">
+            <a:schemeClr val="lt1"/>
+          </a:lnRef>
+          <a:fillRef idx="1">
+            <a:schemeClr val="dk1"/>
+          </a:fillRef>
+          <a:effectRef idx="1">
+            <a:schemeClr val="dk1"/>
+          </a:effectRef>
+          <a:fontRef idx="minor">
+            <a:schemeClr val="lt1"/>
+          </a:fontRef>
+        </p:style>
+        <p:txBody>
+          <a:bodyPr rtlCol="0" anchor="ctr"/>
+          <a:lstStyle/>
+          <a:p>
+            <a:pPr algn="ctr"/>
+            <a:endParaRPr lang="en-US">
+              <a:solidFill>
+                <a:schemeClr val="tx1"/>
+              </a:solidFill>
+            </a:endParaRPr>
+          </a:p>
+        </p:txBody>
+      </p:sp>
+      <p:sp>
+        <p:nvSpPr>
+          <p:cNvPr id="5" name="Rectangle: Rounded Corners 4">
+            <a:extLst>
+              <a:ext uri="{FF2B5EF4-FFF2-40B4-BE49-F238E27FC236}">
+                <a16:creationId xmlns:a16="http://schemas.microsoft.com/office/drawing/2014/main" id="{88AF8450-E3E6-93DD-705F-2E943FA06DF3}"/>
+              </a:ext>
+            </a:extLst>
+          </p:cNvPr>
+          <p:cNvSpPr/>
+          <p:nvPr/>
+        </p:nvSpPr>
+        <p:spPr>
+          <a:xfrm>
+            <a:off x="2535115" y="3661388"/>
+            <a:ext cx="1992923" cy="961292"/>
+          </a:xfrm>
+          <a:prstGeom prst="roundRect">
+            <a:avLst/>
+          </a:prstGeom>
+        </p:spPr>
+        <p:style>
+          <a:lnRef idx="2">
+            <a:schemeClr val="dk1"/>
+          </a:lnRef>
+          <a:fillRef idx="1">
+            <a:schemeClr val="lt1"/>
+          </a:fillRef>
+          <a:effectRef idx="0">
+            <a:schemeClr val="dk1"/>
+          </a:effectRef>
+          <a:fontRef idx="minor">
+            <a:schemeClr val="dk1"/>
+          </a:fontRef>
+        </p:style>
+        <p:txBody>
+          <a:bodyPr rtlCol="0" anchor="ctr"/>
+          <a:lstStyle/>
+          <a:p>
+            <a:pPr algn="ctr"/>
+            <a:r>
+              <a:rPr lang="en-US" sz="2400" b="1" dirty="0">
+                <a:latin typeface="Aptos" panose="020B0004020202020204" pitchFamily="34" charset="0"/>
+              </a:rPr>
+              <a:t>Client</a:t>
+            </a:r>
+            <a:endParaRPr lang="en-US" sz="2800" b="1" dirty="0">
+              <a:latin typeface="Aptos" panose="020B0004020202020204" pitchFamily="34" charset="0"/>
+            </a:endParaRPr>
+          </a:p>
+        </p:txBody>
+      </p:sp>
+      <p:sp>
+        <p:nvSpPr>
+          <p:cNvPr id="6" name="Rectangle: Rounded Corners 5">
+            <a:extLst>
+              <a:ext uri="{FF2B5EF4-FFF2-40B4-BE49-F238E27FC236}">
+                <a16:creationId xmlns:a16="http://schemas.microsoft.com/office/drawing/2014/main" id="{6D5BBAB4-D51A-D233-8EB0-164B4B318372}"/>
+              </a:ext>
+            </a:extLst>
+          </p:cNvPr>
+          <p:cNvSpPr/>
+          <p:nvPr/>
+        </p:nvSpPr>
+        <p:spPr>
+          <a:xfrm>
+            <a:off x="8021515" y="3661388"/>
+            <a:ext cx="1992923" cy="961292"/>
+          </a:xfrm>
+          <a:prstGeom prst="roundRect">
+            <a:avLst/>
+          </a:prstGeom>
+        </p:spPr>
+        <p:style>
+          <a:lnRef idx="2">
+            <a:schemeClr val="dk1"/>
+          </a:lnRef>
+          <a:fillRef idx="1">
+            <a:schemeClr val="lt1"/>
+          </a:fillRef>
+          <a:effectRef idx="0">
+            <a:schemeClr val="dk1"/>
+          </a:effectRef>
+          <a:fontRef idx="minor">
+            <a:schemeClr val="dk1"/>
+          </a:fontRef>
+        </p:style>
+        <p:txBody>
+          <a:bodyPr rtlCol="0" anchor="ctr"/>
+          <a:lstStyle/>
+          <a:p>
+            <a:pPr algn="ctr"/>
+            <a:r>
+              <a:rPr lang="en-US" sz="2400" b="1" dirty="0">
+                <a:latin typeface="Aptos" panose="020B0004020202020204" pitchFamily="34" charset="0"/>
+              </a:rPr>
+              <a:t>Server</a:t>
+            </a:r>
+          </a:p>
+        </p:txBody>
+      </p:sp>
+      <p:sp>
+        <p:nvSpPr>
+          <p:cNvPr id="16" name="Rectangle: Rounded Corners 15">
+            <a:extLst>
+              <a:ext uri="{FF2B5EF4-FFF2-40B4-BE49-F238E27FC236}">
+                <a16:creationId xmlns:a16="http://schemas.microsoft.com/office/drawing/2014/main" id="{2B7811D7-15EA-7311-0487-B98B37B3A75C}"/>
+              </a:ext>
+            </a:extLst>
+          </p:cNvPr>
+          <p:cNvSpPr/>
+          <p:nvPr/>
+        </p:nvSpPr>
+        <p:spPr>
+          <a:xfrm>
+            <a:off x="4606802" y="2885936"/>
+            <a:ext cx="3335947" cy="373974"/>
+          </a:xfrm>
+          <a:prstGeom prst="roundRect">
+            <a:avLst/>
+          </a:prstGeom>
+        </p:spPr>
+        <p:style>
+          <a:lnRef idx="2">
+            <a:schemeClr val="dk1"/>
+          </a:lnRef>
+          <a:fillRef idx="1">
+            <a:schemeClr val="lt1"/>
+          </a:fillRef>
+          <a:effectRef idx="0">
+            <a:schemeClr val="dk1"/>
+          </a:effectRef>
+          <a:fontRef idx="minor">
+            <a:schemeClr val="dk1"/>
+          </a:fontRef>
+        </p:style>
+        <p:txBody>
+          <a:bodyPr rtlCol="0" anchor="ctr"/>
+          <a:lstStyle/>
+          <a:p>
+            <a:pPr algn="ctr"/>
+            <a:r>
+              <a:rPr lang="en-US" dirty="0">
+                <a:latin typeface="Aptos" panose="020B0004020202020204" pitchFamily="34" charset="0"/>
+              </a:rPr>
+              <a:t>Request $care-gaps Operation</a:t>
+            </a:r>
+          </a:p>
+        </p:txBody>
+      </p:sp>
+      <p:sp>
+        <p:nvSpPr>
+          <p:cNvPr id="17" name="Rectangle: Rounded Corners 16">
+            <a:extLst>
+              <a:ext uri="{FF2B5EF4-FFF2-40B4-BE49-F238E27FC236}">
+                <a16:creationId xmlns:a16="http://schemas.microsoft.com/office/drawing/2014/main" id="{B1B6E4B7-9506-F6BA-87EC-5CF00119A90F}"/>
+              </a:ext>
+            </a:extLst>
+          </p:cNvPr>
+          <p:cNvSpPr/>
+          <p:nvPr/>
+        </p:nvSpPr>
+        <p:spPr>
+          <a:xfrm>
+            <a:off x="4322884" y="5024552"/>
+            <a:ext cx="3903785" cy="385575"/>
+          </a:xfrm>
+          <a:prstGeom prst="roundRect">
+            <a:avLst/>
+          </a:prstGeom>
+        </p:spPr>
+        <p:style>
+          <a:lnRef idx="2">
+            <a:schemeClr val="dk1"/>
+          </a:lnRef>
+          <a:fillRef idx="1">
+            <a:schemeClr val="lt1"/>
+          </a:fillRef>
+          <a:effectRef idx="0">
+            <a:schemeClr val="dk1"/>
+          </a:effectRef>
+          <a:fontRef idx="minor">
+            <a:schemeClr val="dk1"/>
+          </a:fontRef>
+        </p:style>
+        <p:txBody>
+          <a:bodyPr rtlCol="0" anchor="ctr"/>
+          <a:lstStyle/>
+          <a:p>
+            <a:pPr algn="ctr"/>
+            <a:r>
+              <a:rPr lang="en-US" dirty="0">
+                <a:latin typeface="Aptos" panose="020B0004020202020204" pitchFamily="34" charset="0"/>
+              </a:rPr>
+              <a:t>Return DEQM Gaps in Care Bundle(s)</a:t>
+            </a:r>
+          </a:p>
+        </p:txBody>
+      </p:sp>
+    </p:spTree>
+    <p:extLst>
+      <p:ext uri="{BB962C8B-B14F-4D97-AF65-F5344CB8AC3E}">
+        <p14:creationId xmlns:p14="http://schemas.microsoft.com/office/powerpoint/2010/main" val="65853685"/>
+      </p:ext>
+    </p:extLst>
+  </p:cSld>
+  <p:clrMapOvr>
+    <a:masterClrMapping/>
+  </p:clrMapOvr>
+</p:sld>
+</file>
+
+<file path=ppt/slides/slide3.xml><?xml version="1.0" encoding="utf-8"?>
+<p:sld xmlns:a="http://schemas.openxmlformats.org/drawingml/2006/main" xmlns:r="http://schemas.openxmlformats.org/officeDocument/2006/relationships" xmlns:p="http://schemas.openxmlformats.org/presentationml/2006/main">
+  <p:cSld>
+    <p:spTree>
+      <p:nvGrpSpPr>
         <p:cNvPr id="1" name=""/>
         <p:cNvGrpSpPr/>
         <p:nvPr/>
@@ -4349,7 +4858,7 @@
 </p:sld>
 </file>
 
-<file path=ppt/slides/slide3.xml><?xml version="1.0" encoding="utf-8"?>
+<file path=ppt/slides/slide4.xml><?xml version="1.0" encoding="utf-8"?>
 <p:sld xmlns:a="http://schemas.openxmlformats.org/drawingml/2006/main" xmlns:r="http://schemas.openxmlformats.org/officeDocument/2006/relationships" xmlns:p="http://schemas.openxmlformats.org/presentationml/2006/main">
   <p:cSld>
     <p:spTree>
@@ -5007,7 +5516,7 @@
 </p:sld>
 </file>
 
-<file path=ppt/slides/slide4.xml><?xml version="1.0" encoding="utf-8"?>
+<file path=ppt/slides/slide5.xml><?xml version="1.0" encoding="utf-8"?>
 <p:sld xmlns:a="http://schemas.openxmlformats.org/drawingml/2006/main" xmlns:r="http://schemas.openxmlformats.org/officeDocument/2006/relationships" xmlns:p="http://schemas.openxmlformats.org/presentationml/2006/main">
   <p:cSld>
     <p:spTree>
@@ -6846,7 +7355,7 @@
 </p:sld>
 </file>
 
-<file path=ppt/slides/slide5.xml><?xml version="1.0" encoding="utf-8"?>
+<file path=ppt/slides/slide6.xml><?xml version="1.0" encoding="utf-8"?>
 <p:sld xmlns:a="http://schemas.openxmlformats.org/drawingml/2006/main" xmlns:r="http://schemas.openxmlformats.org/officeDocument/2006/relationships" xmlns:p="http://schemas.openxmlformats.org/presentationml/2006/main">
   <p:cSld>
     <p:spTree>
@@ -6964,7 +7473,7 @@
 </p:sld>
 </file>
 
-<file path=ppt/slides/slide6.xml><?xml version="1.0" encoding="utf-8"?>
+<file path=ppt/slides/slide7.xml><?xml version="1.0" encoding="utf-8"?>
 <p:sld xmlns:a="http://schemas.openxmlformats.org/drawingml/2006/main" xmlns:r="http://schemas.openxmlformats.org/officeDocument/2006/relationships" xmlns:p="http://schemas.openxmlformats.org/presentationml/2006/main">
   <p:cSld>
     <p:spTree>
@@ -7685,7 +8194,7 @@
 </p:sld>
 </file>
 
-<file path=ppt/slides/slide7.xml><?xml version="1.0" encoding="utf-8"?>
+<file path=ppt/slides/slide8.xml><?xml version="1.0" encoding="utf-8"?>
 <p:sld xmlns:a="http://schemas.openxmlformats.org/drawingml/2006/main" xmlns:r="http://schemas.openxmlformats.org/officeDocument/2006/relationships" xmlns:p="http://schemas.openxmlformats.org/presentationml/2006/main">
   <p:cSld>
     <p:spTree>

</xml_diff>

<commit_message>
[FHIR-56294](https://jira.hl7.org/browse/FHIR-56294): Add GuidanceResponse Resource to list of resources used by Gaps In Care
</commit_message>
<xml_diff>
--- a/input/images/source/Gaps in Care Graphics.pptx
+++ b/input/images/source/Gaps in Care Graphics.pptx
@@ -220,7 +220,7 @@
           <a:p>
             <a:fld id="{17E6B6D7-20D6-4E9A-B6E5-85297A5570A7}" type="datetimeFigureOut">
               <a:rPr lang="en-US" smtClean="0"/>
-              <a:t>6/1/2026</a:t>
+              <a:t>6/23/2026</a:t>
             </a:fld>
             <a:endParaRPr lang="en-US"/>
           </a:p>
@@ -515,6 +515,13 @@
           </p:nvPr>
         </p:nvSpPr>
         <p:spPr/>
+        <p:txBody>
+          <a:bodyPr/>
+          <a:lstStyle/>
+          <a:p>
+            <a:endParaRPr lang="en-US"/>
+          </a:p>
+        </p:txBody>
       </p:sp>
       <p:sp>
         <p:nvSpPr>
@@ -603,6 +610,13 @@
           </p:nvPr>
         </p:nvSpPr>
         <p:spPr/>
+        <p:txBody>
+          <a:bodyPr/>
+          <a:lstStyle/>
+          <a:p>
+            <a:endParaRPr lang="en-US"/>
+          </a:p>
+        </p:txBody>
       </p:sp>
       <p:sp>
         <p:nvSpPr>
@@ -824,7 +838,7 @@
           <a:p>
             <a:fld id="{CCEBD49B-BC6D-4065-97F6-E22D565E4F2F}" type="datetimeFigureOut">
               <a:rPr lang="en-US" smtClean="0"/>
-              <a:t>6/1/2026</a:t>
+              <a:t>6/23/2026</a:t>
             </a:fld>
             <a:endParaRPr lang="en-US"/>
           </a:p>
@@ -1022,7 +1036,7 @@
           <a:p>
             <a:fld id="{CCEBD49B-BC6D-4065-97F6-E22D565E4F2F}" type="datetimeFigureOut">
               <a:rPr lang="en-US" smtClean="0"/>
-              <a:t>6/1/2026</a:t>
+              <a:t>6/23/2026</a:t>
             </a:fld>
             <a:endParaRPr lang="en-US"/>
           </a:p>
@@ -1230,7 +1244,7 @@
           <a:p>
             <a:fld id="{CCEBD49B-BC6D-4065-97F6-E22D565E4F2F}" type="datetimeFigureOut">
               <a:rPr lang="en-US" smtClean="0"/>
-              <a:t>6/1/2026</a:t>
+              <a:t>6/23/2026</a:t>
             </a:fld>
             <a:endParaRPr lang="en-US"/>
           </a:p>
@@ -1428,7 +1442,7 @@
           <a:p>
             <a:fld id="{CCEBD49B-BC6D-4065-97F6-E22D565E4F2F}" type="datetimeFigureOut">
               <a:rPr lang="en-US" smtClean="0"/>
-              <a:t>6/1/2026</a:t>
+              <a:t>6/23/2026</a:t>
             </a:fld>
             <a:endParaRPr lang="en-US"/>
           </a:p>
@@ -1703,7 +1717,7 @@
           <a:p>
             <a:fld id="{CCEBD49B-BC6D-4065-97F6-E22D565E4F2F}" type="datetimeFigureOut">
               <a:rPr lang="en-US" smtClean="0"/>
-              <a:t>6/1/2026</a:t>
+              <a:t>6/23/2026</a:t>
             </a:fld>
             <a:endParaRPr lang="en-US"/>
           </a:p>
@@ -1968,7 +1982,7 @@
           <a:p>
             <a:fld id="{CCEBD49B-BC6D-4065-97F6-E22D565E4F2F}" type="datetimeFigureOut">
               <a:rPr lang="en-US" smtClean="0"/>
-              <a:t>6/1/2026</a:t>
+              <a:t>6/23/2026</a:t>
             </a:fld>
             <a:endParaRPr lang="en-US"/>
           </a:p>
@@ -2380,7 +2394,7 @@
           <a:p>
             <a:fld id="{CCEBD49B-BC6D-4065-97F6-E22D565E4F2F}" type="datetimeFigureOut">
               <a:rPr lang="en-US" smtClean="0"/>
-              <a:t>6/1/2026</a:t>
+              <a:t>6/23/2026</a:t>
             </a:fld>
             <a:endParaRPr lang="en-US"/>
           </a:p>
@@ -2521,7 +2535,7 @@
           <a:p>
             <a:fld id="{CCEBD49B-BC6D-4065-97F6-E22D565E4F2F}" type="datetimeFigureOut">
               <a:rPr lang="en-US" smtClean="0"/>
-              <a:t>6/1/2026</a:t>
+              <a:t>6/23/2026</a:t>
             </a:fld>
             <a:endParaRPr lang="en-US"/>
           </a:p>
@@ -2634,7 +2648,7 @@
           <a:p>
             <a:fld id="{CCEBD49B-BC6D-4065-97F6-E22D565E4F2F}" type="datetimeFigureOut">
               <a:rPr lang="en-US" smtClean="0"/>
-              <a:t>6/1/2026</a:t>
+              <a:t>6/23/2026</a:t>
             </a:fld>
             <a:endParaRPr lang="en-US"/>
           </a:p>
@@ -2945,7 +2959,7 @@
           <a:p>
             <a:fld id="{CCEBD49B-BC6D-4065-97F6-E22D565E4F2F}" type="datetimeFigureOut">
               <a:rPr lang="en-US" smtClean="0"/>
-              <a:t>6/1/2026</a:t>
+              <a:t>6/23/2026</a:t>
             </a:fld>
             <a:endParaRPr lang="en-US"/>
           </a:p>
@@ -3233,7 +3247,7 @@
           <a:p>
             <a:fld id="{CCEBD49B-BC6D-4065-97F6-E22D565E4F2F}" type="datetimeFigureOut">
               <a:rPr lang="en-US" smtClean="0"/>
-              <a:t>6/1/2026</a:t>
+              <a:t>6/23/2026</a:t>
             </a:fld>
             <a:endParaRPr lang="en-US"/>
           </a:p>
@@ -3474,7 +3488,7 @@
           <a:p>
             <a:fld id="{CCEBD49B-BC6D-4065-97F6-E22D565E4F2F}" type="datetimeFigureOut">
               <a:rPr lang="en-US" smtClean="0"/>
-              <a:t>6/1/2026</a:t>
+              <a:t>6/23/2026</a:t>
             </a:fld>
             <a:endParaRPr lang="en-US"/>
           </a:p>
@@ -5967,7 +5981,7 @@
         </p:nvSpPr>
         <p:spPr>
           <a:xfrm>
-            <a:off x="596938" y="3518748"/>
+            <a:off x="489358" y="4486943"/>
             <a:ext cx="1864311" cy="795922"/>
           </a:xfrm>
           <a:prstGeom prst="flowChartProcess">
@@ -6698,7 +6712,7 @@
         </p:nvSpPr>
         <p:spPr>
           <a:xfrm>
-            <a:off x="593447" y="1901502"/>
+            <a:off x="485867" y="2934245"/>
             <a:ext cx="1864311" cy="776860"/>
           </a:xfrm>
           <a:prstGeom prst="flowChartProcess">
@@ -6937,8 +6951,8 @@
         </p:nvCxnSpPr>
         <p:spPr>
           <a:xfrm flipH="1">
-            <a:off x="2461249" y="3909382"/>
-            <a:ext cx="790794" cy="7327"/>
+            <a:off x="2353669" y="3909382"/>
+            <a:ext cx="898374" cy="975522"/>
           </a:xfrm>
           <a:prstGeom prst="straightConnector1">
             <a:avLst/>
@@ -6980,8 +6994,8 @@
         </p:nvCxnSpPr>
         <p:spPr>
           <a:xfrm>
-            <a:off x="1525603" y="2678362"/>
-            <a:ext cx="3491" cy="840386"/>
+            <a:off x="1418023" y="3711105"/>
+            <a:ext cx="3491" cy="775838"/>
           </a:xfrm>
           <a:prstGeom prst="straightConnector1">
             <a:avLst/>
@@ -7019,7 +7033,7 @@
         </p:nvSpPr>
         <p:spPr>
           <a:xfrm>
-            <a:off x="718799" y="5034569"/>
+            <a:off x="440559" y="5625518"/>
             <a:ext cx="2075630" cy="646331"/>
           </a:xfrm>
           <a:prstGeom prst="rect">
@@ -7051,15 +7065,15 @@
           </p:cNvPr>
           <p:cNvCxnSpPr>
             <a:cxnSpLocks/>
-            <a:stCxn id="4" idx="0"/>
+            <a:stCxn id="4" idx="1"/>
             <a:endCxn id="90" idx="3"/>
           </p:cNvCxnSpPr>
           <p:nvPr/>
         </p:nvCxnSpPr>
         <p:spPr>
           <a:xfrm flipH="1" flipV="1">
-            <a:off x="2457758" y="2289932"/>
-            <a:ext cx="1726441" cy="1231020"/>
+            <a:off x="2350178" y="3322675"/>
+            <a:ext cx="901865" cy="586707"/>
           </a:xfrm>
           <a:prstGeom prst="straightConnector1">
             <a:avLst/>
@@ -7097,7 +7111,7 @@
         </p:nvSpPr>
         <p:spPr>
           <a:xfrm>
-            <a:off x="2716620" y="2684407"/>
+            <a:off x="2396858" y="3440053"/>
             <a:ext cx="851536" cy="230832"/>
           </a:xfrm>
           <a:prstGeom prst="rect">
@@ -7134,7 +7148,7 @@
         </p:nvSpPr>
         <p:spPr>
           <a:xfrm>
-            <a:off x="1250351" y="2956726"/>
+            <a:off x="1142771" y="3924921"/>
             <a:ext cx="573375" cy="230832"/>
           </a:xfrm>
           <a:prstGeom prst="rect">
@@ -7171,7 +7185,7 @@
         </p:nvSpPr>
         <p:spPr>
           <a:xfrm>
-            <a:off x="2602823" y="3782240"/>
+            <a:off x="2569013" y="4251846"/>
             <a:ext cx="573375" cy="230832"/>
           </a:xfrm>
           <a:prstGeom prst="rect">
@@ -7338,6 +7352,140 @@
             <a:r>
               <a:rPr lang="en-US" sz="900" b="1" dirty="0"/>
               <a:t>evaluateResources</a:t>
+            </a:r>
+          </a:p>
+        </p:txBody>
+      </p:sp>
+      <p:sp>
+        <p:nvSpPr>
+          <p:cNvPr id="9" name="Flowchart: Process 8">
+            <a:extLst>
+              <a:ext uri="{FF2B5EF4-FFF2-40B4-BE49-F238E27FC236}">
+                <a16:creationId xmlns:a16="http://schemas.microsoft.com/office/drawing/2014/main" id="{EDA1EADE-5AFD-2B31-96BD-F517D1A6F431}"/>
+              </a:ext>
+            </a:extLst>
+          </p:cNvPr>
+          <p:cNvSpPr/>
+          <p:nvPr/>
+        </p:nvSpPr>
+        <p:spPr>
+          <a:xfrm>
+            <a:off x="481670" y="1633448"/>
+            <a:ext cx="1864311" cy="776860"/>
+          </a:xfrm>
+          <a:prstGeom prst="flowChartProcess">
+            <a:avLst/>
+          </a:prstGeom>
+          <a:ln>
+            <a:solidFill>
+              <a:schemeClr val="tx1"/>
+            </a:solidFill>
+          </a:ln>
+        </p:spPr>
+        <p:style>
+          <a:lnRef idx="2">
+            <a:schemeClr val="accent1">
+              <a:shade val="50000"/>
+            </a:schemeClr>
+          </a:lnRef>
+          <a:fillRef idx="1">
+            <a:schemeClr val="accent1"/>
+          </a:fillRef>
+          <a:effectRef idx="0">
+            <a:schemeClr val="accent1"/>
+          </a:effectRef>
+          <a:fontRef idx="minor">
+            <a:schemeClr val="lt1"/>
+          </a:fontRef>
+        </p:style>
+        <p:txBody>
+          <a:bodyPr rtlCol="0" anchor="ctr"/>
+          <a:lstStyle/>
+          <a:p>
+            <a:pPr algn="ctr"/>
+            <a:r>
+              <a:rPr lang="en-US" sz="1600" dirty="0"/>
+              <a:t>Detailed Care Gap Guidance Response</a:t>
+            </a:r>
+          </a:p>
+        </p:txBody>
+      </p:sp>
+      <p:cxnSp>
+        <p:nvCxnSpPr>
+          <p:cNvPr id="10" name="Straight Arrow Connector 9">
+            <a:extLst>
+              <a:ext uri="{FF2B5EF4-FFF2-40B4-BE49-F238E27FC236}">
+                <a16:creationId xmlns:a16="http://schemas.microsoft.com/office/drawing/2014/main" id="{DF6C3439-D8C2-9E40-8526-74058D1967B5}"/>
+              </a:ext>
+            </a:extLst>
+          </p:cNvPr>
+          <p:cNvCxnSpPr>
+            <a:cxnSpLocks/>
+            <a:stCxn id="90" idx="0"/>
+            <a:endCxn id="9" idx="2"/>
+          </p:cNvCxnSpPr>
+          <p:nvPr/>
+        </p:nvCxnSpPr>
+        <p:spPr>
+          <a:xfrm flipH="1" flipV="1">
+            <a:off x="1413826" y="2410308"/>
+            <a:ext cx="4197" cy="523937"/>
+          </a:xfrm>
+          <a:prstGeom prst="straightConnector1">
+            <a:avLst/>
+          </a:prstGeom>
+          <a:ln>
+            <a:tailEnd type="triangle"/>
+          </a:ln>
+        </p:spPr>
+        <p:style>
+          <a:lnRef idx="1">
+            <a:schemeClr val="accent1"/>
+          </a:lnRef>
+          <a:fillRef idx="0">
+            <a:schemeClr val="accent1"/>
+          </a:fillRef>
+          <a:effectRef idx="0">
+            <a:schemeClr val="accent1"/>
+          </a:effectRef>
+          <a:fontRef idx="minor">
+            <a:schemeClr val="tx1"/>
+          </a:fontRef>
+        </p:style>
+      </p:cxnSp>
+      <p:sp>
+        <p:nvSpPr>
+          <p:cNvPr id="21" name="TextBox 20">
+            <a:extLst>
+              <a:ext uri="{FF2B5EF4-FFF2-40B4-BE49-F238E27FC236}">
+                <a16:creationId xmlns:a16="http://schemas.microsoft.com/office/drawing/2014/main" id="{430D58F7-98AF-3FF5-FFF3-5ED3AE9C25EF}"/>
+              </a:ext>
+            </a:extLst>
+          </p:cNvPr>
+          <p:cNvSpPr txBox="1"/>
+          <p:nvPr/>
+        </p:nvSpPr>
+        <p:spPr>
+          <a:xfrm>
+            <a:off x="912750" y="2569817"/>
+            <a:ext cx="1180791" cy="230832"/>
+          </a:xfrm>
+          <a:prstGeom prst="rect">
+            <a:avLst/>
+          </a:prstGeom>
+          <a:solidFill>
+            <a:schemeClr val="bg1"/>
+          </a:solidFill>
+        </p:spPr>
+        <p:txBody>
+          <a:bodyPr wrap="square" rtlCol="0">
+            <a:spAutoFit/>
+          </a:bodyPr>
+          <a:lstStyle/>
+          <a:p>
+            <a:r>
+              <a:rPr lang="en-US" sz="900" b="1" dirty="0"/>
+              <a:t>evidence.detail</a:t>
             </a:r>
           </a:p>
         </p:txBody>

</xml_diff>

<commit_message>
[FHIR-56296](https://jira.hl7.org/browse/FHIR-56296): Updated Gaps in care bundle profile to allow document or collection bundles
</commit_message>
<xml_diff>
--- a/input/images/source/Gaps in Care Graphics.pptx
+++ b/input/images/source/Gaps in Care Graphics.pptx
@@ -5,7 +5,7 @@
     <p:sldMasterId id="2147483648" r:id="rId1"/>
   </p:sldMasterIdLst>
   <p:notesMasterIdLst>
-    <p:notesMasterId r:id="rId10"/>
+    <p:notesMasterId r:id="rId11"/>
   </p:notesMasterIdLst>
   <p:sldIdLst>
     <p:sldId id="257" r:id="rId2"/>
@@ -15,7 +15,8 @@
     <p:sldId id="264" r:id="rId6"/>
     <p:sldId id="256" r:id="rId7"/>
     <p:sldId id="265" r:id="rId8"/>
-    <p:sldId id="268" r:id="rId9"/>
+    <p:sldId id="270" r:id="rId9"/>
+    <p:sldId id="268" r:id="rId10"/>
   </p:sldIdLst>
   <p:sldSz cx="12192000" cy="6858000"/>
   <p:notesSz cx="6858000" cy="9144000"/>
@@ -126,6 +127,7 @@
             <p14:sldId id="264"/>
             <p14:sldId id="256"/>
             <p14:sldId id="265"/>
+            <p14:sldId id="270"/>
             <p14:sldId id="268"/>
           </p14:sldIdLst>
         </p14:section>
@@ -220,7 +222,7 @@
           <a:p>
             <a:fld id="{17E6B6D7-20D6-4E9A-B6E5-85297A5570A7}" type="datetimeFigureOut">
               <a:rPr lang="en-US" smtClean="0"/>
-              <a:t>6/23/2026</a:t>
+              <a:t>8/11/2026</a:t>
             </a:fld>
             <a:endParaRPr lang="en-US"/>
           </a:p>
@@ -587,6 +589,139 @@
   <p:cSld>
     <p:spTree>
       <p:nvGrpSpPr>
+        <p:cNvPr id="1" name="">
+          <a:extLst>
+            <a:ext uri="{FF2B5EF4-FFF2-40B4-BE49-F238E27FC236}">
+              <a16:creationId xmlns:a16="http://schemas.microsoft.com/office/drawing/2014/main" id="{984DF49F-1116-8534-17A3-E899FB61857E}"/>
+            </a:ext>
+          </a:extLst>
+        </p:cNvPr>
+        <p:cNvGrpSpPr/>
+        <p:nvPr/>
+      </p:nvGrpSpPr>
+      <p:grpSpPr>
+        <a:xfrm>
+          <a:off x="0" y="0"/>
+          <a:ext cx="0" cy="0"/>
+          <a:chOff x="0" y="0"/>
+          <a:chExt cx="0" cy="0"/>
+        </a:xfrm>
+      </p:grpSpPr>
+      <p:sp>
+        <p:nvSpPr>
+          <p:cNvPr id="2" name="Slide Image Placeholder 1">
+            <a:extLst>
+              <a:ext uri="{FF2B5EF4-FFF2-40B4-BE49-F238E27FC236}">
+                <a16:creationId xmlns:a16="http://schemas.microsoft.com/office/drawing/2014/main" id="{C6A3D7D1-B032-99F4-F6BF-E0EAD7A861D3}"/>
+              </a:ext>
+            </a:extLst>
+          </p:cNvPr>
+          <p:cNvSpPr>
+            <a:spLocks noGrp="1" noRot="1" noChangeAspect="1"/>
+          </p:cNvSpPr>
+          <p:nvPr>
+            <p:ph type="sldImg"/>
+          </p:nvPr>
+        </p:nvSpPr>
+        <p:spPr/>
+        <p:txBody>
+          <a:bodyPr/>
+          <a:lstStyle/>
+          <a:p>
+            <a:endParaRPr lang="en-US"/>
+          </a:p>
+        </p:txBody>
+      </p:sp>
+      <p:sp>
+        <p:nvSpPr>
+          <p:cNvPr id="3" name="Notes Placeholder 2">
+            <a:extLst>
+              <a:ext uri="{FF2B5EF4-FFF2-40B4-BE49-F238E27FC236}">
+                <a16:creationId xmlns:a16="http://schemas.microsoft.com/office/drawing/2014/main" id="{9040DC31-DE5C-537D-27F8-B6EEB6228444}"/>
+              </a:ext>
+            </a:extLst>
+          </p:cNvPr>
+          <p:cNvSpPr>
+            <a:spLocks noGrp="1"/>
+          </p:cNvSpPr>
+          <p:nvPr>
+            <p:ph type="body" idx="1"/>
+          </p:nvPr>
+        </p:nvSpPr>
+        <p:spPr/>
+        <p:txBody>
+          <a:bodyPr/>
+          <a:lstStyle/>
+          <a:p>
+            <a:r>
+              <a:rPr lang="en-US" sz="1200" dirty="0"/>
+              <a:t>11/23/2022: Added this slide to address https://jira.hl7.org/browse/FHIR-33175 as part of the STU4-ballot (to show Bundle including all referenced patient resources and </a:t>
+            </a:r>
+            <a:r>
+              <a:rPr lang="en-US" sz="1200" dirty="0" err="1"/>
+              <a:t>detectedIssue</a:t>
+            </a:r>
+            <a:r>
+              <a:rPr lang="en-US" sz="1200" dirty="0"/>
+              <a:t> as entries)</a:t>
+            </a:r>
+            <a:br>
+              <a:rPr lang="en-US" sz="1200" dirty="0"/>
+            </a:br>
+            <a:br>
+              <a:rPr lang="en-US" sz="1400" dirty="0"/>
+            </a:br>
+            <a:endParaRPr lang="en-US" dirty="0"/>
+          </a:p>
+        </p:txBody>
+      </p:sp>
+      <p:sp>
+        <p:nvSpPr>
+          <p:cNvPr id="4" name="Slide Number Placeholder 3">
+            <a:extLst>
+              <a:ext uri="{FF2B5EF4-FFF2-40B4-BE49-F238E27FC236}">
+                <a16:creationId xmlns:a16="http://schemas.microsoft.com/office/drawing/2014/main" id="{C6EB135C-19FA-325D-850C-73C7DF7A23C1}"/>
+              </a:ext>
+            </a:extLst>
+          </p:cNvPr>
+          <p:cNvSpPr>
+            <a:spLocks noGrp="1"/>
+          </p:cNvSpPr>
+          <p:nvPr>
+            <p:ph type="sldNum" sz="quarter" idx="5"/>
+          </p:nvPr>
+        </p:nvSpPr>
+        <p:spPr/>
+        <p:txBody>
+          <a:bodyPr/>
+          <a:lstStyle/>
+          <a:p>
+            <a:fld id="{F6C01152-882A-4CAB-AF5B-0D5B05615CCB}" type="slidenum">
+              <a:rPr lang="en-US" smtClean="0"/>
+              <a:t>8</a:t>
+            </a:fld>
+            <a:endParaRPr lang="en-US"/>
+          </a:p>
+        </p:txBody>
+      </p:sp>
+    </p:spTree>
+    <p:extLst>
+      <p:ext uri="{BB962C8B-B14F-4D97-AF65-F5344CB8AC3E}">
+        <p14:creationId xmlns:p14="http://schemas.microsoft.com/office/powerpoint/2010/main" val="1753565463"/>
+      </p:ext>
+    </p:extLst>
+  </p:cSld>
+  <p:clrMapOvr>
+    <a:masterClrMapping/>
+  </p:clrMapOvr>
+</p:notes>
+</file>
+
+<file path=ppt/notesSlides/notesSlide3.xml><?xml version="1.0" encoding="utf-8"?>
+<p:notes xmlns:a="http://schemas.openxmlformats.org/drawingml/2006/main" xmlns:r="http://schemas.openxmlformats.org/officeDocument/2006/relationships" xmlns:p="http://schemas.openxmlformats.org/presentationml/2006/main">
+  <p:cSld>
+    <p:spTree>
+      <p:nvGrpSpPr>
         <p:cNvPr id="1" name=""/>
         <p:cNvGrpSpPr/>
         <p:nvPr/>
@@ -672,7 +807,7 @@
           <a:p>
             <a:fld id="{F6C01152-882A-4CAB-AF5B-0D5B05615CCB}" type="slidenum">
               <a:rPr lang="en-US" smtClean="0"/>
-              <a:t>8</a:t>
+              <a:t>9</a:t>
             </a:fld>
             <a:endParaRPr lang="en-US"/>
           </a:p>
@@ -838,7 +973,7 @@
           <a:p>
             <a:fld id="{CCEBD49B-BC6D-4065-97F6-E22D565E4F2F}" type="datetimeFigureOut">
               <a:rPr lang="en-US" smtClean="0"/>
-              <a:t>6/23/2026</a:t>
+              <a:t>8/11/2026</a:t>
             </a:fld>
             <a:endParaRPr lang="en-US"/>
           </a:p>
@@ -1036,7 +1171,7 @@
           <a:p>
             <a:fld id="{CCEBD49B-BC6D-4065-97F6-E22D565E4F2F}" type="datetimeFigureOut">
               <a:rPr lang="en-US" smtClean="0"/>
-              <a:t>6/23/2026</a:t>
+              <a:t>8/11/2026</a:t>
             </a:fld>
             <a:endParaRPr lang="en-US"/>
           </a:p>
@@ -1244,7 +1379,7 @@
           <a:p>
             <a:fld id="{CCEBD49B-BC6D-4065-97F6-E22D565E4F2F}" type="datetimeFigureOut">
               <a:rPr lang="en-US" smtClean="0"/>
-              <a:t>6/23/2026</a:t>
+              <a:t>8/11/2026</a:t>
             </a:fld>
             <a:endParaRPr lang="en-US"/>
           </a:p>
@@ -1442,7 +1577,7 @@
           <a:p>
             <a:fld id="{CCEBD49B-BC6D-4065-97F6-E22D565E4F2F}" type="datetimeFigureOut">
               <a:rPr lang="en-US" smtClean="0"/>
-              <a:t>6/23/2026</a:t>
+              <a:t>8/11/2026</a:t>
             </a:fld>
             <a:endParaRPr lang="en-US"/>
           </a:p>
@@ -1717,7 +1852,7 @@
           <a:p>
             <a:fld id="{CCEBD49B-BC6D-4065-97F6-E22D565E4F2F}" type="datetimeFigureOut">
               <a:rPr lang="en-US" smtClean="0"/>
-              <a:t>6/23/2026</a:t>
+              <a:t>8/11/2026</a:t>
             </a:fld>
             <a:endParaRPr lang="en-US"/>
           </a:p>
@@ -1982,7 +2117,7 @@
           <a:p>
             <a:fld id="{CCEBD49B-BC6D-4065-97F6-E22D565E4F2F}" type="datetimeFigureOut">
               <a:rPr lang="en-US" smtClean="0"/>
-              <a:t>6/23/2026</a:t>
+              <a:t>8/11/2026</a:t>
             </a:fld>
             <a:endParaRPr lang="en-US"/>
           </a:p>
@@ -2394,7 +2529,7 @@
           <a:p>
             <a:fld id="{CCEBD49B-BC6D-4065-97F6-E22D565E4F2F}" type="datetimeFigureOut">
               <a:rPr lang="en-US" smtClean="0"/>
-              <a:t>6/23/2026</a:t>
+              <a:t>8/11/2026</a:t>
             </a:fld>
             <a:endParaRPr lang="en-US"/>
           </a:p>
@@ -2535,7 +2670,7 @@
           <a:p>
             <a:fld id="{CCEBD49B-BC6D-4065-97F6-E22D565E4F2F}" type="datetimeFigureOut">
               <a:rPr lang="en-US" smtClean="0"/>
-              <a:t>6/23/2026</a:t>
+              <a:t>8/11/2026</a:t>
             </a:fld>
             <a:endParaRPr lang="en-US"/>
           </a:p>
@@ -2648,7 +2783,7 @@
           <a:p>
             <a:fld id="{CCEBD49B-BC6D-4065-97F6-E22D565E4F2F}" type="datetimeFigureOut">
               <a:rPr lang="en-US" smtClean="0"/>
-              <a:t>6/23/2026</a:t>
+              <a:t>8/11/2026</a:t>
             </a:fld>
             <a:endParaRPr lang="en-US"/>
           </a:p>
@@ -2959,7 +3094,7 @@
           <a:p>
             <a:fld id="{CCEBD49B-BC6D-4065-97F6-E22D565E4F2F}" type="datetimeFigureOut">
               <a:rPr lang="en-US" smtClean="0"/>
-              <a:t>6/23/2026</a:t>
+              <a:t>8/11/2026</a:t>
             </a:fld>
             <a:endParaRPr lang="en-US"/>
           </a:p>
@@ -3247,7 +3382,7 @@
           <a:p>
             <a:fld id="{CCEBD49B-BC6D-4065-97F6-E22D565E4F2F}" type="datetimeFigureOut">
               <a:rPr lang="en-US" smtClean="0"/>
-              <a:t>6/23/2026</a:t>
+              <a:t>8/11/2026</a:t>
             </a:fld>
             <a:endParaRPr lang="en-US"/>
           </a:p>
@@ -3488,7 +3623,7 @@
           <a:p>
             <a:fld id="{CCEBD49B-BC6D-4065-97F6-E22D565E4F2F}" type="datetimeFigureOut">
               <a:rPr lang="en-US" smtClean="0"/>
-              <a:t>6/23/2026</a:t>
+              <a:t>8/11/2026</a:t>
             </a:fld>
             <a:endParaRPr lang="en-US"/>
           </a:p>
@@ -8347,6 +8482,2675 @@
   <p:cSld>
     <p:spTree>
       <p:nvGrpSpPr>
+        <p:cNvPr id="1" name="">
+          <a:extLst>
+            <a:ext uri="{FF2B5EF4-FFF2-40B4-BE49-F238E27FC236}">
+              <a16:creationId xmlns:a16="http://schemas.microsoft.com/office/drawing/2014/main" id="{0D41ED3F-20A4-D4EE-9EA3-E614610D439A}"/>
+            </a:ext>
+          </a:extLst>
+        </p:cNvPr>
+        <p:cNvGrpSpPr/>
+        <p:nvPr/>
+      </p:nvGrpSpPr>
+      <p:grpSpPr>
+        <a:xfrm>
+          <a:off x="0" y="0"/>
+          <a:ext cx="0" cy="0"/>
+          <a:chOff x="0" y="0"/>
+          <a:chExt cx="0" cy="0"/>
+        </a:xfrm>
+      </p:grpSpPr>
+      <p:sp>
+        <p:nvSpPr>
+          <p:cNvPr id="2" name="Title 1">
+            <a:extLst>
+              <a:ext uri="{FF2B5EF4-FFF2-40B4-BE49-F238E27FC236}">
+                <a16:creationId xmlns:a16="http://schemas.microsoft.com/office/drawing/2014/main" id="{B5C1FC47-14AF-B068-BA78-1D3AFA02A64E}"/>
+              </a:ext>
+            </a:extLst>
+          </p:cNvPr>
+          <p:cNvSpPr>
+            <a:spLocks noGrp="1"/>
+          </p:cNvSpPr>
+          <p:nvPr>
+            <p:ph type="title"/>
+          </p:nvPr>
+        </p:nvSpPr>
+        <p:spPr>
+          <a:xfrm>
+            <a:off x="838199" y="365125"/>
+            <a:ext cx="11056557" cy="1325563"/>
+          </a:xfrm>
+        </p:spPr>
+        <p:txBody>
+          <a:bodyPr/>
+          <a:lstStyle/>
+          <a:p>
+            <a:r>
+              <a:rPr lang="en-US" sz="3200" dirty="0"/>
+              <a:t>DEQM Gaps In Care Bundle (document)</a:t>
+            </a:r>
+            <a:endParaRPr lang="en-US" dirty="0"/>
+          </a:p>
+        </p:txBody>
+      </p:sp>
+      <p:sp>
+        <p:nvSpPr>
+          <p:cNvPr id="3" name="Content Placeholder 2">
+            <a:extLst>
+              <a:ext uri="{FF2B5EF4-FFF2-40B4-BE49-F238E27FC236}">
+                <a16:creationId xmlns:a16="http://schemas.microsoft.com/office/drawing/2014/main" id="{17C105B7-F671-762C-AA0E-B8DB96E59742}"/>
+              </a:ext>
+            </a:extLst>
+          </p:cNvPr>
+          <p:cNvSpPr>
+            <a:spLocks noGrp="1"/>
+          </p:cNvSpPr>
+          <p:nvPr>
+            <p:ph idx="1"/>
+          </p:nvPr>
+        </p:nvSpPr>
+        <p:spPr>
+          <a:xfrm>
+            <a:off x="409406" y="1441841"/>
+            <a:ext cx="11185124" cy="5142461"/>
+          </a:xfrm>
+        </p:spPr>
+        <p:txBody>
+          <a:bodyPr/>
+          <a:lstStyle/>
+          <a:p>
+            <a:pPr marL="0" indent="0">
+              <a:buNone/>
+            </a:pPr>
+            <a:r>
+              <a:rPr lang="en-US" dirty="0"/>
+              <a:t> </a:t>
+            </a:r>
+          </a:p>
+        </p:txBody>
+      </p:sp>
+      <p:sp>
+        <p:nvSpPr>
+          <p:cNvPr id="5" name="Flowchart: Process 4">
+            <a:extLst>
+              <a:ext uri="{FF2B5EF4-FFF2-40B4-BE49-F238E27FC236}">
+                <a16:creationId xmlns:a16="http://schemas.microsoft.com/office/drawing/2014/main" id="{CBB3FC02-660B-CB0B-2238-AA8D2C33527B}"/>
+              </a:ext>
+            </a:extLst>
+          </p:cNvPr>
+          <p:cNvSpPr/>
+          <p:nvPr/>
+        </p:nvSpPr>
+        <p:spPr>
+          <a:xfrm>
+            <a:off x="563136" y="1820994"/>
+            <a:ext cx="1864311" cy="611431"/>
+          </a:xfrm>
+          <a:prstGeom prst="flowChartProcess">
+            <a:avLst/>
+          </a:prstGeom>
+          <a:ln>
+            <a:solidFill>
+              <a:schemeClr val="tx1"/>
+            </a:solidFill>
+          </a:ln>
+        </p:spPr>
+        <p:style>
+          <a:lnRef idx="2">
+            <a:schemeClr val="accent1">
+              <a:shade val="50000"/>
+            </a:schemeClr>
+          </a:lnRef>
+          <a:fillRef idx="1">
+            <a:schemeClr val="accent1"/>
+          </a:fillRef>
+          <a:effectRef idx="0">
+            <a:schemeClr val="accent1"/>
+          </a:effectRef>
+          <a:fontRef idx="minor">
+            <a:schemeClr val="lt1"/>
+          </a:fontRef>
+        </p:style>
+        <p:txBody>
+          <a:bodyPr rtlCol="0" anchor="ctr"/>
+          <a:lstStyle/>
+          <a:p>
+            <a:pPr algn="ctr"/>
+            <a:r>
+              <a:rPr lang="en-US" sz="1600" dirty="0"/>
+              <a:t>GIC Bundle</a:t>
+            </a:r>
+          </a:p>
+        </p:txBody>
+      </p:sp>
+      <p:sp>
+        <p:nvSpPr>
+          <p:cNvPr id="7" name="Flowchart: Process 6">
+            <a:extLst>
+              <a:ext uri="{FF2B5EF4-FFF2-40B4-BE49-F238E27FC236}">
+                <a16:creationId xmlns:a16="http://schemas.microsoft.com/office/drawing/2014/main" id="{EE36308E-622C-F64B-2F67-9E7B3D22B9BA}"/>
+              </a:ext>
+            </a:extLst>
+          </p:cNvPr>
+          <p:cNvSpPr/>
+          <p:nvPr/>
+        </p:nvSpPr>
+        <p:spPr>
+          <a:xfrm>
+            <a:off x="3949210" y="2681763"/>
+            <a:ext cx="1864311" cy="613637"/>
+          </a:xfrm>
+          <a:prstGeom prst="flowChartProcess">
+            <a:avLst/>
+          </a:prstGeom>
+          <a:solidFill>
+            <a:schemeClr val="accent1"/>
+          </a:solidFill>
+          <a:ln>
+            <a:solidFill>
+              <a:schemeClr val="tx1"/>
+            </a:solidFill>
+          </a:ln>
+        </p:spPr>
+        <p:style>
+          <a:lnRef idx="2">
+            <a:schemeClr val="accent1">
+              <a:shade val="50000"/>
+            </a:schemeClr>
+          </a:lnRef>
+          <a:fillRef idx="1">
+            <a:schemeClr val="accent1"/>
+          </a:fillRef>
+          <a:effectRef idx="0">
+            <a:schemeClr val="accent1"/>
+          </a:effectRef>
+          <a:fontRef idx="minor">
+            <a:schemeClr val="lt1"/>
+          </a:fontRef>
+        </p:style>
+        <p:txBody>
+          <a:bodyPr rtlCol="0" anchor="ctr"/>
+          <a:lstStyle/>
+          <a:p>
+            <a:pPr algn="ctr"/>
+            <a:r>
+              <a:rPr lang="en-US" sz="1600" dirty="0"/>
+              <a:t>GIC Measure Report  </a:t>
+            </a:r>
+            <a:r>
+              <a:rPr lang="en-US" sz="1000" dirty="0"/>
+              <a:t>Colorectal Cancer Screening</a:t>
+            </a:r>
+          </a:p>
+        </p:txBody>
+      </p:sp>
+      <p:sp>
+        <p:nvSpPr>
+          <p:cNvPr id="13" name="Flowchart: Process 12">
+            <a:extLst>
+              <a:ext uri="{FF2B5EF4-FFF2-40B4-BE49-F238E27FC236}">
+                <a16:creationId xmlns:a16="http://schemas.microsoft.com/office/drawing/2014/main" id="{98A80350-D873-C321-7D28-7015AAFD0A0C}"/>
+              </a:ext>
+            </a:extLst>
+          </p:cNvPr>
+          <p:cNvSpPr/>
+          <p:nvPr/>
+        </p:nvSpPr>
+        <p:spPr>
+          <a:xfrm>
+            <a:off x="3949209" y="3520726"/>
+            <a:ext cx="1864311" cy="555563"/>
+          </a:xfrm>
+          <a:prstGeom prst="flowChartProcess">
+            <a:avLst/>
+          </a:prstGeom>
+          <a:ln>
+            <a:solidFill>
+              <a:schemeClr val="tx1"/>
+            </a:solidFill>
+          </a:ln>
+        </p:spPr>
+        <p:style>
+          <a:lnRef idx="2">
+            <a:schemeClr val="accent1">
+              <a:shade val="50000"/>
+            </a:schemeClr>
+          </a:lnRef>
+          <a:fillRef idx="1">
+            <a:schemeClr val="accent1"/>
+          </a:fillRef>
+          <a:effectRef idx="0">
+            <a:schemeClr val="accent1"/>
+          </a:effectRef>
+          <a:fontRef idx="minor">
+            <a:schemeClr val="lt1"/>
+          </a:fontRef>
+        </p:style>
+        <p:txBody>
+          <a:bodyPr rtlCol="0" anchor="ctr"/>
+          <a:lstStyle/>
+          <a:p>
+            <a:pPr algn="ctr"/>
+            <a:r>
+              <a:rPr lang="en-US" sz="1600" dirty="0"/>
+              <a:t>Patient</a:t>
+            </a:r>
+          </a:p>
+        </p:txBody>
+      </p:sp>
+      <p:sp>
+        <p:nvSpPr>
+          <p:cNvPr id="15" name="Flowchart: Process 14">
+            <a:extLst>
+              <a:ext uri="{FF2B5EF4-FFF2-40B4-BE49-F238E27FC236}">
+                <a16:creationId xmlns:a16="http://schemas.microsoft.com/office/drawing/2014/main" id="{FD584335-0484-4307-AE4E-F7E97F8AC581}"/>
+              </a:ext>
+            </a:extLst>
+          </p:cNvPr>
+          <p:cNvSpPr/>
+          <p:nvPr/>
+        </p:nvSpPr>
+        <p:spPr>
+          <a:xfrm>
+            <a:off x="10169285" y="2782563"/>
+            <a:ext cx="1864310" cy="688895"/>
+          </a:xfrm>
+          <a:prstGeom prst="flowChartProcess">
+            <a:avLst/>
+          </a:prstGeom>
+          <a:solidFill>
+            <a:schemeClr val="accent5">
+              <a:lumMod val="60000"/>
+              <a:lumOff val="40000"/>
+            </a:schemeClr>
+          </a:solidFill>
+          <a:ln>
+            <a:noFill/>
+          </a:ln>
+        </p:spPr>
+        <p:style>
+          <a:lnRef idx="2">
+            <a:schemeClr val="accent1">
+              <a:shade val="50000"/>
+            </a:schemeClr>
+          </a:lnRef>
+          <a:fillRef idx="1">
+            <a:schemeClr val="accent1"/>
+          </a:fillRef>
+          <a:effectRef idx="0">
+            <a:schemeClr val="accent1"/>
+          </a:effectRef>
+          <a:fontRef idx="minor">
+            <a:schemeClr val="lt1"/>
+          </a:fontRef>
+        </p:style>
+        <p:txBody>
+          <a:bodyPr rtlCol="0" anchor="ctr"/>
+          <a:lstStyle/>
+          <a:p>
+            <a:pPr algn="ctr"/>
+            <a:r>
+              <a:rPr lang="en-US" sz="1600" dirty="0"/>
+              <a:t>Lab Observation</a:t>
+            </a:r>
+          </a:p>
+          <a:p>
+            <a:pPr algn="ctr"/>
+            <a:r>
+              <a:rPr lang="en-US" sz="1000" dirty="0"/>
+              <a:t>FOBT</a:t>
+            </a:r>
+          </a:p>
+        </p:txBody>
+      </p:sp>
+      <p:sp>
+        <p:nvSpPr>
+          <p:cNvPr id="16" name="Flowchart: Process 15">
+            <a:extLst>
+              <a:ext uri="{FF2B5EF4-FFF2-40B4-BE49-F238E27FC236}">
+                <a16:creationId xmlns:a16="http://schemas.microsoft.com/office/drawing/2014/main" id="{6FF416B1-7F47-BD79-AF53-3C0BBD95176A}"/>
+              </a:ext>
+            </a:extLst>
+          </p:cNvPr>
+          <p:cNvSpPr/>
+          <p:nvPr/>
+        </p:nvSpPr>
+        <p:spPr>
+          <a:xfrm>
+            <a:off x="3955723" y="5106004"/>
+            <a:ext cx="1864311" cy="562122"/>
+          </a:xfrm>
+          <a:prstGeom prst="flowChartProcess">
+            <a:avLst/>
+          </a:prstGeom>
+          <a:ln>
+            <a:solidFill>
+              <a:schemeClr val="tx1"/>
+            </a:solidFill>
+          </a:ln>
+        </p:spPr>
+        <p:style>
+          <a:lnRef idx="2">
+            <a:schemeClr val="accent1">
+              <a:shade val="50000"/>
+            </a:schemeClr>
+          </a:lnRef>
+          <a:fillRef idx="1">
+            <a:schemeClr val="accent1"/>
+          </a:fillRef>
+          <a:effectRef idx="0">
+            <a:schemeClr val="accent1"/>
+          </a:effectRef>
+          <a:fontRef idx="minor">
+            <a:schemeClr val="lt1"/>
+          </a:fontRef>
+        </p:style>
+        <p:txBody>
+          <a:bodyPr rtlCol="0" anchor="ctr"/>
+          <a:lstStyle/>
+          <a:p>
+            <a:pPr algn="ctr"/>
+            <a:r>
+              <a:rPr lang="en-US" sz="1600" dirty="0"/>
+              <a:t>Organization</a:t>
+            </a:r>
+          </a:p>
+        </p:txBody>
+      </p:sp>
+      <p:cxnSp>
+        <p:nvCxnSpPr>
+          <p:cNvPr id="44" name="Straight Arrow Connector 43">
+            <a:extLst>
+              <a:ext uri="{FF2B5EF4-FFF2-40B4-BE49-F238E27FC236}">
+                <a16:creationId xmlns:a16="http://schemas.microsoft.com/office/drawing/2014/main" id="{F75DB4C0-EB2F-E8BA-C158-5E783375EDD4}"/>
+              </a:ext>
+            </a:extLst>
+          </p:cNvPr>
+          <p:cNvCxnSpPr>
+            <a:cxnSpLocks/>
+            <a:stCxn id="90" idx="3"/>
+            <a:endCxn id="15" idx="1"/>
+          </p:cNvCxnSpPr>
+          <p:nvPr/>
+        </p:nvCxnSpPr>
+        <p:spPr>
+          <a:xfrm flipV="1">
+            <a:off x="8723427" y="3127011"/>
+            <a:ext cx="1445858" cy="348738"/>
+          </a:xfrm>
+          <a:prstGeom prst="straightConnector1">
+            <a:avLst/>
+          </a:prstGeom>
+          <a:ln>
+            <a:solidFill>
+              <a:srgbClr val="0070C0"/>
+            </a:solidFill>
+            <a:tailEnd type="triangle"/>
+          </a:ln>
+        </p:spPr>
+        <p:style>
+          <a:lnRef idx="1">
+            <a:schemeClr val="accent1"/>
+          </a:lnRef>
+          <a:fillRef idx="0">
+            <a:schemeClr val="accent1"/>
+          </a:fillRef>
+          <a:effectRef idx="0">
+            <a:schemeClr val="accent1"/>
+          </a:effectRef>
+          <a:fontRef idx="minor">
+            <a:schemeClr val="tx1"/>
+          </a:fontRef>
+        </p:style>
+      </p:cxnSp>
+      <p:sp>
+        <p:nvSpPr>
+          <p:cNvPr id="90" name="Flowchart: Process 89">
+            <a:extLst>
+              <a:ext uri="{FF2B5EF4-FFF2-40B4-BE49-F238E27FC236}">
+                <a16:creationId xmlns:a16="http://schemas.microsoft.com/office/drawing/2014/main" id="{8B1EB943-92C4-83D3-FF8E-72A914C1E18F}"/>
+              </a:ext>
+            </a:extLst>
+          </p:cNvPr>
+          <p:cNvSpPr/>
+          <p:nvPr/>
+        </p:nvSpPr>
+        <p:spPr>
+          <a:xfrm>
+            <a:off x="6859116" y="3194688"/>
+            <a:ext cx="1864311" cy="562122"/>
+          </a:xfrm>
+          <a:prstGeom prst="flowChartProcess">
+            <a:avLst/>
+          </a:prstGeom>
+          <a:solidFill>
+            <a:schemeClr val="accent5">
+              <a:lumMod val="60000"/>
+              <a:lumOff val="40000"/>
+            </a:schemeClr>
+          </a:solidFill>
+          <a:ln>
+            <a:noFill/>
+          </a:ln>
+        </p:spPr>
+        <p:style>
+          <a:lnRef idx="2">
+            <a:schemeClr val="accent1">
+              <a:shade val="50000"/>
+            </a:schemeClr>
+          </a:lnRef>
+          <a:fillRef idx="1">
+            <a:schemeClr val="accent1"/>
+          </a:fillRef>
+          <a:effectRef idx="0">
+            <a:schemeClr val="accent1"/>
+          </a:effectRef>
+          <a:fontRef idx="minor">
+            <a:schemeClr val="lt1"/>
+          </a:fontRef>
+        </p:style>
+        <p:txBody>
+          <a:bodyPr rtlCol="0" anchor="ctr"/>
+          <a:lstStyle/>
+          <a:p>
+            <a:pPr algn="ctr"/>
+            <a:r>
+              <a:rPr lang="en-US" sz="1600" dirty="0"/>
+              <a:t>GIC Measure Report</a:t>
+            </a:r>
+          </a:p>
+          <a:p>
+            <a:pPr algn="ctr"/>
+            <a:r>
+              <a:rPr lang="en-US" sz="1000" dirty="0"/>
+              <a:t>Colorectal Cancer Screening</a:t>
+            </a:r>
+          </a:p>
+        </p:txBody>
+      </p:sp>
+      <p:cxnSp>
+        <p:nvCxnSpPr>
+          <p:cNvPr id="144" name="Straight Arrow Connector 143">
+            <a:extLst>
+              <a:ext uri="{FF2B5EF4-FFF2-40B4-BE49-F238E27FC236}">
+                <a16:creationId xmlns:a16="http://schemas.microsoft.com/office/drawing/2014/main" id="{FD0B95BB-0BA8-7C0A-6D24-36C3C5A2B5E4}"/>
+              </a:ext>
+            </a:extLst>
+          </p:cNvPr>
+          <p:cNvCxnSpPr>
+            <a:cxnSpLocks/>
+            <a:stCxn id="5" idx="3"/>
+            <a:endCxn id="7" idx="1"/>
+          </p:cNvCxnSpPr>
+          <p:nvPr/>
+        </p:nvCxnSpPr>
+        <p:spPr>
+          <a:xfrm>
+            <a:off x="2427447" y="2126710"/>
+            <a:ext cx="1521763" cy="861872"/>
+          </a:xfrm>
+          <a:prstGeom prst="straightConnector1">
+            <a:avLst/>
+          </a:prstGeom>
+          <a:ln>
+            <a:solidFill>
+              <a:schemeClr val="tx1"/>
+            </a:solidFill>
+            <a:tailEnd type="triangle"/>
+          </a:ln>
+        </p:spPr>
+        <p:style>
+          <a:lnRef idx="1">
+            <a:schemeClr val="accent1"/>
+          </a:lnRef>
+          <a:fillRef idx="0">
+            <a:schemeClr val="accent1"/>
+          </a:fillRef>
+          <a:effectRef idx="0">
+            <a:schemeClr val="accent1"/>
+          </a:effectRef>
+          <a:fontRef idx="minor">
+            <a:schemeClr val="tx1"/>
+          </a:fontRef>
+        </p:style>
+      </p:cxnSp>
+      <p:cxnSp>
+        <p:nvCxnSpPr>
+          <p:cNvPr id="150" name="Straight Arrow Connector 149">
+            <a:extLst>
+              <a:ext uri="{FF2B5EF4-FFF2-40B4-BE49-F238E27FC236}">
+                <a16:creationId xmlns:a16="http://schemas.microsoft.com/office/drawing/2014/main" id="{E8FDDAE9-9578-120A-C30C-69A4BF375404}"/>
+              </a:ext>
+            </a:extLst>
+          </p:cNvPr>
+          <p:cNvCxnSpPr>
+            <a:cxnSpLocks/>
+            <a:stCxn id="5" idx="3"/>
+          </p:cNvCxnSpPr>
+          <p:nvPr/>
+        </p:nvCxnSpPr>
+        <p:spPr>
+          <a:xfrm flipV="1">
+            <a:off x="2427447" y="2125216"/>
+            <a:ext cx="1521765" cy="1494"/>
+          </a:xfrm>
+          <a:prstGeom prst="straightConnector1">
+            <a:avLst/>
+          </a:prstGeom>
+          <a:ln>
+            <a:solidFill>
+              <a:schemeClr val="tx1"/>
+            </a:solidFill>
+            <a:prstDash val="dash"/>
+            <a:tailEnd type="triangle"/>
+          </a:ln>
+        </p:spPr>
+        <p:style>
+          <a:lnRef idx="1">
+            <a:schemeClr val="accent1"/>
+          </a:lnRef>
+          <a:fillRef idx="0">
+            <a:schemeClr val="accent1"/>
+          </a:fillRef>
+          <a:effectRef idx="0">
+            <a:schemeClr val="accent1"/>
+          </a:effectRef>
+          <a:fontRef idx="minor">
+            <a:schemeClr val="tx1"/>
+          </a:fontRef>
+        </p:style>
+      </p:cxnSp>
+      <p:sp>
+        <p:nvSpPr>
+          <p:cNvPr id="165" name="TextBox 164">
+            <a:extLst>
+              <a:ext uri="{FF2B5EF4-FFF2-40B4-BE49-F238E27FC236}">
+                <a16:creationId xmlns:a16="http://schemas.microsoft.com/office/drawing/2014/main" id="{4363B30E-2A39-36B6-8E8D-D3672B7D3E25}"/>
+              </a:ext>
+            </a:extLst>
+          </p:cNvPr>
+          <p:cNvSpPr txBox="1"/>
+          <p:nvPr/>
+        </p:nvSpPr>
+        <p:spPr>
+          <a:xfrm>
+            <a:off x="3062513" y="2010190"/>
+            <a:ext cx="459578" cy="230832"/>
+          </a:xfrm>
+          <a:prstGeom prst="rect">
+            <a:avLst/>
+          </a:prstGeom>
+          <a:solidFill>
+            <a:schemeClr val="bg1"/>
+          </a:solidFill>
+        </p:spPr>
+        <p:txBody>
+          <a:bodyPr wrap="square" rtlCol="0">
+            <a:spAutoFit/>
+          </a:bodyPr>
+          <a:lstStyle/>
+          <a:p>
+            <a:r>
+              <a:rPr lang="en-US" sz="900" b="1" dirty="0"/>
+              <a:t>entry</a:t>
+            </a:r>
+          </a:p>
+        </p:txBody>
+      </p:sp>
+      <p:cxnSp>
+        <p:nvCxnSpPr>
+          <p:cNvPr id="74" name="Straight Arrow Connector 73">
+            <a:extLst>
+              <a:ext uri="{FF2B5EF4-FFF2-40B4-BE49-F238E27FC236}">
+                <a16:creationId xmlns:a16="http://schemas.microsoft.com/office/drawing/2014/main" id="{408DE87E-DE97-C26A-0F5B-EC9F3AB62F23}"/>
+              </a:ext>
+            </a:extLst>
+          </p:cNvPr>
+          <p:cNvCxnSpPr>
+            <a:cxnSpLocks/>
+            <a:stCxn id="90" idx="3"/>
+            <a:endCxn id="85" idx="1"/>
+          </p:cNvCxnSpPr>
+          <p:nvPr/>
+        </p:nvCxnSpPr>
+        <p:spPr>
+          <a:xfrm flipV="1">
+            <a:off x="8723427" y="2115991"/>
+            <a:ext cx="1445858" cy="1359758"/>
+          </a:xfrm>
+          <a:prstGeom prst="straightConnector1">
+            <a:avLst/>
+          </a:prstGeom>
+          <a:ln>
+            <a:solidFill>
+              <a:srgbClr val="0070C0"/>
+            </a:solidFill>
+            <a:tailEnd type="triangle"/>
+          </a:ln>
+        </p:spPr>
+        <p:style>
+          <a:lnRef idx="1">
+            <a:schemeClr val="accent1"/>
+          </a:lnRef>
+          <a:fillRef idx="0">
+            <a:schemeClr val="accent1"/>
+          </a:fillRef>
+          <a:effectRef idx="0">
+            <a:schemeClr val="accent1"/>
+          </a:effectRef>
+          <a:fontRef idx="minor">
+            <a:schemeClr val="tx1"/>
+          </a:fontRef>
+        </p:style>
+      </p:cxnSp>
+      <p:sp>
+        <p:nvSpPr>
+          <p:cNvPr id="83" name="TextBox 82">
+            <a:extLst>
+              <a:ext uri="{FF2B5EF4-FFF2-40B4-BE49-F238E27FC236}">
+                <a16:creationId xmlns:a16="http://schemas.microsoft.com/office/drawing/2014/main" id="{C6A06D09-4EBF-F68F-C158-6759FC92BBEF}"/>
+              </a:ext>
+            </a:extLst>
+          </p:cNvPr>
+          <p:cNvSpPr txBox="1"/>
+          <p:nvPr/>
+        </p:nvSpPr>
+        <p:spPr>
+          <a:xfrm>
+            <a:off x="3068722" y="2427311"/>
+            <a:ext cx="459578" cy="230832"/>
+          </a:xfrm>
+          <a:prstGeom prst="rect">
+            <a:avLst/>
+          </a:prstGeom>
+          <a:solidFill>
+            <a:schemeClr val="bg1"/>
+          </a:solidFill>
+        </p:spPr>
+        <p:txBody>
+          <a:bodyPr wrap="square" rtlCol="0">
+            <a:spAutoFit/>
+          </a:bodyPr>
+          <a:lstStyle/>
+          <a:p>
+            <a:r>
+              <a:rPr lang="en-US" sz="900" b="1" dirty="0"/>
+              <a:t>entry</a:t>
+            </a:r>
+          </a:p>
+        </p:txBody>
+      </p:sp>
+      <p:sp>
+        <p:nvSpPr>
+          <p:cNvPr id="85" name="Flowchart: Process 84">
+            <a:extLst>
+              <a:ext uri="{FF2B5EF4-FFF2-40B4-BE49-F238E27FC236}">
+                <a16:creationId xmlns:a16="http://schemas.microsoft.com/office/drawing/2014/main" id="{EB4B5463-8FA6-CDA0-A739-CAEFB2F54A70}"/>
+              </a:ext>
+            </a:extLst>
+          </p:cNvPr>
+          <p:cNvSpPr/>
+          <p:nvPr/>
+        </p:nvSpPr>
+        <p:spPr>
+          <a:xfrm>
+            <a:off x="10169285" y="1826344"/>
+            <a:ext cx="1864311" cy="579294"/>
+          </a:xfrm>
+          <a:prstGeom prst="flowChartProcess">
+            <a:avLst/>
+          </a:prstGeom>
+          <a:solidFill>
+            <a:schemeClr val="accent5">
+              <a:lumMod val="60000"/>
+              <a:lumOff val="40000"/>
+            </a:schemeClr>
+          </a:solidFill>
+          <a:ln>
+            <a:noFill/>
+          </a:ln>
+        </p:spPr>
+        <p:style>
+          <a:lnRef idx="2">
+            <a:schemeClr val="accent1">
+              <a:shade val="50000"/>
+            </a:schemeClr>
+          </a:lnRef>
+          <a:fillRef idx="1">
+            <a:schemeClr val="accent1"/>
+          </a:fillRef>
+          <a:effectRef idx="0">
+            <a:schemeClr val="accent1"/>
+          </a:effectRef>
+          <a:fontRef idx="minor">
+            <a:schemeClr val="lt1"/>
+          </a:fontRef>
+        </p:style>
+        <p:txBody>
+          <a:bodyPr rtlCol="0" anchor="ctr"/>
+          <a:lstStyle/>
+          <a:p>
+            <a:pPr algn="ctr"/>
+            <a:r>
+              <a:rPr lang="en-US" sz="1600" dirty="0"/>
+              <a:t>Procedure</a:t>
+            </a:r>
+          </a:p>
+          <a:p>
+            <a:pPr algn="ctr"/>
+            <a:r>
+              <a:rPr lang="en-US" sz="1000" dirty="0"/>
+              <a:t>Colonoscopy</a:t>
+            </a:r>
+          </a:p>
+        </p:txBody>
+      </p:sp>
+      <p:sp>
+        <p:nvSpPr>
+          <p:cNvPr id="92" name="TextBox 91">
+            <a:extLst>
+              <a:ext uri="{FF2B5EF4-FFF2-40B4-BE49-F238E27FC236}">
+                <a16:creationId xmlns:a16="http://schemas.microsoft.com/office/drawing/2014/main" id="{F841A4C1-DED2-8FF2-0414-782E12CEDB81}"/>
+              </a:ext>
+            </a:extLst>
+          </p:cNvPr>
+          <p:cNvSpPr txBox="1"/>
+          <p:nvPr/>
+        </p:nvSpPr>
+        <p:spPr>
+          <a:xfrm>
+            <a:off x="9057024" y="3168833"/>
+            <a:ext cx="1124767" cy="230832"/>
+          </a:xfrm>
+          <a:prstGeom prst="rect">
+            <a:avLst/>
+          </a:prstGeom>
+          <a:solidFill>
+            <a:schemeClr val="bg1"/>
+          </a:solidFill>
+        </p:spPr>
+        <p:txBody>
+          <a:bodyPr wrap="square" rtlCol="0">
+            <a:spAutoFit/>
+          </a:bodyPr>
+          <a:lstStyle/>
+          <a:p>
+            <a:r>
+              <a:rPr lang="en-US" sz="900" b="1" dirty="0">
+                <a:solidFill>
+                  <a:srgbClr val="0070C0"/>
+                </a:solidFill>
+              </a:rPr>
+              <a:t>evaluatedResource</a:t>
+            </a:r>
+          </a:p>
+        </p:txBody>
+      </p:sp>
+      <p:sp>
+        <p:nvSpPr>
+          <p:cNvPr id="93" name="TextBox 92">
+            <a:extLst>
+              <a:ext uri="{FF2B5EF4-FFF2-40B4-BE49-F238E27FC236}">
+                <a16:creationId xmlns:a16="http://schemas.microsoft.com/office/drawing/2014/main" id="{CBCB60AC-79F0-CEF0-A450-133D1A765A6B}"/>
+              </a:ext>
+            </a:extLst>
+          </p:cNvPr>
+          <p:cNvSpPr txBox="1"/>
+          <p:nvPr/>
+        </p:nvSpPr>
+        <p:spPr>
+          <a:xfrm>
+            <a:off x="9019671" y="2515453"/>
+            <a:ext cx="1124767" cy="230832"/>
+          </a:xfrm>
+          <a:prstGeom prst="rect">
+            <a:avLst/>
+          </a:prstGeom>
+          <a:solidFill>
+            <a:schemeClr val="bg1"/>
+          </a:solidFill>
+        </p:spPr>
+        <p:txBody>
+          <a:bodyPr wrap="square" rtlCol="0">
+            <a:spAutoFit/>
+          </a:bodyPr>
+          <a:lstStyle/>
+          <a:p>
+            <a:r>
+              <a:rPr lang="en-US" sz="900" b="1" dirty="0">
+                <a:solidFill>
+                  <a:srgbClr val="0070C0"/>
+                </a:solidFill>
+              </a:rPr>
+              <a:t>evaluatedResource</a:t>
+            </a:r>
+          </a:p>
+        </p:txBody>
+      </p:sp>
+      <p:sp>
+        <p:nvSpPr>
+          <p:cNvPr id="109" name="Flowchart: Process 108">
+            <a:extLst>
+              <a:ext uri="{FF2B5EF4-FFF2-40B4-BE49-F238E27FC236}">
+                <a16:creationId xmlns:a16="http://schemas.microsoft.com/office/drawing/2014/main" id="{3FBFD297-9606-2D25-6BA4-9CF2EF72D551}"/>
+              </a:ext>
+            </a:extLst>
+          </p:cNvPr>
+          <p:cNvSpPr/>
+          <p:nvPr/>
+        </p:nvSpPr>
+        <p:spPr>
+          <a:xfrm>
+            <a:off x="3964192" y="4356428"/>
+            <a:ext cx="1864311" cy="562122"/>
+          </a:xfrm>
+          <a:prstGeom prst="flowChartProcess">
+            <a:avLst/>
+          </a:prstGeom>
+          <a:ln>
+            <a:solidFill>
+              <a:schemeClr val="tx1"/>
+            </a:solidFill>
+          </a:ln>
+        </p:spPr>
+        <p:style>
+          <a:lnRef idx="2">
+            <a:schemeClr val="accent1">
+              <a:shade val="50000"/>
+            </a:schemeClr>
+          </a:lnRef>
+          <a:fillRef idx="1">
+            <a:schemeClr val="accent1"/>
+          </a:fillRef>
+          <a:effectRef idx="0">
+            <a:schemeClr val="accent1"/>
+          </a:effectRef>
+          <a:fontRef idx="minor">
+            <a:schemeClr val="lt1"/>
+          </a:fontRef>
+        </p:style>
+        <p:txBody>
+          <a:bodyPr rtlCol="0" anchor="ctr"/>
+          <a:lstStyle/>
+          <a:p>
+            <a:pPr algn="ctr"/>
+            <a:r>
+              <a:rPr lang="en-US" sz="1600" dirty="0"/>
+              <a:t>GIC Detected Issue</a:t>
+            </a:r>
+          </a:p>
+        </p:txBody>
+      </p:sp>
+      <p:cxnSp>
+        <p:nvCxnSpPr>
+          <p:cNvPr id="110" name="Straight Arrow Connector 109">
+            <a:extLst>
+              <a:ext uri="{FF2B5EF4-FFF2-40B4-BE49-F238E27FC236}">
+                <a16:creationId xmlns:a16="http://schemas.microsoft.com/office/drawing/2014/main" id="{A71AA692-4984-217A-2B35-92BA8056F4F2}"/>
+              </a:ext>
+            </a:extLst>
+          </p:cNvPr>
+          <p:cNvCxnSpPr>
+            <a:cxnSpLocks/>
+            <a:endCxn id="90" idx="1"/>
+          </p:cNvCxnSpPr>
+          <p:nvPr/>
+        </p:nvCxnSpPr>
+        <p:spPr>
+          <a:xfrm>
+            <a:off x="5813523" y="2125216"/>
+            <a:ext cx="1045593" cy="1350533"/>
+          </a:xfrm>
+          <a:prstGeom prst="straightConnector1">
+            <a:avLst/>
+          </a:prstGeom>
+          <a:ln w="9525">
+            <a:solidFill>
+              <a:srgbClr val="0070C0"/>
+            </a:solidFill>
+            <a:tailEnd type="triangle"/>
+          </a:ln>
+        </p:spPr>
+        <p:style>
+          <a:lnRef idx="1">
+            <a:schemeClr val="accent1"/>
+          </a:lnRef>
+          <a:fillRef idx="0">
+            <a:schemeClr val="accent1"/>
+          </a:fillRef>
+          <a:effectRef idx="0">
+            <a:schemeClr val="accent1"/>
+          </a:effectRef>
+          <a:fontRef idx="minor">
+            <a:schemeClr val="tx1"/>
+          </a:fontRef>
+        </p:style>
+      </p:cxnSp>
+      <p:cxnSp>
+        <p:nvCxnSpPr>
+          <p:cNvPr id="111" name="Straight Arrow Connector 110">
+            <a:extLst>
+              <a:ext uri="{FF2B5EF4-FFF2-40B4-BE49-F238E27FC236}">
+                <a16:creationId xmlns:a16="http://schemas.microsoft.com/office/drawing/2014/main" id="{C27122A1-7723-71BB-3EE9-81BD503758D6}"/>
+              </a:ext>
+            </a:extLst>
+          </p:cNvPr>
+          <p:cNvCxnSpPr>
+            <a:cxnSpLocks/>
+            <a:stCxn id="5" idx="3"/>
+            <a:endCxn id="13" idx="1"/>
+          </p:cNvCxnSpPr>
+          <p:nvPr/>
+        </p:nvCxnSpPr>
+        <p:spPr>
+          <a:xfrm>
+            <a:off x="2427447" y="2126710"/>
+            <a:ext cx="1521762" cy="1671798"/>
+          </a:xfrm>
+          <a:prstGeom prst="straightConnector1">
+            <a:avLst/>
+          </a:prstGeom>
+          <a:ln>
+            <a:solidFill>
+              <a:schemeClr val="tx1"/>
+            </a:solidFill>
+            <a:tailEnd type="triangle"/>
+          </a:ln>
+        </p:spPr>
+        <p:style>
+          <a:lnRef idx="1">
+            <a:schemeClr val="accent1"/>
+          </a:lnRef>
+          <a:fillRef idx="0">
+            <a:schemeClr val="accent1"/>
+          </a:fillRef>
+          <a:effectRef idx="0">
+            <a:schemeClr val="accent1"/>
+          </a:effectRef>
+          <a:fontRef idx="minor">
+            <a:schemeClr val="tx1"/>
+          </a:fontRef>
+        </p:style>
+      </p:cxnSp>
+      <p:cxnSp>
+        <p:nvCxnSpPr>
+          <p:cNvPr id="114" name="Straight Arrow Connector 113">
+            <a:extLst>
+              <a:ext uri="{FF2B5EF4-FFF2-40B4-BE49-F238E27FC236}">
+                <a16:creationId xmlns:a16="http://schemas.microsoft.com/office/drawing/2014/main" id="{F93FDB6B-69B1-44BD-728D-DF680B22757C}"/>
+              </a:ext>
+            </a:extLst>
+          </p:cNvPr>
+          <p:cNvCxnSpPr>
+            <a:cxnSpLocks/>
+            <a:stCxn id="5" idx="3"/>
+            <a:endCxn id="109" idx="1"/>
+          </p:cNvCxnSpPr>
+          <p:nvPr/>
+        </p:nvCxnSpPr>
+        <p:spPr>
+          <a:xfrm>
+            <a:off x="2427447" y="2126710"/>
+            <a:ext cx="1536745" cy="2510779"/>
+          </a:xfrm>
+          <a:prstGeom prst="straightConnector1">
+            <a:avLst/>
+          </a:prstGeom>
+          <a:ln>
+            <a:solidFill>
+              <a:schemeClr val="tx1"/>
+            </a:solidFill>
+            <a:tailEnd type="triangle"/>
+          </a:ln>
+        </p:spPr>
+        <p:style>
+          <a:lnRef idx="1">
+            <a:schemeClr val="accent1"/>
+          </a:lnRef>
+          <a:fillRef idx="0">
+            <a:schemeClr val="accent1"/>
+          </a:fillRef>
+          <a:effectRef idx="0">
+            <a:schemeClr val="accent1"/>
+          </a:effectRef>
+          <a:fontRef idx="minor">
+            <a:schemeClr val="tx1"/>
+          </a:fontRef>
+        </p:style>
+      </p:cxnSp>
+      <p:sp>
+        <p:nvSpPr>
+          <p:cNvPr id="122" name="TextBox 121">
+            <a:extLst>
+              <a:ext uri="{FF2B5EF4-FFF2-40B4-BE49-F238E27FC236}">
+                <a16:creationId xmlns:a16="http://schemas.microsoft.com/office/drawing/2014/main" id="{E8A87B7E-E451-19D8-C479-6D12AEFF86BB}"/>
+              </a:ext>
+            </a:extLst>
+          </p:cNvPr>
+          <p:cNvSpPr txBox="1"/>
+          <p:nvPr/>
+        </p:nvSpPr>
+        <p:spPr>
+          <a:xfrm>
+            <a:off x="3054225" y="2769787"/>
+            <a:ext cx="459578" cy="230832"/>
+          </a:xfrm>
+          <a:prstGeom prst="rect">
+            <a:avLst/>
+          </a:prstGeom>
+          <a:solidFill>
+            <a:schemeClr val="bg1"/>
+          </a:solidFill>
+        </p:spPr>
+        <p:txBody>
+          <a:bodyPr wrap="square" rtlCol="0">
+            <a:spAutoFit/>
+          </a:bodyPr>
+          <a:lstStyle/>
+          <a:p>
+            <a:r>
+              <a:rPr lang="en-US" sz="900" b="1" dirty="0"/>
+              <a:t>entry</a:t>
+            </a:r>
+          </a:p>
+        </p:txBody>
+      </p:sp>
+      <p:sp>
+        <p:nvSpPr>
+          <p:cNvPr id="123" name="TextBox 122">
+            <a:extLst>
+              <a:ext uri="{FF2B5EF4-FFF2-40B4-BE49-F238E27FC236}">
+                <a16:creationId xmlns:a16="http://schemas.microsoft.com/office/drawing/2014/main" id="{46B6C959-DB0E-3405-7EC8-2E388D764CBD}"/>
+              </a:ext>
+            </a:extLst>
+          </p:cNvPr>
+          <p:cNvSpPr txBox="1"/>
+          <p:nvPr/>
+        </p:nvSpPr>
+        <p:spPr>
+          <a:xfrm>
+            <a:off x="3299449" y="3681785"/>
+            <a:ext cx="459578" cy="230832"/>
+          </a:xfrm>
+          <a:prstGeom prst="rect">
+            <a:avLst/>
+          </a:prstGeom>
+          <a:solidFill>
+            <a:schemeClr val="bg1"/>
+          </a:solidFill>
+        </p:spPr>
+        <p:txBody>
+          <a:bodyPr wrap="square" rtlCol="0">
+            <a:spAutoFit/>
+          </a:bodyPr>
+          <a:lstStyle/>
+          <a:p>
+            <a:r>
+              <a:rPr lang="en-US" sz="900" b="1" dirty="0"/>
+              <a:t>entry</a:t>
+            </a:r>
+          </a:p>
+        </p:txBody>
+      </p:sp>
+      <p:cxnSp>
+        <p:nvCxnSpPr>
+          <p:cNvPr id="124" name="Straight Arrow Connector 123">
+            <a:extLst>
+              <a:ext uri="{FF2B5EF4-FFF2-40B4-BE49-F238E27FC236}">
+                <a16:creationId xmlns:a16="http://schemas.microsoft.com/office/drawing/2014/main" id="{9192B48F-64A2-6CED-B0CC-06DCD8467A9B}"/>
+              </a:ext>
+            </a:extLst>
+          </p:cNvPr>
+          <p:cNvCxnSpPr>
+            <a:cxnSpLocks/>
+            <a:stCxn id="5" idx="2"/>
+            <a:endCxn id="217" idx="0"/>
+          </p:cNvCxnSpPr>
+          <p:nvPr/>
+        </p:nvCxnSpPr>
+        <p:spPr>
+          <a:xfrm>
+            <a:off x="1495292" y="2432425"/>
+            <a:ext cx="632895" cy="1989514"/>
+          </a:xfrm>
+          <a:prstGeom prst="straightConnector1">
+            <a:avLst/>
+          </a:prstGeom>
+          <a:ln>
+            <a:solidFill>
+              <a:schemeClr val="tx1"/>
+            </a:solidFill>
+            <a:tailEnd type="triangle"/>
+          </a:ln>
+        </p:spPr>
+        <p:style>
+          <a:lnRef idx="1">
+            <a:schemeClr val="accent1"/>
+          </a:lnRef>
+          <a:fillRef idx="0">
+            <a:schemeClr val="accent1"/>
+          </a:fillRef>
+          <a:effectRef idx="0">
+            <a:schemeClr val="accent1"/>
+          </a:effectRef>
+          <a:fontRef idx="minor">
+            <a:schemeClr val="tx1"/>
+          </a:fontRef>
+        </p:style>
+      </p:cxnSp>
+      <p:cxnSp>
+        <p:nvCxnSpPr>
+          <p:cNvPr id="127" name="Straight Arrow Connector 126">
+            <a:extLst>
+              <a:ext uri="{FF2B5EF4-FFF2-40B4-BE49-F238E27FC236}">
+                <a16:creationId xmlns:a16="http://schemas.microsoft.com/office/drawing/2014/main" id="{A48B7723-E241-E5A4-A65E-8BF83C1D9258}"/>
+              </a:ext>
+            </a:extLst>
+          </p:cNvPr>
+          <p:cNvCxnSpPr>
+            <a:cxnSpLocks/>
+            <a:stCxn id="5" idx="2"/>
+            <a:endCxn id="216" idx="0"/>
+          </p:cNvCxnSpPr>
+          <p:nvPr/>
+        </p:nvCxnSpPr>
+        <p:spPr>
+          <a:xfrm>
+            <a:off x="1495292" y="2432425"/>
+            <a:ext cx="5975" cy="1173909"/>
+          </a:xfrm>
+          <a:prstGeom prst="straightConnector1">
+            <a:avLst/>
+          </a:prstGeom>
+          <a:ln>
+            <a:solidFill>
+              <a:schemeClr val="tx1"/>
+            </a:solidFill>
+            <a:tailEnd type="triangle"/>
+          </a:ln>
+        </p:spPr>
+        <p:style>
+          <a:lnRef idx="1">
+            <a:schemeClr val="accent1"/>
+          </a:lnRef>
+          <a:fillRef idx="0">
+            <a:schemeClr val="accent1"/>
+          </a:fillRef>
+          <a:effectRef idx="0">
+            <a:schemeClr val="accent1"/>
+          </a:effectRef>
+          <a:fontRef idx="minor">
+            <a:schemeClr val="tx1"/>
+          </a:fontRef>
+        </p:style>
+      </p:cxnSp>
+      <p:sp>
+        <p:nvSpPr>
+          <p:cNvPr id="134" name="Flowchart: Process 133">
+            <a:extLst>
+              <a:ext uri="{FF2B5EF4-FFF2-40B4-BE49-F238E27FC236}">
+                <a16:creationId xmlns:a16="http://schemas.microsoft.com/office/drawing/2014/main" id="{B285BB8B-D0EE-0FC7-8D38-5AE2849BD4A3}"/>
+              </a:ext>
+            </a:extLst>
+          </p:cNvPr>
+          <p:cNvSpPr/>
+          <p:nvPr/>
+        </p:nvSpPr>
+        <p:spPr>
+          <a:xfrm>
+            <a:off x="6859116" y="4588897"/>
+            <a:ext cx="1864311" cy="562122"/>
+          </a:xfrm>
+          <a:prstGeom prst="flowChartProcess">
+            <a:avLst/>
+          </a:prstGeom>
+          <a:solidFill>
+            <a:schemeClr val="accent5">
+              <a:lumMod val="60000"/>
+              <a:lumOff val="40000"/>
+            </a:schemeClr>
+          </a:solidFill>
+          <a:ln>
+            <a:noFill/>
+          </a:ln>
+        </p:spPr>
+        <p:style>
+          <a:lnRef idx="2">
+            <a:schemeClr val="accent1">
+              <a:shade val="50000"/>
+            </a:schemeClr>
+          </a:lnRef>
+          <a:fillRef idx="1">
+            <a:schemeClr val="accent1"/>
+          </a:fillRef>
+          <a:effectRef idx="0">
+            <a:schemeClr val="accent1"/>
+          </a:effectRef>
+          <a:fontRef idx="minor">
+            <a:schemeClr val="lt1"/>
+          </a:fontRef>
+        </p:style>
+        <p:txBody>
+          <a:bodyPr rtlCol="0" anchor="ctr"/>
+          <a:lstStyle/>
+          <a:p>
+            <a:pPr algn="ctr"/>
+            <a:r>
+              <a:rPr lang="en-US" sz="1600" dirty="0"/>
+              <a:t>GIC Detected Issue</a:t>
+            </a:r>
+          </a:p>
+        </p:txBody>
+      </p:sp>
+      <p:cxnSp>
+        <p:nvCxnSpPr>
+          <p:cNvPr id="164" name="Straight Arrow Connector 163">
+            <a:extLst>
+              <a:ext uri="{FF2B5EF4-FFF2-40B4-BE49-F238E27FC236}">
+                <a16:creationId xmlns:a16="http://schemas.microsoft.com/office/drawing/2014/main" id="{C69064EB-6226-9CA1-BCA8-38EEB5DCE9E9}"/>
+              </a:ext>
+            </a:extLst>
+          </p:cNvPr>
+          <p:cNvCxnSpPr>
+            <a:cxnSpLocks/>
+            <a:endCxn id="134" idx="1"/>
+          </p:cNvCxnSpPr>
+          <p:nvPr/>
+        </p:nvCxnSpPr>
+        <p:spPr>
+          <a:xfrm>
+            <a:off x="5813523" y="2125216"/>
+            <a:ext cx="1045593" cy="2744742"/>
+          </a:xfrm>
+          <a:prstGeom prst="straightConnector1">
+            <a:avLst/>
+          </a:prstGeom>
+          <a:ln w="9525">
+            <a:solidFill>
+              <a:srgbClr val="0070C0"/>
+            </a:solidFill>
+            <a:tailEnd type="triangle"/>
+          </a:ln>
+        </p:spPr>
+        <p:style>
+          <a:lnRef idx="1">
+            <a:schemeClr val="accent1"/>
+          </a:lnRef>
+          <a:fillRef idx="0">
+            <a:schemeClr val="accent1"/>
+          </a:fillRef>
+          <a:effectRef idx="0">
+            <a:schemeClr val="accent1"/>
+          </a:effectRef>
+          <a:fontRef idx="minor">
+            <a:schemeClr val="tx1"/>
+          </a:fontRef>
+        </p:style>
+      </p:cxnSp>
+      <p:sp>
+        <p:nvSpPr>
+          <p:cNvPr id="166" name="TextBox 165">
+            <a:extLst>
+              <a:ext uri="{FF2B5EF4-FFF2-40B4-BE49-F238E27FC236}">
+                <a16:creationId xmlns:a16="http://schemas.microsoft.com/office/drawing/2014/main" id="{2F348932-B465-88B6-FDC1-E02054483C76}"/>
+              </a:ext>
+            </a:extLst>
+          </p:cNvPr>
+          <p:cNvSpPr txBox="1"/>
+          <p:nvPr/>
+        </p:nvSpPr>
+        <p:spPr>
+          <a:xfrm>
+            <a:off x="6139654" y="2756779"/>
+            <a:ext cx="900006" cy="230832"/>
+          </a:xfrm>
+          <a:prstGeom prst="rect">
+            <a:avLst/>
+          </a:prstGeom>
+          <a:solidFill>
+            <a:schemeClr val="bg1"/>
+          </a:solidFill>
+        </p:spPr>
+        <p:txBody>
+          <a:bodyPr wrap="square" rtlCol="0">
+            <a:spAutoFit/>
+          </a:bodyPr>
+          <a:lstStyle/>
+          <a:p>
+            <a:r>
+              <a:rPr lang="en-US" sz="900" b="1" dirty="0">
+                <a:solidFill>
+                  <a:srgbClr val="0070C0"/>
+                </a:solidFill>
+              </a:rPr>
+              <a:t>section.entry</a:t>
+            </a:r>
+          </a:p>
+        </p:txBody>
+      </p:sp>
+      <p:sp>
+        <p:nvSpPr>
+          <p:cNvPr id="167" name="TextBox 166">
+            <a:extLst>
+              <a:ext uri="{FF2B5EF4-FFF2-40B4-BE49-F238E27FC236}">
+                <a16:creationId xmlns:a16="http://schemas.microsoft.com/office/drawing/2014/main" id="{3BE936EF-B293-993E-DFB1-13304ECFC054}"/>
+              </a:ext>
+            </a:extLst>
+          </p:cNvPr>
+          <p:cNvSpPr txBox="1"/>
+          <p:nvPr/>
+        </p:nvSpPr>
+        <p:spPr>
+          <a:xfrm>
+            <a:off x="6136876" y="3986625"/>
+            <a:ext cx="814938" cy="230832"/>
+          </a:xfrm>
+          <a:prstGeom prst="rect">
+            <a:avLst/>
+          </a:prstGeom>
+          <a:solidFill>
+            <a:schemeClr val="bg1"/>
+          </a:solidFill>
+        </p:spPr>
+        <p:txBody>
+          <a:bodyPr wrap="square" rtlCol="0">
+            <a:spAutoFit/>
+          </a:bodyPr>
+          <a:lstStyle/>
+          <a:p>
+            <a:r>
+              <a:rPr lang="en-US" sz="900" b="1" dirty="0">
+                <a:solidFill>
+                  <a:srgbClr val="0070C0"/>
+                </a:solidFill>
+              </a:rPr>
+              <a:t>section.focus</a:t>
+            </a:r>
+          </a:p>
+        </p:txBody>
+      </p:sp>
+      <p:sp>
+        <p:nvSpPr>
+          <p:cNvPr id="180" name="Flowchart: Process 179">
+            <a:extLst>
+              <a:ext uri="{FF2B5EF4-FFF2-40B4-BE49-F238E27FC236}">
+                <a16:creationId xmlns:a16="http://schemas.microsoft.com/office/drawing/2014/main" id="{916B94D6-857D-C423-8782-4577E2F8B689}"/>
+              </a:ext>
+            </a:extLst>
+          </p:cNvPr>
+          <p:cNvSpPr/>
+          <p:nvPr/>
+        </p:nvSpPr>
+        <p:spPr>
+          <a:xfrm>
+            <a:off x="6859116" y="1848234"/>
+            <a:ext cx="1864311" cy="562122"/>
+          </a:xfrm>
+          <a:prstGeom prst="flowChartProcess">
+            <a:avLst/>
+          </a:prstGeom>
+          <a:solidFill>
+            <a:schemeClr val="accent5">
+              <a:lumMod val="60000"/>
+              <a:lumOff val="40000"/>
+            </a:schemeClr>
+          </a:solidFill>
+          <a:ln>
+            <a:noFill/>
+          </a:ln>
+        </p:spPr>
+        <p:style>
+          <a:lnRef idx="2">
+            <a:schemeClr val="accent1">
+              <a:shade val="50000"/>
+            </a:schemeClr>
+          </a:lnRef>
+          <a:fillRef idx="1">
+            <a:schemeClr val="accent1"/>
+          </a:fillRef>
+          <a:effectRef idx="0">
+            <a:schemeClr val="accent1"/>
+          </a:effectRef>
+          <a:fontRef idx="minor">
+            <a:schemeClr val="lt1"/>
+          </a:fontRef>
+        </p:style>
+        <p:txBody>
+          <a:bodyPr rtlCol="0" anchor="ctr"/>
+          <a:lstStyle/>
+          <a:p>
+            <a:pPr algn="ctr"/>
+            <a:r>
+              <a:rPr lang="en-US" sz="1600" dirty="0"/>
+              <a:t>Patient</a:t>
+            </a:r>
+          </a:p>
+        </p:txBody>
+      </p:sp>
+      <p:cxnSp>
+        <p:nvCxnSpPr>
+          <p:cNvPr id="181" name="Straight Arrow Connector 180">
+            <a:extLst>
+              <a:ext uri="{FF2B5EF4-FFF2-40B4-BE49-F238E27FC236}">
+                <a16:creationId xmlns:a16="http://schemas.microsoft.com/office/drawing/2014/main" id="{3EC97E9D-26FE-A786-D1FB-B852CE5EFFC9}"/>
+              </a:ext>
+            </a:extLst>
+          </p:cNvPr>
+          <p:cNvCxnSpPr>
+            <a:cxnSpLocks/>
+            <a:endCxn id="180" idx="1"/>
+          </p:cNvCxnSpPr>
+          <p:nvPr/>
+        </p:nvCxnSpPr>
+        <p:spPr>
+          <a:xfrm>
+            <a:off x="5813523" y="2125216"/>
+            <a:ext cx="1045593" cy="4079"/>
+          </a:xfrm>
+          <a:prstGeom prst="straightConnector1">
+            <a:avLst/>
+          </a:prstGeom>
+          <a:ln w="9525">
+            <a:solidFill>
+              <a:srgbClr val="0070C0"/>
+            </a:solidFill>
+            <a:tailEnd type="triangle"/>
+          </a:ln>
+        </p:spPr>
+        <p:style>
+          <a:lnRef idx="1">
+            <a:schemeClr val="accent1"/>
+          </a:lnRef>
+          <a:fillRef idx="0">
+            <a:schemeClr val="accent1"/>
+          </a:fillRef>
+          <a:effectRef idx="0">
+            <a:schemeClr val="accent1"/>
+          </a:effectRef>
+          <a:fontRef idx="minor">
+            <a:schemeClr val="tx1"/>
+          </a:fontRef>
+        </p:style>
+      </p:cxnSp>
+      <p:sp>
+        <p:nvSpPr>
+          <p:cNvPr id="182" name="TextBox 181">
+            <a:extLst>
+              <a:ext uri="{FF2B5EF4-FFF2-40B4-BE49-F238E27FC236}">
+                <a16:creationId xmlns:a16="http://schemas.microsoft.com/office/drawing/2014/main" id="{E7E638E0-F5F4-226A-D48F-BC388C6C61EE}"/>
+              </a:ext>
+            </a:extLst>
+          </p:cNvPr>
+          <p:cNvSpPr txBox="1"/>
+          <p:nvPr/>
+        </p:nvSpPr>
+        <p:spPr>
+          <a:xfrm>
+            <a:off x="6090625" y="2010190"/>
+            <a:ext cx="633829" cy="230832"/>
+          </a:xfrm>
+          <a:prstGeom prst="rect">
+            <a:avLst/>
+          </a:prstGeom>
+          <a:solidFill>
+            <a:schemeClr val="bg1"/>
+          </a:solidFill>
+        </p:spPr>
+        <p:txBody>
+          <a:bodyPr wrap="square" rtlCol="0">
+            <a:spAutoFit/>
+          </a:bodyPr>
+          <a:lstStyle/>
+          <a:p>
+            <a:r>
+              <a:rPr lang="en-US" sz="900" b="1" dirty="0">
+                <a:solidFill>
+                  <a:srgbClr val="0070C0"/>
+                </a:solidFill>
+              </a:rPr>
+              <a:t>subject</a:t>
+            </a:r>
+          </a:p>
+        </p:txBody>
+      </p:sp>
+      <p:sp>
+        <p:nvSpPr>
+          <p:cNvPr id="183" name="Flowchart: Process 182">
+            <a:extLst>
+              <a:ext uri="{FF2B5EF4-FFF2-40B4-BE49-F238E27FC236}">
+                <a16:creationId xmlns:a16="http://schemas.microsoft.com/office/drawing/2014/main" id="{C7E7B304-6EC3-695A-6CE8-55882D29D690}"/>
+              </a:ext>
+            </a:extLst>
+          </p:cNvPr>
+          <p:cNvSpPr/>
+          <p:nvPr/>
+        </p:nvSpPr>
+        <p:spPr>
+          <a:xfrm>
+            <a:off x="10169285" y="3797201"/>
+            <a:ext cx="1864310" cy="555676"/>
+          </a:xfrm>
+          <a:prstGeom prst="flowChartProcess">
+            <a:avLst/>
+          </a:prstGeom>
+          <a:solidFill>
+            <a:schemeClr val="accent5">
+              <a:lumMod val="60000"/>
+              <a:lumOff val="40000"/>
+            </a:schemeClr>
+          </a:solidFill>
+          <a:ln>
+            <a:noFill/>
+          </a:ln>
+        </p:spPr>
+        <p:style>
+          <a:lnRef idx="2">
+            <a:schemeClr val="accent1">
+              <a:shade val="50000"/>
+            </a:schemeClr>
+          </a:lnRef>
+          <a:fillRef idx="1">
+            <a:schemeClr val="accent1"/>
+          </a:fillRef>
+          <a:effectRef idx="0">
+            <a:schemeClr val="accent1"/>
+          </a:effectRef>
+          <a:fontRef idx="minor">
+            <a:schemeClr val="lt1"/>
+          </a:fontRef>
+        </p:style>
+        <p:txBody>
+          <a:bodyPr rtlCol="0" anchor="ctr"/>
+          <a:lstStyle/>
+          <a:p>
+            <a:pPr algn="ctr"/>
+            <a:r>
+              <a:rPr lang="en-US" sz="1600" dirty="0"/>
+              <a:t>Organization</a:t>
+            </a:r>
+            <a:endParaRPr lang="en-US" sz="1000" dirty="0"/>
+          </a:p>
+        </p:txBody>
+      </p:sp>
+      <p:cxnSp>
+        <p:nvCxnSpPr>
+          <p:cNvPr id="184" name="Straight Arrow Connector 183">
+            <a:extLst>
+              <a:ext uri="{FF2B5EF4-FFF2-40B4-BE49-F238E27FC236}">
+                <a16:creationId xmlns:a16="http://schemas.microsoft.com/office/drawing/2014/main" id="{CDFE09B4-1B4F-1261-B898-6DBC5AA54D7E}"/>
+              </a:ext>
+            </a:extLst>
+          </p:cNvPr>
+          <p:cNvCxnSpPr>
+            <a:cxnSpLocks/>
+            <a:stCxn id="90" idx="3"/>
+            <a:endCxn id="183" idx="1"/>
+          </p:cNvCxnSpPr>
+          <p:nvPr/>
+        </p:nvCxnSpPr>
+        <p:spPr>
+          <a:xfrm>
+            <a:off x="8723427" y="3475749"/>
+            <a:ext cx="1445858" cy="599290"/>
+          </a:xfrm>
+          <a:prstGeom prst="straightConnector1">
+            <a:avLst/>
+          </a:prstGeom>
+          <a:ln>
+            <a:solidFill>
+              <a:srgbClr val="0070C0"/>
+            </a:solidFill>
+            <a:tailEnd type="triangle"/>
+          </a:ln>
+        </p:spPr>
+        <p:style>
+          <a:lnRef idx="1">
+            <a:schemeClr val="accent1"/>
+          </a:lnRef>
+          <a:fillRef idx="0">
+            <a:schemeClr val="accent1"/>
+          </a:fillRef>
+          <a:effectRef idx="0">
+            <a:schemeClr val="accent1"/>
+          </a:effectRef>
+          <a:fontRef idx="minor">
+            <a:schemeClr val="tx1"/>
+          </a:fontRef>
+        </p:style>
+      </p:cxnSp>
+      <p:sp>
+        <p:nvSpPr>
+          <p:cNvPr id="185" name="TextBox 184">
+            <a:extLst>
+              <a:ext uri="{FF2B5EF4-FFF2-40B4-BE49-F238E27FC236}">
+                <a16:creationId xmlns:a16="http://schemas.microsoft.com/office/drawing/2014/main" id="{538BEEBE-E20D-0C6A-7F06-ECF5BDE2FC2D}"/>
+              </a:ext>
+            </a:extLst>
+          </p:cNvPr>
+          <p:cNvSpPr txBox="1"/>
+          <p:nvPr/>
+        </p:nvSpPr>
+        <p:spPr>
+          <a:xfrm>
+            <a:off x="9123125" y="3682575"/>
+            <a:ext cx="737102" cy="230832"/>
+          </a:xfrm>
+          <a:prstGeom prst="rect">
+            <a:avLst/>
+          </a:prstGeom>
+          <a:solidFill>
+            <a:schemeClr val="bg1"/>
+          </a:solidFill>
+        </p:spPr>
+        <p:txBody>
+          <a:bodyPr wrap="square" rtlCol="0">
+            <a:spAutoFit/>
+          </a:bodyPr>
+          <a:lstStyle/>
+          <a:p>
+            <a:r>
+              <a:rPr lang="en-US" sz="900" b="1" dirty="0">
+                <a:solidFill>
+                  <a:srgbClr val="0070C0"/>
+                </a:solidFill>
+              </a:rPr>
+              <a:t>reporter</a:t>
+            </a:r>
+          </a:p>
+        </p:txBody>
+      </p:sp>
+      <p:sp>
+        <p:nvSpPr>
+          <p:cNvPr id="186" name="TextBox 185">
+            <a:extLst>
+              <a:ext uri="{FF2B5EF4-FFF2-40B4-BE49-F238E27FC236}">
+                <a16:creationId xmlns:a16="http://schemas.microsoft.com/office/drawing/2014/main" id="{DDA0B69F-B9EB-4269-C8DC-7B1A1B4E92A9}"/>
+              </a:ext>
+            </a:extLst>
+          </p:cNvPr>
+          <p:cNvSpPr txBox="1"/>
+          <p:nvPr/>
+        </p:nvSpPr>
+        <p:spPr>
+          <a:xfrm>
+            <a:off x="1516554" y="3209857"/>
+            <a:ext cx="459578" cy="230832"/>
+          </a:xfrm>
+          <a:prstGeom prst="rect">
+            <a:avLst/>
+          </a:prstGeom>
+          <a:solidFill>
+            <a:schemeClr val="bg1"/>
+          </a:solidFill>
+        </p:spPr>
+        <p:txBody>
+          <a:bodyPr wrap="square" rtlCol="0">
+            <a:spAutoFit/>
+          </a:bodyPr>
+          <a:lstStyle/>
+          <a:p>
+            <a:r>
+              <a:rPr lang="en-US" sz="900" b="1" dirty="0"/>
+              <a:t>entry</a:t>
+            </a:r>
+          </a:p>
+        </p:txBody>
+      </p:sp>
+      <p:sp>
+        <p:nvSpPr>
+          <p:cNvPr id="187" name="TextBox 186">
+            <a:extLst>
+              <a:ext uri="{FF2B5EF4-FFF2-40B4-BE49-F238E27FC236}">
+                <a16:creationId xmlns:a16="http://schemas.microsoft.com/office/drawing/2014/main" id="{AA7B40CD-768F-518F-DB94-8914434AB873}"/>
+              </a:ext>
+            </a:extLst>
+          </p:cNvPr>
+          <p:cNvSpPr txBox="1"/>
+          <p:nvPr/>
+        </p:nvSpPr>
+        <p:spPr>
+          <a:xfrm>
+            <a:off x="1204549" y="2969018"/>
+            <a:ext cx="459578" cy="230832"/>
+          </a:xfrm>
+          <a:prstGeom prst="rect">
+            <a:avLst/>
+          </a:prstGeom>
+          <a:solidFill>
+            <a:schemeClr val="bg1"/>
+          </a:solidFill>
+        </p:spPr>
+        <p:txBody>
+          <a:bodyPr wrap="square" rtlCol="0">
+            <a:spAutoFit/>
+          </a:bodyPr>
+          <a:lstStyle/>
+          <a:p>
+            <a:r>
+              <a:rPr lang="en-US" sz="900" b="1" dirty="0"/>
+              <a:t>entry</a:t>
+            </a:r>
+          </a:p>
+        </p:txBody>
+      </p:sp>
+      <p:sp>
+        <p:nvSpPr>
+          <p:cNvPr id="188" name="Flowchart: Process 187">
+            <a:extLst>
+              <a:ext uri="{FF2B5EF4-FFF2-40B4-BE49-F238E27FC236}">
+                <a16:creationId xmlns:a16="http://schemas.microsoft.com/office/drawing/2014/main" id="{E4FB34CA-D210-C46A-F4A9-C86FA6099F0A}"/>
+              </a:ext>
+            </a:extLst>
+          </p:cNvPr>
+          <p:cNvSpPr/>
+          <p:nvPr/>
+        </p:nvSpPr>
+        <p:spPr>
+          <a:xfrm>
+            <a:off x="10190760" y="4703000"/>
+            <a:ext cx="1864310" cy="555676"/>
+          </a:xfrm>
+          <a:prstGeom prst="flowChartProcess">
+            <a:avLst/>
+          </a:prstGeom>
+          <a:solidFill>
+            <a:schemeClr val="accent5">
+              <a:lumMod val="60000"/>
+              <a:lumOff val="40000"/>
+            </a:schemeClr>
+          </a:solidFill>
+          <a:ln>
+            <a:noFill/>
+          </a:ln>
+        </p:spPr>
+        <p:style>
+          <a:lnRef idx="2">
+            <a:schemeClr val="accent1">
+              <a:shade val="50000"/>
+            </a:schemeClr>
+          </a:lnRef>
+          <a:fillRef idx="1">
+            <a:schemeClr val="accent1"/>
+          </a:fillRef>
+          <a:effectRef idx="0">
+            <a:schemeClr val="accent1"/>
+          </a:effectRef>
+          <a:fontRef idx="minor">
+            <a:schemeClr val="lt1"/>
+          </a:fontRef>
+        </p:style>
+        <p:txBody>
+          <a:bodyPr rtlCol="0" anchor="ctr"/>
+          <a:lstStyle/>
+          <a:p>
+            <a:pPr algn="ctr"/>
+            <a:r>
+              <a:rPr lang="en-US" sz="1600" dirty="0"/>
+              <a:t>Guidance Response</a:t>
+            </a:r>
+            <a:endParaRPr lang="en-US" sz="1000" dirty="0"/>
+          </a:p>
+        </p:txBody>
+      </p:sp>
+      <p:cxnSp>
+        <p:nvCxnSpPr>
+          <p:cNvPr id="189" name="Straight Arrow Connector 188">
+            <a:extLst>
+              <a:ext uri="{FF2B5EF4-FFF2-40B4-BE49-F238E27FC236}">
+                <a16:creationId xmlns:a16="http://schemas.microsoft.com/office/drawing/2014/main" id="{6067B6DF-7C1A-6E61-2841-52A30DD1CF34}"/>
+              </a:ext>
+            </a:extLst>
+          </p:cNvPr>
+          <p:cNvCxnSpPr>
+            <a:cxnSpLocks/>
+            <a:stCxn id="134" idx="3"/>
+            <a:endCxn id="188" idx="1"/>
+          </p:cNvCxnSpPr>
+          <p:nvPr/>
+        </p:nvCxnSpPr>
+        <p:spPr>
+          <a:xfrm>
+            <a:off x="8723427" y="4869958"/>
+            <a:ext cx="1467333" cy="110880"/>
+          </a:xfrm>
+          <a:prstGeom prst="straightConnector1">
+            <a:avLst/>
+          </a:prstGeom>
+          <a:ln>
+            <a:solidFill>
+              <a:srgbClr val="0070C0"/>
+            </a:solidFill>
+            <a:tailEnd type="triangle"/>
+          </a:ln>
+        </p:spPr>
+        <p:style>
+          <a:lnRef idx="1">
+            <a:schemeClr val="accent1"/>
+          </a:lnRef>
+          <a:fillRef idx="0">
+            <a:schemeClr val="accent1"/>
+          </a:fillRef>
+          <a:effectRef idx="0">
+            <a:schemeClr val="accent1"/>
+          </a:effectRef>
+          <a:fontRef idx="minor">
+            <a:schemeClr val="tx1"/>
+          </a:fontRef>
+        </p:style>
+      </p:cxnSp>
+      <p:sp>
+        <p:nvSpPr>
+          <p:cNvPr id="190" name="TextBox 189">
+            <a:extLst>
+              <a:ext uri="{FF2B5EF4-FFF2-40B4-BE49-F238E27FC236}">
+                <a16:creationId xmlns:a16="http://schemas.microsoft.com/office/drawing/2014/main" id="{26F9CE3A-EE8C-68C2-127E-64EEB7E1161E}"/>
+              </a:ext>
+            </a:extLst>
+          </p:cNvPr>
+          <p:cNvSpPr txBox="1"/>
+          <p:nvPr/>
+        </p:nvSpPr>
+        <p:spPr>
+          <a:xfrm>
+            <a:off x="8890114" y="4763611"/>
+            <a:ext cx="1070395" cy="230832"/>
+          </a:xfrm>
+          <a:prstGeom prst="rect">
+            <a:avLst/>
+          </a:prstGeom>
+          <a:solidFill>
+            <a:schemeClr val="bg1"/>
+          </a:solidFill>
+        </p:spPr>
+        <p:txBody>
+          <a:bodyPr wrap="square" rtlCol="0">
+            <a:spAutoFit/>
+          </a:bodyPr>
+          <a:lstStyle/>
+          <a:p>
+            <a:r>
+              <a:rPr lang="en-US" sz="900" b="1" dirty="0">
+                <a:solidFill>
+                  <a:srgbClr val="0070C0"/>
+                </a:solidFill>
+              </a:rPr>
+              <a:t>evidence[1].detail</a:t>
+            </a:r>
+          </a:p>
+        </p:txBody>
+      </p:sp>
+      <p:cxnSp>
+        <p:nvCxnSpPr>
+          <p:cNvPr id="193" name="Straight Arrow Connector 192">
+            <a:extLst>
+              <a:ext uri="{FF2B5EF4-FFF2-40B4-BE49-F238E27FC236}">
+                <a16:creationId xmlns:a16="http://schemas.microsoft.com/office/drawing/2014/main" id="{9D77868B-2FDE-EF32-219F-047E2A3F973C}"/>
+              </a:ext>
+            </a:extLst>
+          </p:cNvPr>
+          <p:cNvCxnSpPr>
+            <a:cxnSpLocks/>
+            <a:stCxn id="5" idx="3"/>
+            <a:endCxn id="16" idx="1"/>
+          </p:cNvCxnSpPr>
+          <p:nvPr/>
+        </p:nvCxnSpPr>
+        <p:spPr>
+          <a:xfrm>
+            <a:off x="2427447" y="2126710"/>
+            <a:ext cx="1528276" cy="3260355"/>
+          </a:xfrm>
+          <a:prstGeom prst="straightConnector1">
+            <a:avLst/>
+          </a:prstGeom>
+          <a:ln>
+            <a:solidFill>
+              <a:schemeClr val="tx1"/>
+            </a:solidFill>
+            <a:tailEnd type="triangle"/>
+          </a:ln>
+        </p:spPr>
+        <p:style>
+          <a:lnRef idx="1">
+            <a:schemeClr val="accent1"/>
+          </a:lnRef>
+          <a:fillRef idx="0">
+            <a:schemeClr val="accent1"/>
+          </a:fillRef>
+          <a:effectRef idx="0">
+            <a:schemeClr val="accent1"/>
+          </a:effectRef>
+          <a:fontRef idx="minor">
+            <a:schemeClr val="tx1"/>
+          </a:fontRef>
+        </p:style>
+      </p:cxnSp>
+      <p:sp>
+        <p:nvSpPr>
+          <p:cNvPr id="197" name="TextBox 196">
+            <a:extLst>
+              <a:ext uri="{FF2B5EF4-FFF2-40B4-BE49-F238E27FC236}">
+                <a16:creationId xmlns:a16="http://schemas.microsoft.com/office/drawing/2014/main" id="{C8BAFFFD-4D52-6B31-2BC6-B7B1CFF0DFF1}"/>
+              </a:ext>
+            </a:extLst>
+          </p:cNvPr>
+          <p:cNvSpPr txBox="1"/>
+          <p:nvPr/>
+        </p:nvSpPr>
+        <p:spPr>
+          <a:xfrm>
+            <a:off x="3082342" y="4044221"/>
+            <a:ext cx="459578" cy="230832"/>
+          </a:xfrm>
+          <a:prstGeom prst="rect">
+            <a:avLst/>
+          </a:prstGeom>
+          <a:solidFill>
+            <a:schemeClr val="bg1"/>
+          </a:solidFill>
+        </p:spPr>
+        <p:txBody>
+          <a:bodyPr wrap="square" rtlCol="0">
+            <a:spAutoFit/>
+          </a:bodyPr>
+          <a:lstStyle/>
+          <a:p>
+            <a:r>
+              <a:rPr lang="en-US" sz="900" b="1" dirty="0"/>
+              <a:t>entry</a:t>
+            </a:r>
+          </a:p>
+        </p:txBody>
+      </p:sp>
+      <p:sp>
+        <p:nvSpPr>
+          <p:cNvPr id="200" name="Rectangle 199">
+            <a:extLst>
+              <a:ext uri="{FF2B5EF4-FFF2-40B4-BE49-F238E27FC236}">
+                <a16:creationId xmlns:a16="http://schemas.microsoft.com/office/drawing/2014/main" id="{049911D4-C0FA-BC8E-9E5F-01AFB4685F3E}"/>
+              </a:ext>
+            </a:extLst>
+          </p:cNvPr>
+          <p:cNvSpPr/>
+          <p:nvPr/>
+        </p:nvSpPr>
+        <p:spPr>
+          <a:xfrm>
+            <a:off x="6011857" y="1518700"/>
+            <a:ext cx="6091088" cy="4230094"/>
+          </a:xfrm>
+          <a:prstGeom prst="rect">
+            <a:avLst/>
+          </a:prstGeom>
+          <a:noFill/>
+          <a:ln>
+            <a:prstDash val="dash"/>
+          </a:ln>
+        </p:spPr>
+        <p:style>
+          <a:lnRef idx="2">
+            <a:schemeClr val="accent1">
+              <a:shade val="50000"/>
+            </a:schemeClr>
+          </a:lnRef>
+          <a:fillRef idx="1">
+            <a:schemeClr val="accent1"/>
+          </a:fillRef>
+          <a:effectRef idx="0">
+            <a:schemeClr val="accent1"/>
+          </a:effectRef>
+          <a:fontRef idx="minor">
+            <a:schemeClr val="lt1"/>
+          </a:fontRef>
+        </p:style>
+        <p:txBody>
+          <a:bodyPr rtlCol="0" anchor="ctr"/>
+          <a:lstStyle/>
+          <a:p>
+            <a:pPr algn="ctr"/>
+            <a:endParaRPr lang="en-US" dirty="0"/>
+          </a:p>
+        </p:txBody>
+      </p:sp>
+      <p:sp>
+        <p:nvSpPr>
+          <p:cNvPr id="201" name="TextBox 200">
+            <a:extLst>
+              <a:ext uri="{FF2B5EF4-FFF2-40B4-BE49-F238E27FC236}">
+                <a16:creationId xmlns:a16="http://schemas.microsoft.com/office/drawing/2014/main" id="{38E435ED-1E65-93D0-3F5D-054A66607F62}"/>
+              </a:ext>
+            </a:extLst>
+          </p:cNvPr>
+          <p:cNvSpPr txBox="1"/>
+          <p:nvPr/>
+        </p:nvSpPr>
+        <p:spPr>
+          <a:xfrm>
+            <a:off x="7972666" y="1479843"/>
+            <a:ext cx="1944378" cy="338554"/>
+          </a:xfrm>
+          <a:prstGeom prst="rect">
+            <a:avLst/>
+          </a:prstGeom>
+          <a:noFill/>
+        </p:spPr>
+        <p:txBody>
+          <a:bodyPr wrap="none" rtlCol="0">
+            <a:spAutoFit/>
+          </a:bodyPr>
+          <a:lstStyle/>
+          <a:p>
+            <a:r>
+              <a:rPr lang="en-US" sz="1600" dirty="0">
+                <a:solidFill>
+                  <a:srgbClr val="0070C0"/>
+                </a:solidFill>
+              </a:rPr>
+              <a:t>referenced resources</a:t>
+            </a:r>
+          </a:p>
+        </p:txBody>
+      </p:sp>
+      <p:sp>
+        <p:nvSpPr>
+          <p:cNvPr id="204" name="Flowchart: Process 203">
+            <a:extLst>
+              <a:ext uri="{FF2B5EF4-FFF2-40B4-BE49-F238E27FC236}">
+                <a16:creationId xmlns:a16="http://schemas.microsoft.com/office/drawing/2014/main" id="{18BA8CA6-851E-77D1-DB3C-3AFA4A59F1CC}"/>
+              </a:ext>
+            </a:extLst>
+          </p:cNvPr>
+          <p:cNvSpPr/>
+          <p:nvPr/>
+        </p:nvSpPr>
+        <p:spPr>
+          <a:xfrm>
+            <a:off x="1875487" y="5106004"/>
+            <a:ext cx="1864311" cy="562122"/>
+          </a:xfrm>
+          <a:prstGeom prst="flowChartProcess">
+            <a:avLst/>
+          </a:prstGeom>
+          <a:ln>
+            <a:solidFill>
+              <a:schemeClr val="tx1"/>
+            </a:solidFill>
+          </a:ln>
+        </p:spPr>
+        <p:style>
+          <a:lnRef idx="2">
+            <a:schemeClr val="accent1">
+              <a:shade val="50000"/>
+            </a:schemeClr>
+          </a:lnRef>
+          <a:fillRef idx="1">
+            <a:schemeClr val="accent1"/>
+          </a:fillRef>
+          <a:effectRef idx="0">
+            <a:schemeClr val="accent1"/>
+          </a:effectRef>
+          <a:fontRef idx="minor">
+            <a:schemeClr val="lt1"/>
+          </a:fontRef>
+        </p:style>
+        <p:txBody>
+          <a:bodyPr rtlCol="0" anchor="ctr"/>
+          <a:lstStyle/>
+          <a:p>
+            <a:pPr algn="ctr"/>
+            <a:r>
+              <a:rPr lang="en-US" sz="1600" dirty="0"/>
+              <a:t>Guidance Response</a:t>
+            </a:r>
+            <a:endParaRPr lang="en-US" sz="1000" dirty="0"/>
+          </a:p>
+        </p:txBody>
+      </p:sp>
+      <p:cxnSp>
+        <p:nvCxnSpPr>
+          <p:cNvPr id="212" name="Straight Arrow Connector 211">
+            <a:extLst>
+              <a:ext uri="{FF2B5EF4-FFF2-40B4-BE49-F238E27FC236}">
+                <a16:creationId xmlns:a16="http://schemas.microsoft.com/office/drawing/2014/main" id="{24C82A02-04BB-5D53-D412-2B464BBD1951}"/>
+              </a:ext>
+            </a:extLst>
+          </p:cNvPr>
+          <p:cNvCxnSpPr>
+            <a:cxnSpLocks/>
+            <a:stCxn id="5" idx="2"/>
+            <a:endCxn id="204" idx="0"/>
+          </p:cNvCxnSpPr>
+          <p:nvPr/>
+        </p:nvCxnSpPr>
+        <p:spPr>
+          <a:xfrm>
+            <a:off x="1495292" y="2432425"/>
+            <a:ext cx="1312351" cy="2673579"/>
+          </a:xfrm>
+          <a:prstGeom prst="straightConnector1">
+            <a:avLst/>
+          </a:prstGeom>
+          <a:ln>
+            <a:solidFill>
+              <a:schemeClr val="tx1"/>
+            </a:solidFill>
+            <a:tailEnd type="triangle"/>
+          </a:ln>
+        </p:spPr>
+        <p:style>
+          <a:lnRef idx="1">
+            <a:schemeClr val="accent1"/>
+          </a:lnRef>
+          <a:fillRef idx="0">
+            <a:schemeClr val="accent1"/>
+          </a:fillRef>
+          <a:effectRef idx="0">
+            <a:schemeClr val="accent1"/>
+          </a:effectRef>
+          <a:fontRef idx="minor">
+            <a:schemeClr val="tx1"/>
+          </a:fontRef>
+        </p:style>
+      </p:cxnSp>
+      <p:sp>
+        <p:nvSpPr>
+          <p:cNvPr id="216" name="Flowchart: Process 215">
+            <a:extLst>
+              <a:ext uri="{FF2B5EF4-FFF2-40B4-BE49-F238E27FC236}">
+                <a16:creationId xmlns:a16="http://schemas.microsoft.com/office/drawing/2014/main" id="{130A3C16-2D3E-3435-DF4B-16C2E0FF3157}"/>
+              </a:ext>
+            </a:extLst>
+          </p:cNvPr>
+          <p:cNvSpPr/>
+          <p:nvPr/>
+        </p:nvSpPr>
+        <p:spPr>
+          <a:xfrm>
+            <a:off x="569111" y="3606334"/>
+            <a:ext cx="1864311" cy="618858"/>
+          </a:xfrm>
+          <a:prstGeom prst="flowChartProcess">
+            <a:avLst/>
+          </a:prstGeom>
+          <a:ln>
+            <a:solidFill>
+              <a:schemeClr val="tx1"/>
+            </a:solidFill>
+          </a:ln>
+        </p:spPr>
+        <p:style>
+          <a:lnRef idx="2">
+            <a:schemeClr val="accent1">
+              <a:shade val="50000"/>
+            </a:schemeClr>
+          </a:lnRef>
+          <a:fillRef idx="1">
+            <a:schemeClr val="accent1"/>
+          </a:fillRef>
+          <a:effectRef idx="0">
+            <a:schemeClr val="accent1"/>
+          </a:effectRef>
+          <a:fontRef idx="minor">
+            <a:schemeClr val="lt1"/>
+          </a:fontRef>
+        </p:style>
+        <p:txBody>
+          <a:bodyPr rtlCol="0" anchor="ctr"/>
+          <a:lstStyle/>
+          <a:p>
+            <a:pPr algn="ctr"/>
+            <a:r>
+              <a:rPr lang="en-US" sz="1600" dirty="0"/>
+              <a:t>Lab Observation</a:t>
+            </a:r>
+          </a:p>
+          <a:p>
+            <a:pPr algn="ctr"/>
+            <a:r>
+              <a:rPr lang="en-US" sz="1000" dirty="0"/>
+              <a:t>FOBT</a:t>
+            </a:r>
+          </a:p>
+        </p:txBody>
+      </p:sp>
+      <p:sp>
+        <p:nvSpPr>
+          <p:cNvPr id="217" name="Flowchart: Process 216">
+            <a:extLst>
+              <a:ext uri="{FF2B5EF4-FFF2-40B4-BE49-F238E27FC236}">
+                <a16:creationId xmlns:a16="http://schemas.microsoft.com/office/drawing/2014/main" id="{3E59222A-630A-6477-4D3C-09DEADF1BC16}"/>
+              </a:ext>
+            </a:extLst>
+          </p:cNvPr>
+          <p:cNvSpPr/>
+          <p:nvPr/>
+        </p:nvSpPr>
+        <p:spPr>
+          <a:xfrm>
+            <a:off x="1196031" y="4421939"/>
+            <a:ext cx="1864311" cy="562122"/>
+          </a:xfrm>
+          <a:prstGeom prst="flowChartProcess">
+            <a:avLst/>
+          </a:prstGeom>
+          <a:ln>
+            <a:solidFill>
+              <a:schemeClr val="tx1"/>
+            </a:solidFill>
+          </a:ln>
+        </p:spPr>
+        <p:style>
+          <a:lnRef idx="2">
+            <a:schemeClr val="accent1">
+              <a:shade val="50000"/>
+            </a:schemeClr>
+          </a:lnRef>
+          <a:fillRef idx="1">
+            <a:schemeClr val="accent1"/>
+          </a:fillRef>
+          <a:effectRef idx="0">
+            <a:schemeClr val="accent1"/>
+          </a:effectRef>
+          <a:fontRef idx="minor">
+            <a:schemeClr val="lt1"/>
+          </a:fontRef>
+        </p:style>
+        <p:txBody>
+          <a:bodyPr rtlCol="0" anchor="ctr"/>
+          <a:lstStyle/>
+          <a:p>
+            <a:pPr algn="ctr"/>
+            <a:r>
+              <a:rPr lang="en-US" sz="1600" dirty="0"/>
+              <a:t>Procedure</a:t>
+            </a:r>
+          </a:p>
+          <a:p>
+            <a:pPr algn="ctr"/>
+            <a:r>
+              <a:rPr lang="en-US" sz="1000" dirty="0"/>
+              <a:t>Colonoscopy</a:t>
+            </a:r>
+          </a:p>
+        </p:txBody>
+      </p:sp>
+      <p:sp>
+        <p:nvSpPr>
+          <p:cNvPr id="219" name="TextBox 218">
+            <a:extLst>
+              <a:ext uri="{FF2B5EF4-FFF2-40B4-BE49-F238E27FC236}">
+                <a16:creationId xmlns:a16="http://schemas.microsoft.com/office/drawing/2014/main" id="{3617E568-82BF-2B81-5D7E-EDE8211B2A34}"/>
+              </a:ext>
+            </a:extLst>
+          </p:cNvPr>
+          <p:cNvSpPr txBox="1"/>
+          <p:nvPr/>
+        </p:nvSpPr>
+        <p:spPr>
+          <a:xfrm>
+            <a:off x="1926289" y="3320966"/>
+            <a:ext cx="445317" cy="230832"/>
+          </a:xfrm>
+          <a:prstGeom prst="rect">
+            <a:avLst/>
+          </a:prstGeom>
+          <a:solidFill>
+            <a:schemeClr val="bg1"/>
+          </a:solidFill>
+        </p:spPr>
+        <p:txBody>
+          <a:bodyPr wrap="square" rtlCol="0">
+            <a:spAutoFit/>
+          </a:bodyPr>
+          <a:lstStyle/>
+          <a:p>
+            <a:r>
+              <a:rPr lang="en-US" sz="900" b="1" dirty="0"/>
+              <a:t>entry</a:t>
+            </a:r>
+          </a:p>
+        </p:txBody>
+      </p:sp>
+      <p:sp>
+        <p:nvSpPr>
+          <p:cNvPr id="52" name="Rectangle 51">
+            <a:extLst>
+              <a:ext uri="{FF2B5EF4-FFF2-40B4-BE49-F238E27FC236}">
+                <a16:creationId xmlns:a16="http://schemas.microsoft.com/office/drawing/2014/main" id="{967A6B95-682D-E0E7-B7E3-BC0C03B64EDA}"/>
+              </a:ext>
+            </a:extLst>
+          </p:cNvPr>
+          <p:cNvSpPr/>
+          <p:nvPr/>
+        </p:nvSpPr>
+        <p:spPr>
+          <a:xfrm>
+            <a:off x="367513" y="1518700"/>
+            <a:ext cx="5550229" cy="4230094"/>
+          </a:xfrm>
+          <a:prstGeom prst="rect">
+            <a:avLst/>
+          </a:prstGeom>
+          <a:noFill/>
+          <a:ln>
+            <a:prstDash val="solid"/>
+          </a:ln>
+        </p:spPr>
+        <p:style>
+          <a:lnRef idx="2">
+            <a:schemeClr val="accent1">
+              <a:shade val="50000"/>
+            </a:schemeClr>
+          </a:lnRef>
+          <a:fillRef idx="1">
+            <a:schemeClr val="accent1"/>
+          </a:fillRef>
+          <a:effectRef idx="0">
+            <a:schemeClr val="accent1"/>
+          </a:effectRef>
+          <a:fontRef idx="minor">
+            <a:schemeClr val="lt1"/>
+          </a:fontRef>
+        </p:style>
+        <p:txBody>
+          <a:bodyPr rtlCol="0" anchor="ctr"/>
+          <a:lstStyle/>
+          <a:p>
+            <a:pPr algn="ctr"/>
+            <a:endParaRPr lang="en-US" dirty="0"/>
+          </a:p>
+        </p:txBody>
+      </p:sp>
+      <p:sp>
+        <p:nvSpPr>
+          <p:cNvPr id="53" name="TextBox 52">
+            <a:extLst>
+              <a:ext uri="{FF2B5EF4-FFF2-40B4-BE49-F238E27FC236}">
+                <a16:creationId xmlns:a16="http://schemas.microsoft.com/office/drawing/2014/main" id="{E6862FD6-FA1F-146C-D846-8A721EBCCCBD}"/>
+              </a:ext>
+            </a:extLst>
+          </p:cNvPr>
+          <p:cNvSpPr txBox="1"/>
+          <p:nvPr/>
+        </p:nvSpPr>
+        <p:spPr>
+          <a:xfrm>
+            <a:off x="2018156" y="1462357"/>
+            <a:ext cx="2088713" cy="338554"/>
+          </a:xfrm>
+          <a:prstGeom prst="rect">
+            <a:avLst/>
+          </a:prstGeom>
+          <a:noFill/>
+        </p:spPr>
+        <p:txBody>
+          <a:bodyPr wrap="none" rtlCol="0">
+            <a:spAutoFit/>
+          </a:bodyPr>
+          <a:lstStyle/>
+          <a:p>
+            <a:r>
+              <a:rPr lang="en-US" sz="1600" dirty="0">
+                <a:solidFill>
+                  <a:srgbClr val="002060"/>
+                </a:solidFill>
+              </a:rPr>
+              <a:t>GIC Bundle and entries</a:t>
+            </a:r>
+          </a:p>
+        </p:txBody>
+      </p:sp>
+      <p:cxnSp>
+        <p:nvCxnSpPr>
+          <p:cNvPr id="11" name="Straight Arrow Connector 10">
+            <a:extLst>
+              <a:ext uri="{FF2B5EF4-FFF2-40B4-BE49-F238E27FC236}">
+                <a16:creationId xmlns:a16="http://schemas.microsoft.com/office/drawing/2014/main" id="{14CBD524-3F01-0C12-59AE-70D4841B748F}"/>
+              </a:ext>
+            </a:extLst>
+          </p:cNvPr>
+          <p:cNvCxnSpPr>
+            <a:cxnSpLocks/>
+            <a:stCxn id="134" idx="0"/>
+            <a:endCxn id="90" idx="2"/>
+          </p:cNvCxnSpPr>
+          <p:nvPr/>
+        </p:nvCxnSpPr>
+        <p:spPr>
+          <a:xfrm flipV="1">
+            <a:off x="7791272" y="3756810"/>
+            <a:ext cx="0" cy="832087"/>
+          </a:xfrm>
+          <a:prstGeom prst="straightConnector1">
+            <a:avLst/>
+          </a:prstGeom>
+          <a:ln>
+            <a:solidFill>
+              <a:srgbClr val="0070C0"/>
+            </a:solidFill>
+            <a:tailEnd type="triangle"/>
+          </a:ln>
+        </p:spPr>
+        <p:style>
+          <a:lnRef idx="1">
+            <a:schemeClr val="accent1"/>
+          </a:lnRef>
+          <a:fillRef idx="0">
+            <a:schemeClr val="accent1"/>
+          </a:fillRef>
+          <a:effectRef idx="0">
+            <a:schemeClr val="accent1"/>
+          </a:effectRef>
+          <a:fontRef idx="minor">
+            <a:schemeClr val="tx1"/>
+          </a:fontRef>
+        </p:style>
+      </p:cxnSp>
+      <p:sp>
+        <p:nvSpPr>
+          <p:cNvPr id="6" name="TextBox 5">
+            <a:extLst>
+              <a:ext uri="{FF2B5EF4-FFF2-40B4-BE49-F238E27FC236}">
+                <a16:creationId xmlns:a16="http://schemas.microsoft.com/office/drawing/2014/main" id="{93579072-076C-AE81-DA9A-93D66B166817}"/>
+              </a:ext>
+            </a:extLst>
+          </p:cNvPr>
+          <p:cNvSpPr txBox="1"/>
+          <p:nvPr/>
+        </p:nvSpPr>
+        <p:spPr>
+          <a:xfrm>
+            <a:off x="7234391" y="4153883"/>
+            <a:ext cx="1070395" cy="230832"/>
+          </a:xfrm>
+          <a:prstGeom prst="rect">
+            <a:avLst/>
+          </a:prstGeom>
+          <a:solidFill>
+            <a:schemeClr val="bg1"/>
+          </a:solidFill>
+        </p:spPr>
+        <p:txBody>
+          <a:bodyPr wrap="square" rtlCol="0">
+            <a:spAutoFit/>
+          </a:bodyPr>
+          <a:lstStyle/>
+          <a:p>
+            <a:r>
+              <a:rPr lang="en-US" sz="900" b="1" dirty="0">
+                <a:solidFill>
+                  <a:srgbClr val="0070C0"/>
+                </a:solidFill>
+              </a:rPr>
+              <a:t>evidence[0].detail</a:t>
+            </a:r>
+          </a:p>
+        </p:txBody>
+      </p:sp>
+      <p:cxnSp>
+        <p:nvCxnSpPr>
+          <p:cNvPr id="26" name="Straight Arrow Connector 25">
+            <a:extLst>
+              <a:ext uri="{FF2B5EF4-FFF2-40B4-BE49-F238E27FC236}">
+                <a16:creationId xmlns:a16="http://schemas.microsoft.com/office/drawing/2014/main" id="{6CAE2FCA-43DC-573F-5F0F-7CE920E91F68}"/>
+              </a:ext>
+            </a:extLst>
+          </p:cNvPr>
+          <p:cNvCxnSpPr>
+            <a:cxnSpLocks/>
+            <a:stCxn id="90" idx="0"/>
+            <a:endCxn id="180" idx="2"/>
+          </p:cNvCxnSpPr>
+          <p:nvPr/>
+        </p:nvCxnSpPr>
+        <p:spPr>
+          <a:xfrm flipV="1">
+            <a:off x="7791272" y="2410356"/>
+            <a:ext cx="0" cy="784332"/>
+          </a:xfrm>
+          <a:prstGeom prst="straightConnector1">
+            <a:avLst/>
+          </a:prstGeom>
+          <a:ln w="9525">
+            <a:solidFill>
+              <a:srgbClr val="0070C0"/>
+            </a:solidFill>
+            <a:tailEnd type="triangle"/>
+          </a:ln>
+        </p:spPr>
+        <p:style>
+          <a:lnRef idx="1">
+            <a:schemeClr val="accent1"/>
+          </a:lnRef>
+          <a:fillRef idx="0">
+            <a:schemeClr val="accent1"/>
+          </a:fillRef>
+          <a:effectRef idx="0">
+            <a:schemeClr val="accent1"/>
+          </a:effectRef>
+          <a:fontRef idx="minor">
+            <a:schemeClr val="tx1"/>
+          </a:fontRef>
+        </p:style>
+      </p:cxnSp>
+      <p:sp>
+        <p:nvSpPr>
+          <p:cNvPr id="30" name="TextBox 29">
+            <a:extLst>
+              <a:ext uri="{FF2B5EF4-FFF2-40B4-BE49-F238E27FC236}">
+                <a16:creationId xmlns:a16="http://schemas.microsoft.com/office/drawing/2014/main" id="{BB4284E4-179D-F9C7-5869-679221D11517}"/>
+              </a:ext>
+            </a:extLst>
+          </p:cNvPr>
+          <p:cNvSpPr txBox="1"/>
+          <p:nvPr/>
+        </p:nvSpPr>
+        <p:spPr>
+          <a:xfrm>
+            <a:off x="7533467" y="2731777"/>
+            <a:ext cx="633829" cy="230832"/>
+          </a:xfrm>
+          <a:prstGeom prst="rect">
+            <a:avLst/>
+          </a:prstGeom>
+          <a:solidFill>
+            <a:schemeClr val="bg1"/>
+          </a:solidFill>
+        </p:spPr>
+        <p:txBody>
+          <a:bodyPr wrap="square" rtlCol="0">
+            <a:spAutoFit/>
+          </a:bodyPr>
+          <a:lstStyle/>
+          <a:p>
+            <a:r>
+              <a:rPr lang="en-US" sz="900" b="1" dirty="0">
+                <a:solidFill>
+                  <a:srgbClr val="0070C0"/>
+                </a:solidFill>
+              </a:rPr>
+              <a:t>subject</a:t>
+            </a:r>
+          </a:p>
+        </p:txBody>
+      </p:sp>
+      <p:sp>
+        <p:nvSpPr>
+          <p:cNvPr id="9" name="Flowchart: Process 8">
+            <a:extLst>
+              <a:ext uri="{FF2B5EF4-FFF2-40B4-BE49-F238E27FC236}">
+                <a16:creationId xmlns:a16="http://schemas.microsoft.com/office/drawing/2014/main" id="{A92DF0BA-0AEF-E27B-45BA-A77B08FA68BF}"/>
+              </a:ext>
+            </a:extLst>
+          </p:cNvPr>
+          <p:cNvSpPr/>
+          <p:nvPr/>
+        </p:nvSpPr>
+        <p:spPr>
+          <a:xfrm>
+            <a:off x="3949209" y="1818397"/>
+            <a:ext cx="1864311" cy="613637"/>
+          </a:xfrm>
+          <a:prstGeom prst="flowChartProcess">
+            <a:avLst/>
+          </a:prstGeom>
+          <a:solidFill>
+            <a:schemeClr val="accent1"/>
+          </a:solidFill>
+          <a:ln>
+            <a:solidFill>
+              <a:schemeClr val="tx1"/>
+            </a:solidFill>
+          </a:ln>
+        </p:spPr>
+        <p:style>
+          <a:lnRef idx="2">
+            <a:schemeClr val="accent1">
+              <a:shade val="50000"/>
+            </a:schemeClr>
+          </a:lnRef>
+          <a:fillRef idx="1">
+            <a:schemeClr val="accent1"/>
+          </a:fillRef>
+          <a:effectRef idx="0">
+            <a:schemeClr val="accent1"/>
+          </a:effectRef>
+          <a:fontRef idx="minor">
+            <a:schemeClr val="lt1"/>
+          </a:fontRef>
+        </p:style>
+        <p:txBody>
+          <a:bodyPr rtlCol="0" anchor="ctr"/>
+          <a:lstStyle/>
+          <a:p>
+            <a:pPr algn="ctr"/>
+            <a:r>
+              <a:rPr lang="en-US" sz="1600" dirty="0"/>
+              <a:t>GIC Composition</a:t>
+            </a:r>
+            <a:endParaRPr lang="en-US" sz="1000" dirty="0"/>
+          </a:p>
+        </p:txBody>
+      </p:sp>
+    </p:spTree>
+    <p:extLst>
+      <p:ext uri="{BB962C8B-B14F-4D97-AF65-F5344CB8AC3E}">
+        <p14:creationId xmlns:p14="http://schemas.microsoft.com/office/powerpoint/2010/main" val="2185718546"/>
+      </p:ext>
+    </p:extLst>
+  </p:cSld>
+  <p:clrMapOvr>
+    <a:masterClrMapping/>
+  </p:clrMapOvr>
+</p:sld>
+</file>
+
+<file path=ppt/slides/slide9.xml><?xml version="1.0" encoding="utf-8"?>
+<p:sld xmlns:a="http://schemas.openxmlformats.org/drawingml/2006/main" xmlns:r="http://schemas.openxmlformats.org/officeDocument/2006/relationships" xmlns:p="http://schemas.openxmlformats.org/presentationml/2006/main">
+  <p:cSld>
+    <p:spTree>
+      <p:nvGrpSpPr>
         <p:cNvPr id="1" name=""/>
         <p:cNvGrpSpPr/>
         <p:nvPr/>
@@ -8387,7 +11191,7 @@
           <a:p>
             <a:r>
               <a:rPr lang="en-US" sz="3200" dirty="0"/>
-              <a:t>DEQM Gaps In Care Bundle </a:t>
+              <a:t>DEQM Gaps In Care Bundle (collection)</a:t>
             </a:r>
             <a:endParaRPr lang="en-US" dirty="0"/>
           </a:p>
@@ -8431,10 +11235,10 @@
       </p:sp>
       <p:sp>
         <p:nvSpPr>
-          <p:cNvPr id="4" name="Flowchart: Process 3">
-            <a:extLst>
-              <a:ext uri="{FF2B5EF4-FFF2-40B4-BE49-F238E27FC236}">
-                <a16:creationId xmlns:a16="http://schemas.microsoft.com/office/drawing/2014/main" id="{3DEA0A30-6A6C-4FA4-B9FC-7A051391A0D6}"/>
+          <p:cNvPr id="5" name="Flowchart: Process 4">
+            <a:extLst>
+              <a:ext uri="{FF2B5EF4-FFF2-40B4-BE49-F238E27FC236}">
+                <a16:creationId xmlns:a16="http://schemas.microsoft.com/office/drawing/2014/main" id="{B7A7E221-C938-4426-AA48-B09EFF0C8A7E}"/>
               </a:ext>
             </a:extLst>
           </p:cNvPr>
@@ -8443,19 +11247,12 @@
         </p:nvSpPr>
         <p:spPr>
           <a:xfrm>
-            <a:off x="3949212" y="1818397"/>
-            <a:ext cx="1864311" cy="613637"/>
+            <a:off x="563136" y="1820994"/>
+            <a:ext cx="1864311" cy="611431"/>
           </a:xfrm>
           <a:prstGeom prst="flowChartProcess">
             <a:avLst/>
           </a:prstGeom>
-          <a:solidFill>
-            <a:schemeClr val="accent6">
-              <a:lumMod val="60000"/>
-              <a:lumOff val="40000"/>
-              <a:alpha val="53000"/>
-            </a:schemeClr>
-          </a:solidFill>
           <a:ln>
             <a:solidFill>
               <a:schemeClr val="tx1"/>
@@ -8484,37 +11281,18 @@
           <a:p>
             <a:pPr algn="ctr"/>
             <a:r>
-              <a:rPr lang="en-US" sz="1600" dirty="0">
-                <a:solidFill>
-                  <a:schemeClr val="bg2">
-                    <a:lumMod val="25000"/>
-                  </a:schemeClr>
-                </a:solidFill>
-              </a:rPr>
-              <a:t>GIC Composition</a:t>
-            </a:r>
-          </a:p>
-          <a:p>
-            <a:pPr algn="ctr"/>
-            <a:r>
-              <a:rPr lang="en-US" sz="1600" dirty="0">
-                <a:solidFill>
-                  <a:schemeClr val="bg2">
-                    <a:lumMod val="25000"/>
-                  </a:schemeClr>
-                </a:solidFill>
-              </a:rPr>
-              <a:t>(optional)</a:t>
-            </a:r>
-          </a:p>
-        </p:txBody>
-      </p:sp>
-      <p:sp>
-        <p:nvSpPr>
-          <p:cNvPr id="5" name="Flowchart: Process 4">
-            <a:extLst>
-              <a:ext uri="{FF2B5EF4-FFF2-40B4-BE49-F238E27FC236}">
-                <a16:creationId xmlns:a16="http://schemas.microsoft.com/office/drawing/2014/main" id="{B7A7E221-C938-4426-AA48-B09EFF0C8A7E}"/>
+              <a:rPr lang="en-US" sz="1600" dirty="0"/>
+              <a:t>GIC Bundle</a:t>
+            </a:r>
+          </a:p>
+        </p:txBody>
+      </p:sp>
+      <p:sp>
+        <p:nvSpPr>
+          <p:cNvPr id="7" name="Flowchart: Process 6">
+            <a:extLst>
+              <a:ext uri="{FF2B5EF4-FFF2-40B4-BE49-F238E27FC236}">
+                <a16:creationId xmlns:a16="http://schemas.microsoft.com/office/drawing/2014/main" id="{C91FCB4F-F2B6-436E-9248-D1FB7A9503A1}"/>
               </a:ext>
             </a:extLst>
           </p:cNvPr>
@@ -8523,12 +11301,15 @@
         </p:nvSpPr>
         <p:spPr>
           <a:xfrm>
-            <a:off x="563136" y="1820994"/>
-            <a:ext cx="1864311" cy="611431"/>
+            <a:off x="3949210" y="2681763"/>
+            <a:ext cx="1864311" cy="613637"/>
           </a:xfrm>
           <a:prstGeom prst="flowChartProcess">
             <a:avLst/>
           </a:prstGeom>
+          <a:solidFill>
+            <a:schemeClr val="accent1"/>
+          </a:solidFill>
           <a:ln>
             <a:solidFill>
               <a:schemeClr val="tx1"/>
@@ -8558,17 +11339,21 @@
             <a:pPr algn="ctr"/>
             <a:r>
               <a:rPr lang="en-US" sz="1600" dirty="0"/>
-              <a:t>GIC Bundle</a:t>
-            </a:r>
-          </a:p>
-        </p:txBody>
-      </p:sp>
-      <p:sp>
-        <p:nvSpPr>
-          <p:cNvPr id="7" name="Flowchart: Process 6">
-            <a:extLst>
-              <a:ext uri="{FF2B5EF4-FFF2-40B4-BE49-F238E27FC236}">
-                <a16:creationId xmlns:a16="http://schemas.microsoft.com/office/drawing/2014/main" id="{C91FCB4F-F2B6-436E-9248-D1FB7A9503A1}"/>
+              <a:t>GIC Measure Report  </a:t>
+            </a:r>
+            <a:r>
+              <a:rPr lang="en-US" sz="1000" dirty="0"/>
+              <a:t>Colorectal Cancer Screening</a:t>
+            </a:r>
+          </a:p>
+        </p:txBody>
+      </p:sp>
+      <p:sp>
+        <p:nvSpPr>
+          <p:cNvPr id="13" name="Flowchart: Process 12">
+            <a:extLst>
+              <a:ext uri="{FF2B5EF4-FFF2-40B4-BE49-F238E27FC236}">
+                <a16:creationId xmlns:a16="http://schemas.microsoft.com/office/drawing/2014/main" id="{7C494011-9B4B-4108-B2F1-32F5A7D22803}"/>
               </a:ext>
             </a:extLst>
           </p:cNvPr>
@@ -8577,8 +11362,8 @@
         </p:nvSpPr>
         <p:spPr>
           <a:xfrm>
-            <a:off x="3949210" y="2681763"/>
-            <a:ext cx="1864311" cy="613637"/>
+            <a:off x="3949209" y="3520726"/>
+            <a:ext cx="1864311" cy="555563"/>
           </a:xfrm>
           <a:prstGeom prst="flowChartProcess">
             <a:avLst/>
@@ -8612,65 +11397,7 @@
             <a:pPr algn="ctr"/>
             <a:r>
               <a:rPr lang="en-US" sz="1600" dirty="0"/>
-              <a:t>GIC Measure Report  </a:t>
-            </a:r>
-            <a:r>
-              <a:rPr lang="en-US" sz="1000" dirty="0"/>
-              <a:t>Colorectal Cancer Screening</a:t>
-            </a:r>
-          </a:p>
-        </p:txBody>
-      </p:sp>
-      <p:sp>
-        <p:nvSpPr>
-          <p:cNvPr id="13" name="Flowchart: Process 12">
-            <a:extLst>
-              <a:ext uri="{FF2B5EF4-FFF2-40B4-BE49-F238E27FC236}">
-                <a16:creationId xmlns:a16="http://schemas.microsoft.com/office/drawing/2014/main" id="{7C494011-9B4B-4108-B2F1-32F5A7D22803}"/>
-              </a:ext>
-            </a:extLst>
-          </p:cNvPr>
-          <p:cNvSpPr/>
-          <p:nvPr/>
-        </p:nvSpPr>
-        <p:spPr>
-          <a:xfrm>
-            <a:off x="3949209" y="3520726"/>
-            <a:ext cx="1864311" cy="555563"/>
-          </a:xfrm>
-          <a:prstGeom prst="flowChartProcess">
-            <a:avLst/>
-          </a:prstGeom>
-          <a:ln>
-            <a:solidFill>
-              <a:schemeClr val="tx1"/>
-            </a:solidFill>
-          </a:ln>
-        </p:spPr>
-        <p:style>
-          <a:lnRef idx="2">
-            <a:schemeClr val="accent1">
-              <a:shade val="50000"/>
-            </a:schemeClr>
-          </a:lnRef>
-          <a:fillRef idx="1">
-            <a:schemeClr val="accent1"/>
-          </a:fillRef>
-          <a:effectRef idx="0">
-            <a:schemeClr val="accent1"/>
-          </a:effectRef>
-          <a:fontRef idx="minor">
-            <a:schemeClr val="lt1"/>
-          </a:fontRef>
-        </p:style>
-        <p:txBody>
-          <a:bodyPr rtlCol="0" anchor="ctr"/>
-          <a:lstStyle/>
-          <a:p>
-            <a:pPr algn="ctr"/>
-            <a:r>
-              <a:rPr lang="en-US" sz="1600" dirty="0"/>
-              <a:t>QI Core Patient</a:t>
+              <a:t>Patient</a:t>
             </a:r>
           </a:p>
         </p:txBody>
@@ -8728,7 +11455,7 @@
             <a:pPr algn="ctr"/>
             <a:r>
               <a:rPr lang="en-US" sz="1600" dirty="0"/>
-              <a:t>QI Core Lab Observation</a:t>
+              <a:t>Lab Observation</a:t>
             </a:r>
           </a:p>
           <a:p>
@@ -8789,7 +11516,7 @@
             <a:pPr algn="ctr"/>
             <a:r>
               <a:rPr lang="en-US" sz="1600" dirty="0"/>
-              <a:t>QI Core Organization</a:t>
+              <a:t>Organization</a:t>
             </a:r>
           </a:p>
         </p:txBody>
@@ -8963,7 +11690,6 @@
           <p:cNvCxnSpPr>
             <a:cxnSpLocks/>
             <a:stCxn id="5" idx="3"/>
-            <a:endCxn id="4" idx="1"/>
           </p:cNvCxnSpPr>
           <p:nvPr/>
         </p:nvCxnSpPr>
@@ -9171,7 +11897,7 @@
             <a:pPr algn="ctr"/>
             <a:r>
               <a:rPr lang="en-US" sz="1600" dirty="0"/>
-              <a:t>QI Core Procedure</a:t>
+              <a:t>Procedure</a:t>
             </a:r>
           </a:p>
           <a:p>
@@ -9285,6 +12011,9 @@
           <a:prstGeom prst="flowChartProcess">
             <a:avLst/>
           </a:prstGeom>
+          <a:solidFill>
+            <a:schemeClr val="accent6"/>
+          </a:solidFill>
           <a:ln>
             <a:solidFill>
               <a:schemeClr val="tx1"/>
@@ -9317,6 +12046,13 @@
               <a:t>GIC Detected Issue</a:t>
             </a:r>
           </a:p>
+          <a:p>
+            <a:pPr algn="ctr"/>
+            <a:r>
+              <a:rPr lang="en-US" sz="1600" dirty="0"/>
+              <a:t>(optional)</a:t>
+            </a:r>
+          </a:p>
         </p:txBody>
       </p:sp>
       <p:cxnSp>
@@ -9330,7 +12066,6 @@
           </p:cNvPr>
           <p:cNvCxnSpPr>
             <a:cxnSpLocks/>
-            <a:stCxn id="4" idx="3"/>
             <a:endCxn id="90" idx="1"/>
           </p:cNvCxnSpPr>
           <p:nvPr/>
@@ -9644,7 +12379,7 @@
             <a:avLst/>
           </a:prstGeom>
           <a:solidFill>
-            <a:schemeClr val="accent5">
+            <a:schemeClr val="accent6">
               <a:lumMod val="60000"/>
               <a:lumOff val="40000"/>
             </a:schemeClr>
@@ -9692,7 +12427,6 @@
           </p:cNvPr>
           <p:cNvCxnSpPr>
             <a:cxnSpLocks/>
-            <a:stCxn id="4" idx="3"/>
             <a:endCxn id="134" idx="1"/>
           </p:cNvCxnSpPr>
           <p:nvPr/>
@@ -9862,7 +12596,7 @@
             <a:pPr algn="ctr"/>
             <a:r>
               <a:rPr lang="en-US" sz="1600" dirty="0"/>
-              <a:t>QI Core Patient</a:t>
+              <a:t>Patient</a:t>
             </a:r>
           </a:p>
         </p:txBody>
@@ -9878,7 +12612,6 @@
           </p:cNvPr>
           <p:cNvCxnSpPr>
             <a:cxnSpLocks/>
-            <a:stCxn id="4" idx="3"/>
             <a:endCxn id="180" idx="1"/>
           </p:cNvCxnSpPr>
           <p:nvPr/>
@@ -10007,7 +12740,7 @@
             <a:pPr algn="ctr"/>
             <a:r>
               <a:rPr lang="en-US" sz="1600" dirty="0"/>
-              <a:t>QI Core Organization</a:t>
+              <a:t>Organization</a:t>
             </a:r>
             <a:endParaRPr lang="en-US" sz="1000" dirty="0"/>
           </a:p>
@@ -10195,7 +12928,7 @@
             <a:avLst/>
           </a:prstGeom>
           <a:solidFill>
-            <a:schemeClr val="accent5">
+            <a:schemeClr val="accent6">
               <a:lumMod val="60000"/>
               <a:lumOff val="40000"/>
             </a:schemeClr>
@@ -10512,6 +13245,9 @@
           <a:prstGeom prst="flowChartProcess">
             <a:avLst/>
           </a:prstGeom>
+          <a:solidFill>
+            <a:schemeClr val="accent6"/>
+          </a:solidFill>
           <a:ln>
             <a:solidFill>
               <a:schemeClr val="tx1"/>
@@ -10543,6 +13279,13 @@
               <a:rPr lang="en-US" sz="1600" dirty="0"/>
               <a:t>Guidance Response</a:t>
             </a:r>
+          </a:p>
+          <a:p>
+            <a:pPr algn="ctr"/>
+            <a:r>
+              <a:rPr lang="en-US" sz="1600" dirty="0"/>
+              <a:t>(optional)</a:t>
+            </a:r>
             <a:endParaRPr lang="en-US" sz="1000" dirty="0"/>
           </a:p>
         </p:txBody>
@@ -10642,7 +13385,7 @@
             <a:pPr algn="ctr"/>
             <a:r>
               <a:rPr lang="en-US" sz="1600" dirty="0"/>
-              <a:t>QI Core Lab Observation</a:t>
+              <a:t>Lab Observation</a:t>
             </a:r>
           </a:p>
           <a:p>
@@ -10703,7 +13446,7 @@
             <a:pPr algn="ctr"/>
             <a:r>
               <a:rPr lang="en-US" sz="1600" dirty="0"/>
-              <a:t>QI Core Procedure</a:t>
+              <a:t>Procedure</a:t>
             </a:r>
           </a:p>
           <a:p>
@@ -11012,6 +13755,71 @@
               </a:rPr>
               <a:t>subject</a:t>
             </a:r>
+          </a:p>
+        </p:txBody>
+      </p:sp>
+      <p:sp>
+        <p:nvSpPr>
+          <p:cNvPr id="9" name="Flowchart: Process 8">
+            <a:extLst>
+              <a:ext uri="{FF2B5EF4-FFF2-40B4-BE49-F238E27FC236}">
+                <a16:creationId xmlns:a16="http://schemas.microsoft.com/office/drawing/2014/main" id="{17C5488F-99E3-AB38-A0B6-6E2F49AEA5A9}"/>
+              </a:ext>
+            </a:extLst>
+          </p:cNvPr>
+          <p:cNvSpPr/>
+          <p:nvPr/>
+        </p:nvSpPr>
+        <p:spPr>
+          <a:xfrm>
+            <a:off x="3949209" y="1818397"/>
+            <a:ext cx="1864311" cy="613637"/>
+          </a:xfrm>
+          <a:prstGeom prst="flowChartProcess">
+            <a:avLst/>
+          </a:prstGeom>
+          <a:solidFill>
+            <a:schemeClr val="accent6"/>
+          </a:solidFill>
+          <a:ln>
+            <a:solidFill>
+              <a:schemeClr val="tx1"/>
+            </a:solidFill>
+          </a:ln>
+        </p:spPr>
+        <p:style>
+          <a:lnRef idx="2">
+            <a:schemeClr val="accent1">
+              <a:shade val="50000"/>
+            </a:schemeClr>
+          </a:lnRef>
+          <a:fillRef idx="1">
+            <a:schemeClr val="accent1"/>
+          </a:fillRef>
+          <a:effectRef idx="0">
+            <a:schemeClr val="accent1"/>
+          </a:effectRef>
+          <a:fontRef idx="minor">
+            <a:schemeClr val="lt1"/>
+          </a:fontRef>
+        </p:style>
+        <p:txBody>
+          <a:bodyPr rtlCol="0" anchor="ctr"/>
+          <a:lstStyle/>
+          <a:p>
+            <a:pPr algn="ctr"/>
+            <a:r>
+              <a:rPr lang="en-US" sz="1600" dirty="0"/>
+              <a:t>GIC Composition</a:t>
+            </a:r>
+          </a:p>
+          <a:p>
+            <a:pPr algn="ctr"/>
+            <a:r>
+              <a:rPr lang="en-US" sz="1600" dirty="0"/>
+              <a:t>(optional)</a:t>
+            </a:r>
+            <a:endParaRPr lang="en-US" sz="1000" dirty="0"/>
           </a:p>
         </p:txBody>
       </p:sp>

</xml_diff>

<commit_message>
QA: Committee review feedback on gaps in care documentation
</commit_message>
<xml_diff>
--- a/input/images/source/Gaps in Care Graphics.pptx
+++ b/input/images/source/Gaps in Care Graphics.pptx
@@ -222,7 +222,7 @@
           <a:p>
             <a:fld id="{17E6B6D7-20D6-4E9A-B6E5-85297A5570A7}" type="datetimeFigureOut">
               <a:rPr lang="en-US" smtClean="0"/>
-              <a:t>8/11/2026</a:t>
+              <a:t>8/14/2026</a:t>
             </a:fld>
             <a:endParaRPr lang="en-US"/>
           </a:p>
@@ -973,7 +973,7 @@
           <a:p>
             <a:fld id="{CCEBD49B-BC6D-4065-97F6-E22D565E4F2F}" type="datetimeFigureOut">
               <a:rPr lang="en-US" smtClean="0"/>
-              <a:t>8/11/2026</a:t>
+              <a:t>8/14/2026</a:t>
             </a:fld>
             <a:endParaRPr lang="en-US"/>
           </a:p>
@@ -1171,7 +1171,7 @@
           <a:p>
             <a:fld id="{CCEBD49B-BC6D-4065-97F6-E22D565E4F2F}" type="datetimeFigureOut">
               <a:rPr lang="en-US" smtClean="0"/>
-              <a:t>8/11/2026</a:t>
+              <a:t>8/14/2026</a:t>
             </a:fld>
             <a:endParaRPr lang="en-US"/>
           </a:p>
@@ -1379,7 +1379,7 @@
           <a:p>
             <a:fld id="{CCEBD49B-BC6D-4065-97F6-E22D565E4F2F}" type="datetimeFigureOut">
               <a:rPr lang="en-US" smtClean="0"/>
-              <a:t>8/11/2026</a:t>
+              <a:t>8/14/2026</a:t>
             </a:fld>
             <a:endParaRPr lang="en-US"/>
           </a:p>
@@ -1577,7 +1577,7 @@
           <a:p>
             <a:fld id="{CCEBD49B-BC6D-4065-97F6-E22D565E4F2F}" type="datetimeFigureOut">
               <a:rPr lang="en-US" smtClean="0"/>
-              <a:t>8/11/2026</a:t>
+              <a:t>8/14/2026</a:t>
             </a:fld>
             <a:endParaRPr lang="en-US"/>
           </a:p>
@@ -1852,7 +1852,7 @@
           <a:p>
             <a:fld id="{CCEBD49B-BC6D-4065-97F6-E22D565E4F2F}" type="datetimeFigureOut">
               <a:rPr lang="en-US" smtClean="0"/>
-              <a:t>8/11/2026</a:t>
+              <a:t>8/14/2026</a:t>
             </a:fld>
             <a:endParaRPr lang="en-US"/>
           </a:p>
@@ -2117,7 +2117,7 @@
           <a:p>
             <a:fld id="{CCEBD49B-BC6D-4065-97F6-E22D565E4F2F}" type="datetimeFigureOut">
               <a:rPr lang="en-US" smtClean="0"/>
-              <a:t>8/11/2026</a:t>
+              <a:t>8/14/2026</a:t>
             </a:fld>
             <a:endParaRPr lang="en-US"/>
           </a:p>
@@ -2529,7 +2529,7 @@
           <a:p>
             <a:fld id="{CCEBD49B-BC6D-4065-97F6-E22D565E4F2F}" type="datetimeFigureOut">
               <a:rPr lang="en-US" smtClean="0"/>
-              <a:t>8/11/2026</a:t>
+              <a:t>8/14/2026</a:t>
             </a:fld>
             <a:endParaRPr lang="en-US"/>
           </a:p>
@@ -2670,7 +2670,7 @@
           <a:p>
             <a:fld id="{CCEBD49B-BC6D-4065-97F6-E22D565E4F2F}" type="datetimeFigureOut">
               <a:rPr lang="en-US" smtClean="0"/>
-              <a:t>8/11/2026</a:t>
+              <a:t>8/14/2026</a:t>
             </a:fld>
             <a:endParaRPr lang="en-US"/>
           </a:p>
@@ -2783,7 +2783,7 @@
           <a:p>
             <a:fld id="{CCEBD49B-BC6D-4065-97F6-E22D565E4F2F}" type="datetimeFigureOut">
               <a:rPr lang="en-US" smtClean="0"/>
-              <a:t>8/11/2026</a:t>
+              <a:t>8/14/2026</a:t>
             </a:fld>
             <a:endParaRPr lang="en-US"/>
           </a:p>
@@ -3094,7 +3094,7 @@
           <a:p>
             <a:fld id="{CCEBD49B-BC6D-4065-97F6-E22D565E4F2F}" type="datetimeFigureOut">
               <a:rPr lang="en-US" smtClean="0"/>
-              <a:t>8/11/2026</a:t>
+              <a:t>8/14/2026</a:t>
             </a:fld>
             <a:endParaRPr lang="en-US"/>
           </a:p>
@@ -3382,7 +3382,7 @@
           <a:p>
             <a:fld id="{CCEBD49B-BC6D-4065-97F6-E22D565E4F2F}" type="datetimeFigureOut">
               <a:rPr lang="en-US" smtClean="0"/>
-              <a:t>8/11/2026</a:t>
+              <a:t>8/14/2026</a:t>
             </a:fld>
             <a:endParaRPr lang="en-US"/>
           </a:p>
@@ -3623,7 +3623,7 @@
           <a:p>
             <a:fld id="{CCEBD49B-BC6D-4065-97F6-E22D565E4F2F}" type="datetimeFigureOut">
               <a:rPr lang="en-US" smtClean="0"/>
-              <a:t>8/11/2026</a:t>
+              <a:t>8/14/2026</a:t>
             </a:fld>
             <a:endParaRPr lang="en-US"/>
           </a:p>
@@ -10572,6 +10572,9 @@
           <a:prstGeom prst="flowChartProcess">
             <a:avLst/>
           </a:prstGeom>
+          <a:solidFill>
+            <a:schemeClr val="accent6"/>
+          </a:solidFill>
           <a:ln>
             <a:solidFill>
               <a:schemeClr val="tx1"/>
@@ -10602,6 +10605,17 @@
             <a:r>
               <a:rPr lang="en-US" sz="1600" dirty="0"/>
               <a:t>Guidance Response</a:t>
+            </a:r>
+            <a:br>
+              <a:rPr lang="en-US" sz="1600"/>
+            </a:br>
+            <a:r>
+              <a:rPr lang="en-US" sz="1600"/>
+              <a:t>(optional</a:t>
+            </a:r>
+            <a:r>
+              <a:rPr lang="en-US" sz="1600" dirty="0"/>
+              <a:t>)</a:t>
             </a:r>
             <a:endParaRPr lang="en-US" sz="1000" dirty="0"/>
           </a:p>

</xml_diff>

<commit_message>
QA: Committee feedback on gaps in care diagrams
</commit_message>
<xml_diff>
--- a/input/images/source/Gaps in Care Graphics.pptx
+++ b/input/images/source/Gaps in Care Graphics.pptx
@@ -11694,89 +11694,6 @@
       </p:cxnSp>
       <p:cxnSp>
         <p:nvCxnSpPr>
-          <p:cNvPr id="150" name="Straight Arrow Connector 149">
-            <a:extLst>
-              <a:ext uri="{FF2B5EF4-FFF2-40B4-BE49-F238E27FC236}">
-                <a16:creationId xmlns:a16="http://schemas.microsoft.com/office/drawing/2014/main" id="{B0A502EB-4FA3-419A-B0EE-C00113470861}"/>
-              </a:ext>
-            </a:extLst>
-          </p:cNvPr>
-          <p:cNvCxnSpPr>
-            <a:cxnSpLocks/>
-            <a:stCxn id="5" idx="3"/>
-          </p:cNvCxnSpPr>
-          <p:nvPr/>
-        </p:nvCxnSpPr>
-        <p:spPr>
-          <a:xfrm flipV="1">
-            <a:off x="2427447" y="2125216"/>
-            <a:ext cx="1521765" cy="1494"/>
-          </a:xfrm>
-          <a:prstGeom prst="straightConnector1">
-            <a:avLst/>
-          </a:prstGeom>
-          <a:ln>
-            <a:solidFill>
-              <a:schemeClr val="tx1"/>
-            </a:solidFill>
-            <a:prstDash val="dash"/>
-            <a:tailEnd type="triangle"/>
-          </a:ln>
-        </p:spPr>
-        <p:style>
-          <a:lnRef idx="1">
-            <a:schemeClr val="accent1"/>
-          </a:lnRef>
-          <a:fillRef idx="0">
-            <a:schemeClr val="accent1"/>
-          </a:fillRef>
-          <a:effectRef idx="0">
-            <a:schemeClr val="accent1"/>
-          </a:effectRef>
-          <a:fontRef idx="minor">
-            <a:schemeClr val="tx1"/>
-          </a:fontRef>
-        </p:style>
-      </p:cxnSp>
-      <p:sp>
-        <p:nvSpPr>
-          <p:cNvPr id="165" name="TextBox 164">
-            <a:extLst>
-              <a:ext uri="{FF2B5EF4-FFF2-40B4-BE49-F238E27FC236}">
-                <a16:creationId xmlns:a16="http://schemas.microsoft.com/office/drawing/2014/main" id="{8F126E68-CFBC-4650-89F4-8608C59D3052}"/>
-              </a:ext>
-            </a:extLst>
-          </p:cNvPr>
-          <p:cNvSpPr txBox="1"/>
-          <p:nvPr/>
-        </p:nvSpPr>
-        <p:spPr>
-          <a:xfrm>
-            <a:off x="3062513" y="2010190"/>
-            <a:ext cx="459578" cy="230832"/>
-          </a:xfrm>
-          <a:prstGeom prst="rect">
-            <a:avLst/>
-          </a:prstGeom>
-          <a:solidFill>
-            <a:schemeClr val="bg1"/>
-          </a:solidFill>
-        </p:spPr>
-        <p:txBody>
-          <a:bodyPr wrap="square" rtlCol="0">
-            <a:spAutoFit/>
-          </a:bodyPr>
-          <a:lstStyle/>
-          <a:p>
-            <a:r>
-              <a:rPr lang="en-US" sz="900" b="1" dirty="0"/>
-              <a:t>entry</a:t>
-            </a:r>
-          </a:p>
-        </p:txBody>
-      </p:sp>
-      <p:cxnSp>
-        <p:nvCxnSpPr>
           <p:cNvPr id="74" name="Straight Arrow Connector 73">
             <a:extLst>
               <a:ext uri="{FF2B5EF4-FFF2-40B4-BE49-F238E27FC236}">
@@ -12071,51 +11988,6 @@
       </p:sp>
       <p:cxnSp>
         <p:nvCxnSpPr>
-          <p:cNvPr id="110" name="Straight Arrow Connector 109">
-            <a:extLst>
-              <a:ext uri="{FF2B5EF4-FFF2-40B4-BE49-F238E27FC236}">
-                <a16:creationId xmlns:a16="http://schemas.microsoft.com/office/drawing/2014/main" id="{D132ADA7-1AEE-4182-88B6-4898C928D30B}"/>
-              </a:ext>
-            </a:extLst>
-          </p:cNvPr>
-          <p:cNvCxnSpPr>
-            <a:cxnSpLocks/>
-            <a:endCxn id="90" idx="1"/>
-          </p:cNvCxnSpPr>
-          <p:nvPr/>
-        </p:nvCxnSpPr>
-        <p:spPr>
-          <a:xfrm>
-            <a:off x="5813523" y="2125216"/>
-            <a:ext cx="1045593" cy="1350533"/>
-          </a:xfrm>
-          <a:prstGeom prst="straightConnector1">
-            <a:avLst/>
-          </a:prstGeom>
-          <a:ln w="9525">
-            <a:solidFill>
-              <a:srgbClr val="0070C0"/>
-            </a:solidFill>
-            <a:tailEnd type="triangle"/>
-          </a:ln>
-        </p:spPr>
-        <p:style>
-          <a:lnRef idx="1">
-            <a:schemeClr val="accent1"/>
-          </a:lnRef>
-          <a:fillRef idx="0">
-            <a:schemeClr val="accent1"/>
-          </a:fillRef>
-          <a:effectRef idx="0">
-            <a:schemeClr val="accent1"/>
-          </a:effectRef>
-          <a:fontRef idx="minor">
-            <a:schemeClr val="tx1"/>
-          </a:fontRef>
-        </p:style>
-      </p:cxnSp>
-      <p:cxnSp>
-        <p:nvCxnSpPr>
           <p:cNvPr id="111" name="Straight Arrow Connector 110">
             <a:extLst>
               <a:ext uri="{FF2B5EF4-FFF2-40B4-BE49-F238E27FC236}">
@@ -12430,133 +12302,6 @@
           </a:p>
         </p:txBody>
       </p:sp>
-      <p:cxnSp>
-        <p:nvCxnSpPr>
-          <p:cNvPr id="164" name="Straight Arrow Connector 163">
-            <a:extLst>
-              <a:ext uri="{FF2B5EF4-FFF2-40B4-BE49-F238E27FC236}">
-                <a16:creationId xmlns:a16="http://schemas.microsoft.com/office/drawing/2014/main" id="{90D686F3-6539-405B-BAAF-D5A603068524}"/>
-              </a:ext>
-            </a:extLst>
-          </p:cNvPr>
-          <p:cNvCxnSpPr>
-            <a:cxnSpLocks/>
-            <a:endCxn id="134" idx="1"/>
-          </p:cNvCxnSpPr>
-          <p:nvPr/>
-        </p:nvCxnSpPr>
-        <p:spPr>
-          <a:xfrm>
-            <a:off x="5813523" y="2125216"/>
-            <a:ext cx="1045593" cy="2744742"/>
-          </a:xfrm>
-          <a:prstGeom prst="straightConnector1">
-            <a:avLst/>
-          </a:prstGeom>
-          <a:ln w="9525">
-            <a:solidFill>
-              <a:srgbClr val="0070C0"/>
-            </a:solidFill>
-            <a:tailEnd type="triangle"/>
-          </a:ln>
-        </p:spPr>
-        <p:style>
-          <a:lnRef idx="1">
-            <a:schemeClr val="accent1"/>
-          </a:lnRef>
-          <a:fillRef idx="0">
-            <a:schemeClr val="accent1"/>
-          </a:fillRef>
-          <a:effectRef idx="0">
-            <a:schemeClr val="accent1"/>
-          </a:effectRef>
-          <a:fontRef idx="minor">
-            <a:schemeClr val="tx1"/>
-          </a:fontRef>
-        </p:style>
-      </p:cxnSp>
-      <p:sp>
-        <p:nvSpPr>
-          <p:cNvPr id="166" name="TextBox 165">
-            <a:extLst>
-              <a:ext uri="{FF2B5EF4-FFF2-40B4-BE49-F238E27FC236}">
-                <a16:creationId xmlns:a16="http://schemas.microsoft.com/office/drawing/2014/main" id="{4385A6E7-8368-40E5-97F6-C06276CE1254}"/>
-              </a:ext>
-            </a:extLst>
-          </p:cNvPr>
-          <p:cNvSpPr txBox="1"/>
-          <p:nvPr/>
-        </p:nvSpPr>
-        <p:spPr>
-          <a:xfrm>
-            <a:off x="6139654" y="2756779"/>
-            <a:ext cx="900006" cy="230832"/>
-          </a:xfrm>
-          <a:prstGeom prst="rect">
-            <a:avLst/>
-          </a:prstGeom>
-          <a:solidFill>
-            <a:schemeClr val="bg1"/>
-          </a:solidFill>
-        </p:spPr>
-        <p:txBody>
-          <a:bodyPr wrap="square" rtlCol="0">
-            <a:spAutoFit/>
-          </a:bodyPr>
-          <a:lstStyle/>
-          <a:p>
-            <a:r>
-              <a:rPr lang="en-US" sz="900" b="1" dirty="0">
-                <a:solidFill>
-                  <a:srgbClr val="0070C0"/>
-                </a:solidFill>
-              </a:rPr>
-              <a:t>section.entry</a:t>
-            </a:r>
-          </a:p>
-        </p:txBody>
-      </p:sp>
-      <p:sp>
-        <p:nvSpPr>
-          <p:cNvPr id="167" name="TextBox 166">
-            <a:extLst>
-              <a:ext uri="{FF2B5EF4-FFF2-40B4-BE49-F238E27FC236}">
-                <a16:creationId xmlns:a16="http://schemas.microsoft.com/office/drawing/2014/main" id="{DC2C6B30-F47E-4161-A251-7799E31B4EE0}"/>
-              </a:ext>
-            </a:extLst>
-          </p:cNvPr>
-          <p:cNvSpPr txBox="1"/>
-          <p:nvPr/>
-        </p:nvSpPr>
-        <p:spPr>
-          <a:xfrm>
-            <a:off x="6136876" y="3986625"/>
-            <a:ext cx="814938" cy="230832"/>
-          </a:xfrm>
-          <a:prstGeom prst="rect">
-            <a:avLst/>
-          </a:prstGeom>
-          <a:solidFill>
-            <a:schemeClr val="bg1"/>
-          </a:solidFill>
-        </p:spPr>
-        <p:txBody>
-          <a:bodyPr wrap="square" rtlCol="0">
-            <a:spAutoFit/>
-          </a:bodyPr>
-          <a:lstStyle/>
-          <a:p>
-            <a:r>
-              <a:rPr lang="en-US" sz="900" b="1" dirty="0">
-                <a:solidFill>
-                  <a:srgbClr val="0070C0"/>
-                </a:solidFill>
-              </a:rPr>
-              <a:t>section.focus</a:t>
-            </a:r>
-          </a:p>
-        </p:txBody>
-      </p:sp>
       <p:sp>
         <p:nvSpPr>
           <p:cNvPr id="180" name="Flowchart: Process 179">
@@ -12615,92 +12360,6 @@
           </a:p>
         </p:txBody>
       </p:sp>
-      <p:cxnSp>
-        <p:nvCxnSpPr>
-          <p:cNvPr id="181" name="Straight Arrow Connector 180">
-            <a:extLst>
-              <a:ext uri="{FF2B5EF4-FFF2-40B4-BE49-F238E27FC236}">
-                <a16:creationId xmlns:a16="http://schemas.microsoft.com/office/drawing/2014/main" id="{7CC7B4FF-EF57-467E-999A-78BDDB6C9EED}"/>
-              </a:ext>
-            </a:extLst>
-          </p:cNvPr>
-          <p:cNvCxnSpPr>
-            <a:cxnSpLocks/>
-            <a:endCxn id="180" idx="1"/>
-          </p:cNvCxnSpPr>
-          <p:nvPr/>
-        </p:nvCxnSpPr>
-        <p:spPr>
-          <a:xfrm>
-            <a:off x="5813523" y="2125216"/>
-            <a:ext cx="1045593" cy="4079"/>
-          </a:xfrm>
-          <a:prstGeom prst="straightConnector1">
-            <a:avLst/>
-          </a:prstGeom>
-          <a:ln w="9525">
-            <a:solidFill>
-              <a:srgbClr val="0070C0"/>
-            </a:solidFill>
-            <a:tailEnd type="triangle"/>
-          </a:ln>
-        </p:spPr>
-        <p:style>
-          <a:lnRef idx="1">
-            <a:schemeClr val="accent1"/>
-          </a:lnRef>
-          <a:fillRef idx="0">
-            <a:schemeClr val="accent1"/>
-          </a:fillRef>
-          <a:effectRef idx="0">
-            <a:schemeClr val="accent1"/>
-          </a:effectRef>
-          <a:fontRef idx="minor">
-            <a:schemeClr val="tx1"/>
-          </a:fontRef>
-        </p:style>
-      </p:cxnSp>
-      <p:sp>
-        <p:nvSpPr>
-          <p:cNvPr id="182" name="TextBox 181">
-            <a:extLst>
-              <a:ext uri="{FF2B5EF4-FFF2-40B4-BE49-F238E27FC236}">
-                <a16:creationId xmlns:a16="http://schemas.microsoft.com/office/drawing/2014/main" id="{8B791539-1D4C-45FA-8E4A-D6DB6040AEF7}"/>
-              </a:ext>
-            </a:extLst>
-          </p:cNvPr>
-          <p:cNvSpPr txBox="1"/>
-          <p:nvPr/>
-        </p:nvSpPr>
-        <p:spPr>
-          <a:xfrm>
-            <a:off x="6090625" y="2010190"/>
-            <a:ext cx="633829" cy="230832"/>
-          </a:xfrm>
-          <a:prstGeom prst="rect">
-            <a:avLst/>
-          </a:prstGeom>
-          <a:solidFill>
-            <a:schemeClr val="bg1"/>
-          </a:solidFill>
-        </p:spPr>
-        <p:txBody>
-          <a:bodyPr wrap="square" rtlCol="0">
-            <a:spAutoFit/>
-          </a:bodyPr>
-          <a:lstStyle/>
-          <a:p>
-            <a:r>
-              <a:rPr lang="en-US" sz="900" b="1" dirty="0">
-                <a:solidFill>
-                  <a:srgbClr val="0070C0"/>
-                </a:solidFill>
-              </a:rPr>
-              <a:t>subject</a:t>
-            </a:r>
-          </a:p>
-        </p:txBody>
-      </p:sp>
       <p:sp>
         <p:nvSpPr>
           <p:cNvPr id="183" name="Flowchart: Process 182">
@@ -13793,7 +13452,7 @@
             <a:avLst/>
           </a:prstGeom>
           <a:solidFill>
-            <a:schemeClr val="accent6"/>
+            <a:srgbClr val="C00000"/>
           </a:solidFill>
           <a:ln>
             <a:solidFill>
@@ -13831,7 +13490,7 @@
             <a:pPr algn="ctr"/>
             <a:r>
               <a:rPr lang="en-US" sz="1600" dirty="0"/>
-              <a:t>(optional)</a:t>
+              <a:t>(not present)</a:t>
             </a:r>
             <a:endParaRPr lang="en-US" sz="1000" dirty="0"/>
           </a:p>

</xml_diff>

<commit_message>
QA: Fixing errors and warnings
</commit_message>
<xml_diff>
--- a/input/images/source/Gaps in Care Graphics.pptx
+++ b/input/images/source/Gaps in Care Graphics.pptx
@@ -11988,6 +11988,52 @@
       </p:sp>
       <p:cxnSp>
         <p:nvCxnSpPr>
+          <p:cNvPr id="110" name="Straight Arrow Connector 109">
+            <a:extLst>
+              <a:ext uri="{FF2B5EF4-FFF2-40B4-BE49-F238E27FC236}">
+                <a16:creationId xmlns:a16="http://schemas.microsoft.com/office/drawing/2014/main" id="{D132ADA7-1AEE-4182-88B6-4898C928D30B}"/>
+              </a:ext>
+            </a:extLst>
+          </p:cNvPr>
+          <p:cNvCxnSpPr>
+            <a:cxnSpLocks/>
+            <a:stCxn id="7" idx="3"/>
+            <a:endCxn id="90" idx="1"/>
+          </p:cNvCxnSpPr>
+          <p:nvPr/>
+        </p:nvCxnSpPr>
+        <p:spPr>
+          <a:xfrm>
+            <a:off x="5813521" y="2988582"/>
+            <a:ext cx="1045595" cy="487167"/>
+          </a:xfrm>
+          <a:prstGeom prst="straightConnector1">
+            <a:avLst/>
+          </a:prstGeom>
+          <a:ln w="9525">
+            <a:solidFill>
+              <a:srgbClr val="0070C0"/>
+            </a:solidFill>
+            <a:tailEnd type="triangle"/>
+          </a:ln>
+        </p:spPr>
+        <p:style>
+          <a:lnRef idx="1">
+            <a:schemeClr val="accent1"/>
+          </a:lnRef>
+          <a:fillRef idx="0">
+            <a:schemeClr val="accent1"/>
+          </a:fillRef>
+          <a:effectRef idx="0">
+            <a:schemeClr val="accent1"/>
+          </a:effectRef>
+          <a:fontRef idx="minor">
+            <a:schemeClr val="tx1"/>
+          </a:fontRef>
+        </p:style>
+      </p:cxnSp>
+      <p:cxnSp>
+        <p:nvCxnSpPr>
           <p:cNvPr id="111" name="Straight Arrow Connector 110">
             <a:extLst>
               <a:ext uri="{FF2B5EF4-FFF2-40B4-BE49-F238E27FC236}">
@@ -12302,6 +12348,52 @@
           </a:p>
         </p:txBody>
       </p:sp>
+      <p:cxnSp>
+        <p:nvCxnSpPr>
+          <p:cNvPr id="164" name="Straight Arrow Connector 163">
+            <a:extLst>
+              <a:ext uri="{FF2B5EF4-FFF2-40B4-BE49-F238E27FC236}">
+                <a16:creationId xmlns:a16="http://schemas.microsoft.com/office/drawing/2014/main" id="{90D686F3-6539-405B-BAAF-D5A603068524}"/>
+              </a:ext>
+            </a:extLst>
+          </p:cNvPr>
+          <p:cNvCxnSpPr>
+            <a:cxnSpLocks/>
+            <a:stCxn id="109" idx="3"/>
+            <a:endCxn id="134" idx="1"/>
+          </p:cNvCxnSpPr>
+          <p:nvPr/>
+        </p:nvCxnSpPr>
+        <p:spPr>
+          <a:xfrm>
+            <a:off x="5828503" y="4637489"/>
+            <a:ext cx="1030613" cy="232469"/>
+          </a:xfrm>
+          <a:prstGeom prst="straightConnector1">
+            <a:avLst/>
+          </a:prstGeom>
+          <a:ln w="9525">
+            <a:solidFill>
+              <a:srgbClr val="0070C0"/>
+            </a:solidFill>
+            <a:tailEnd type="triangle"/>
+          </a:ln>
+        </p:spPr>
+        <p:style>
+          <a:lnRef idx="1">
+            <a:schemeClr val="accent1"/>
+          </a:lnRef>
+          <a:fillRef idx="0">
+            <a:schemeClr val="accent1"/>
+          </a:fillRef>
+          <a:effectRef idx="0">
+            <a:schemeClr val="accent1"/>
+          </a:effectRef>
+          <a:fontRef idx="minor">
+            <a:schemeClr val="tx1"/>
+          </a:fontRef>
+        </p:style>
+      </p:cxnSp>
       <p:sp>
         <p:nvSpPr>
           <p:cNvPr id="180" name="Flowchart: Process 179">
@@ -12356,6 +12448,92 @@
             <a:r>
               <a:rPr lang="en-US" sz="1600" dirty="0"/>
               <a:t>Patient</a:t>
+            </a:r>
+          </a:p>
+        </p:txBody>
+      </p:sp>
+      <p:cxnSp>
+        <p:nvCxnSpPr>
+          <p:cNvPr id="181" name="Straight Arrow Connector 180">
+            <a:extLst>
+              <a:ext uri="{FF2B5EF4-FFF2-40B4-BE49-F238E27FC236}">
+                <a16:creationId xmlns:a16="http://schemas.microsoft.com/office/drawing/2014/main" id="{7CC7B4FF-EF57-467E-999A-78BDDB6C9EED}"/>
+              </a:ext>
+            </a:extLst>
+          </p:cNvPr>
+          <p:cNvCxnSpPr>
+            <a:cxnSpLocks/>
+            <a:endCxn id="180" idx="1"/>
+          </p:cNvCxnSpPr>
+          <p:nvPr/>
+        </p:nvCxnSpPr>
+        <p:spPr>
+          <a:xfrm flipV="1">
+            <a:off x="5820034" y="2129295"/>
+            <a:ext cx="1039082" cy="890084"/>
+          </a:xfrm>
+          <a:prstGeom prst="straightConnector1">
+            <a:avLst/>
+          </a:prstGeom>
+          <a:ln w="9525">
+            <a:solidFill>
+              <a:srgbClr val="0070C0"/>
+            </a:solidFill>
+            <a:tailEnd type="triangle"/>
+          </a:ln>
+        </p:spPr>
+        <p:style>
+          <a:lnRef idx="1">
+            <a:schemeClr val="accent1"/>
+          </a:lnRef>
+          <a:fillRef idx="0">
+            <a:schemeClr val="accent1"/>
+          </a:fillRef>
+          <a:effectRef idx="0">
+            <a:schemeClr val="accent1"/>
+          </a:effectRef>
+          <a:fontRef idx="minor">
+            <a:schemeClr val="tx1"/>
+          </a:fontRef>
+        </p:style>
+      </p:cxnSp>
+      <p:sp>
+        <p:nvSpPr>
+          <p:cNvPr id="182" name="TextBox 181">
+            <a:extLst>
+              <a:ext uri="{FF2B5EF4-FFF2-40B4-BE49-F238E27FC236}">
+                <a16:creationId xmlns:a16="http://schemas.microsoft.com/office/drawing/2014/main" id="{8B791539-1D4C-45FA-8E4A-D6DB6040AEF7}"/>
+              </a:ext>
+            </a:extLst>
+          </p:cNvPr>
+          <p:cNvSpPr txBox="1"/>
+          <p:nvPr/>
+        </p:nvSpPr>
+        <p:spPr>
+          <a:xfrm>
+            <a:off x="6079248" y="2515453"/>
+            <a:ext cx="633829" cy="230832"/>
+          </a:xfrm>
+          <a:prstGeom prst="rect">
+            <a:avLst/>
+          </a:prstGeom>
+          <a:solidFill>
+            <a:schemeClr val="bg1"/>
+          </a:solidFill>
+        </p:spPr>
+        <p:txBody>
+          <a:bodyPr wrap="square" rtlCol="0">
+            <a:spAutoFit/>
+          </a:bodyPr>
+          <a:lstStyle/>
+          <a:p>
+            <a:r>
+              <a:rPr lang="en-US" sz="900" b="1" dirty="0">
+                <a:solidFill>
+                  <a:srgbClr val="0070C0"/>
+                </a:solidFill>
+              </a:rPr>
+              <a:t>subject</a:t>
             </a:r>
           </a:p>
         </p:txBody>

</xml_diff>